<commit_message>
Presentation: data-driven builder emits pptx + PDF; add .gitattributes
- Refactor build_presentation_dec.py to a single SLIDES source of truth; emit BOTH
  haptic_brain_talk.pptx (editable, with speaker notes) and haptic_brain_talk.pdf
  (matplotlib bakes images into each page -> renders everywhere, fixes 'images not
  loading' in Quick Look/GitHub/Drive-preview).
- .gitattributes marks pptx/pdf/png/etc binary so EOL normalization can't corrupt
  embedded images across machines.
- Verified: the existing pptx was already valid (images embedded, relationships
  resolve, git-intact) -- 'not loading' was a viewer artifact.

Co-Authored-By: Claude Opus 4.8 (1M context) <noreply@anthropic.com>
</commit_message>
<xml_diff>
--- a/presentation/haptic_brain_talk.pptx
+++ b/presentation/haptic_brain_talk.pptx
@@ -597,7 +597,7 @@
           <a:lstStyle/>
           <a:p>
             <a:r>
-              <a:t>Here's the test. If the brain hummed at the buzz speed, we'd see a sharp 'spike' of energy at that exact frequency, sticking up above the brain's normal background. We don't — at any speed. The line just follows the usual background. So in the hippocampus, no frequency-following: it notices the buzz but doesn't oscillate in step with it. And importantly, this replicated across two recording sessions. So far the swing isn't catching the push.</a:t>
+              <a:t>If the brain hummed at the buzz speed, we'd see a sharp spike of energy at that exact frequency, above the brain's normal background. We don't — at any speed. So in the hippocampus, no frequency-following: it notices the buzz but doesn't oscillate in step. And this replicated across two sessions. The swing isn't catching the push.</a:t>
             </a:r>
           </a:p>
         </p:txBody>
@@ -667,7 +667,7 @@
           <a:lstStyle/>
           <a:p>
             <a:r>
-              <a:t>Now it gets interesting. In the second region — the entorhinal inbox — a signal at exactly 50 per second DOES show up in the crowd murmur, and it gets bigger as we buzz harder. At this point in the project we were excited: maybe THIS region entrains at 50! But here's where you have to be a careful scientist, because there's a trap. Let me teach you the trap.</a:t>
+              <a:t>Now it gets interesting. In the entorhinal inbox, a signal at exactly 50 per second DOES show up in the crowd murmur, and it grows as we buzz harder. We were excited — maybe THIS region entrains at 50! But there's a trap, and a careful scientist has to check it. Let me teach you the trap.</a:t>
             </a:r>
           </a:p>
         </p:txBody>
@@ -737,7 +737,7 @@
           <a:lstStyle/>
           <a:p>
             <a:r>
-              <a:t>Analogy: you're recording the crowd, but the stadium's PA speaker is humming at 50 Hz, and your microphone picks up THAT hum too. Now your recording shows a clean 50 Hz — but it's the speaker, not the crowd. Same risk here: the buzzing motor and its electronics can leak a 50-per-second electrical signal straight into our recording wires. That would look exactly like a '50 Hz brain signal' but be pure equipment artifact. So how do you tell the brain from the machine? We found a clean test.</a:t>
+              <a:t>Analogy: you're recording the crowd, but the stadium PA speaker hums at 50 Hz and your mic picks up THAT. Now your recording shows a clean 50 Hz — but it's the speaker, not the crowd. Same risk: the buzzing motor and its electronics can leak a 50-per-second electrical signal into our wires. That would look like a '50 Hz brain signal' but be pure equipment artifact. How do you tell brain from machine? We found a clean test.</a:t>
             </a:r>
           </a:p>
         </p:txBody>
@@ -807,7 +807,7 @@
           <a:lstStyle/>
           <a:p>
             <a:r>
-              <a:t>Here's the trick. Some of our electrodes were broken/disconnected — they physically can't hear any neurons. They're dead microphones. If a dead microphone still records a loud 50 Hz, that 50 Hz CANNOT be the brain — it can only be the machine's hum leaking in. And that's exactly what we saw: the dead electrodes picked up about SIX TIMES MORE 50 Hz than the live, in-brain ones (left panel: the clean region is flat; right: it piles up on the broken channels in red). Verdict: the entorhinal '50 Hz brain wave' is largely equipment pickup. The crowd-murmur signal fooled us. Good thing we checked — and good thing we have a more trustworthy signal.</a:t>
+              <a:t>The trick: some electrodes were broken/disconnected — they physically can't hear neurons. Dead microphones. If a dead mic still records a loud 50 Hz, that CANNOT be the brain — only the machine's hum leaking in. And that's what we saw: the dead electrodes picked up about SIX TIMES MORE 50 Hz than the live, in-brain ones (right panel, red). Verdict: the entorhinal '50 Hz brain wave' is largely equipment pickup. The crowd murmur fooled us — good thing we checked.</a:t>
             </a:r>
           </a:p>
         </p:txBody>
@@ -877,7 +877,7 @@
           <a:lstStyle/>
           <a:p>
             <a:r>
-              <a:t>Now the hero arrives: the individual voices. When we track single, identified neurons, they genuinely change how much they fire during the strong 50-per-second buzz — and this happens in BOTH regions. Why is this trustworthy when the crowd-murmur wasn't? Because the machine's electrical hum can make a recording wiggle, but it can't make a real, identified neuron decide to fire. This is the clean, honest result: 50 Hz, strong buzz, is the condition where the brain's actual cells respond — far more than at the slower speeds. So question 2 — does speed matter? — yes: 50 is special.</a:t>
+              <a:t>Now the hero arrives: the individual voices. Tracking single, identified neurons, they genuinely change how much they fire during the strong 50-per-second buzz — in BOTH regions. Why trustworthy when the crowd murmur wasn't? The machine's hum can make a recording wiggle, but it can't make a real, identified neuron decide to fire. This is the clean result: 50 Hz, strong buzz, is where the brain's actual cells respond — far more than at slower speeds. So question 2 — does speed matter? — yes: 50 is special.</a:t>
             </a:r>
           </a:p>
         </p:txBody>
@@ -947,7 +947,7 @@
           <a:lstStyle/>
           <a:p>
             <a:r>
-              <a:t>Two safeguards, both intuitive. First: to find spikes we throw away the slow, low part of the signal and keep only the fast, sharp blips — like turning up the treble to hear finger-snaps over a rumble. The 50 Hz hum is a slow rumble, so it gets thrown away before we ever count a spike. Second safeguard: if the hum WERE sneaking in as fake spikes, the neuron would look like a metronome — ticking exactly every 1/50th of a second. We checked (this figure): the neuron's firing shows NO such 50 Hz ticking, and it looks the same during buzz and rest. So these are real neurons responding, not the machine. (This was the unit we scrutinized hardest; it passed.)</a:t>
+              <a:t>Two safeguards. First: to find spikes we throw away the slow part and keep only the fast, sharp blips — like turning up the treble to hear finger-snaps over a rumble. The 50 Hz hum is a slow rumble, so it's gone before we ever count a spike. Second: if the hum WERE sneaking in as fake spikes, the neuron would look like a metronome — ticking exactly every 1/50th of a second. We checked: NO such 50 Hz ticking, and it looks the same during buzz and rest. So these are real neurons. (This was the unit we scrutinized hardest; it passed.)</a:t>
             </a:r>
           </a:p>
         </p:txBody>
@@ -1017,7 +1017,7 @@
           <a:lstStyle/>
           <a:p>
             <a:r>
-              <a:t>And here's the satisfying part. The two regions react to the SAME buzz in OPPOSITE directions: in the hippocampus a subset of cells revs up; in the entorhinal region cells mostly quiet down. Analogy: two people hearing the same news — one gets excited, one goes quiet. That difference tells you they're actively PROCESSING the input, each in their own way — not just passively echoing the buzz. (Bonus: the quieting-down is itself strong evidence it's real, because equipment pickup can only ADD fake blips, it can't make a neuron go silent.)</a:t>
+              <a:t>The satisfying part: the two regions react to the SAME buzz in OPPOSITE directions — hippocampus revs a subset up, entorhinal mostly quiets down. Analogy: two people hearing the same news, one excited, one goes quiet. That difference means they're actively PROCESSING the input, not passively echoing it. (Bonus: the quieting-down is itself strong evidence it's real — equipment pickup can only ADD fake blips, it can't make a neuron go silent.)</a:t>
             </a:r>
           </a:p>
         </p:txBody>
@@ -1087,7 +1087,7 @@
           <a:lstStyle/>
           <a:p>
             <a:r>
-              <a:t>Last finding. Both regions respond — do they coordinate, like partners in a conversation? The crowd-murmur made them look in sync. But analogy: two orchestras in separate rooms can SEEM synchronized simply because both hear the same metronome ticking in the hallway — not because they're listening to each other. The trustworthy test is whether the actual MUSICIANS (the neurons) time themselves to the other room — and they don't, not more during the buzz. So the apparent 'sync' is the shared hum (that 50 Hz pickup again), not genuine teamwork. Honest answer: no clear coordination.</a:t>
+              <a:t>Do they coordinate, like partners in a conversation? The crowd murmur made them look in sync. But analogy: two orchestras in separate rooms can SEEM synchronized just because both hear the same metronome in the hallway — not because they listen to each other. The trustworthy test is whether the actual MUSICIANS (neurons) time to the other room — they don't, not more during the buzz. So the apparent 'sync' is the shared hum (that 50 Hz pickup again), not teamwork. Honest answer: no clear coordination.</a:t>
             </a:r>
           </a:p>
         </p:txBody>
@@ -1157,7 +1157,7 @@
           <a:lstStyle/>
           <a:p>
             <a:r>
-              <a:t>Back to the holy-grail question — does the brain entrain, march in step? We genuinely could not test it, and the reason is important and honest. Analogy: to judge whether a dancer is on the beat, you need to have recorded the MUSIC. We recorded the dancer (the brain) beautifully — but we never properly recorded the music (the exact timing of the buzz). Without the beat, you can't score the dancing. So 'we didn't show entrainment' is NOT 'the brain failed to entrain' — it's 'we were missing the measurement.'</a:t>
+              <a:t>Back to the holy-grail question — does the brain entrain? We genuinely could not test it, for an honest reason. Analogy: to judge whether a dancer is on the beat, you need to have recorded the MUSIC. We recorded the dancer (the brain) beautifully — but never properly recorded the music (the exact timing of the buzz). No beat, no scoring. So 'we didn't show entrainment' is NOT 'the brain failed to entrain' — it's 'we were missing the measurement.'</a:t>
             </a:r>
           </a:p>
         </p:txBody>
@@ -1227,7 +1227,7 @@
           <a:lstStyle/>
           <a:p>
             <a:r>
-              <a:t>I went back and proved this from the data. The signal that was supposed to mark each buzz cycle actually updated only about 4 times a second — but the tactor was buzzing 26 times a second. Analogy: trying to track a hummingbird's wingbeats by glancing 4 times a second — between your glances the wings have flapped 6 times; you simply can't recover the motion. (Top: the actual recorded line, irregular and slow. Middle: what a real 26-per-second buzz looks like. Bottom: the recorded gaps are ~6× too long.) So the 'music track' was effectively blank. That single missing signal is the main limitation of the whole study.</a:t>
+              <a:t>I proved this from the data. The signal that should have marked each buzz cycle updated only ~4 times a second — but the tactor buzzed 26 times a second. Analogy: tracking a hummingbird's wingbeats by glancing 4 times a second — between glances the wings flapped 6 times; you can't recover the motion. (Top: the actual recorded line, slow and irregular. Middle: what a real 26-per-second buzz looks like. Bottom: the gaps are ~6× too long.) So the 'music track' was effectively blank. That one missing signal is the main limitation of the study.</a:t>
             </a:r>
           </a:p>
         </p:txBody>
@@ -1297,7 +1297,7 @@
           <a:lstStyle/>
           <a:p>
             <a:r>
-              <a:t>Big picture first. There's huge interest in wearables that touch your skin to shift a brain state — to help you sleep, focus, calm down, or aid therapy after injury. The skin is the easiest, safest door to the nervous system. But before any of that, we need the unglamorous groundwork: if I buzz the body, (1) does the brain even notice, (2) does it matter how FAST I buzz, and (3) can the brain lock onto the rhythm of the buzz? That third one — 'marching in step' with the stimulus — is the holy grail, because that's how you'd drive a brain rhythm on purpose. That's what this project chips away at.</a:t>
+              <a:t>Big picture first. There's huge interest in wearables that touch your skin to shift a brain state — to help you sleep, focus, calm down, or aid therapy after injury. The skin is the easiest, safest door to the nervous system. But before any of that, we need the unglamorous groundwork: if I buzz the body, (1) does the brain even notice, (2) does it matter how FAST I buzz, and (3) can the brain lock onto the rhythm of the buzz? That third one — 'marching in step' with the stimulus — is the holy grail, because that's how you'd drive a brain rhythm on purpose.</a:t>
             </a:r>
           </a:p>
         </p:txBody>
@@ -1367,7 +1367,7 @@
           <a:lstStyle/>
           <a:p>
             <a:r>
-              <a:t>The good news: this is a wiring problem, not a dead end, and we've already designed the fix. Next round we record the music three ways at once, all on the same clock as the brain: (1) a clean marker the buzzer's own software emits once per cycle; (2) a tiny force sensor squeezed between the tactor and the skin that measures the ACTUAL vibration delivered — proving the buzz really happened and giving us its exact beat; and (3) a copy of the drive signal as a backup. And we'll do a 2-minute test recording to CONFIRM it works before collecting real data — the check that would have caught this last time. Then entrainment becomes directly testable.</a:t>
+              <a:t>The good news: a wiring problem, not a dead end, and we've designed the fix. Next round we record the music three ways at once, all on the brain's clock: (1) a clean marker the buzzer's software emits once per cycle; (2) a tiny force sensor between tactor and skin measuring the ACTUAL vibration — proving the buzz happened and giving its exact beat; (3) a copy of the drive signal as backup. Plus a 2-minute test recording to CONFIRM it works before real data — the check that would have caught this. Then entrainment is directly testable.</a:t>
             </a:r>
           </a:p>
         </p:txBody>
@@ -1437,7 +1437,7 @@
           <a:lstStyle/>
           <a:p>
             <a:r>
-              <a:t>Let me land the plane with three plain-language takeaways. ONE: a buzz on the body really does change the brain — that's not trivial, and it's real. TWO: the most trustworthy effect is at the level of individual neurons, specifically at the fast 50-per-second buzz, and the two regions handle it differently — active processing, not a passive echo. THREE: the flashy 'brain wave at 50 Hz' turned out to be mostly the machine's hum, and whether the brain truly 'marches in step' (entrains) we couldn't test yet — because the stimulus timing wasn't recorded. We know exactly how to fix that.</a:t>
+              <a:t>Three plain-language takeaways. ONE: a buzz on the body really does change the brain — real, not trivial. TWO: the most trustworthy effect is at the level of individual neurons, specifically at the fast 50-per-second buzz, and the two regions handle it differently — active processing, not a passive echo. THREE: the flashy 'brain wave at 50 Hz' was mostly the machine's hum, and whether the brain truly 'marches in step' we couldn't test yet — because the stimulus timing wasn't recorded. We know exactly how to fix that.</a:t>
             </a:r>
           </a:p>
         </p:txBody>
@@ -1507,7 +1507,7 @@
           <a:lstStyle/>
           <a:p>
             <a:r>
-              <a:t>Why should a non-neuroscientist care? Because if the next round shows the brain CAN be entrained through the skin, that's a foundation for safe, non-invasive wearables that nudge brain states — for sleep, focus, calm, or rehabilitation — without surgery or drugs. This study did the honest groundwork: it found a real neural effect, it caught itself when a result was actually equipment noise, and it pinpointed the one measurement we must add to ask the biggest question properly. That's how careful science gets built.</a:t>
+              <a:t>Why should a non-neuroscientist care? If the next round shows the brain CAN be entrained through the skin, that's a foundation for safe, non-invasive wearables that nudge brain states — for sleep, focus, calm, rehabilitation — without surgery or drugs. This study did the honest groundwork: found a real neural effect, caught itself when a result was actually equipment noise, and pinpointed the one measurement we must add to ask the biggest question properly.</a:t>
             </a:r>
           </a:p>
         </p:txBody>
@@ -1577,7 +1577,7 @@
           <a:lstStyle/>
           <a:p>
             <a:r>
-              <a:t>Likely questions: 'Is 50 Hz special or just strongest?' (strongest clean single-unit effect of the speeds we tested). 'Could it be arousal — they just felt a strong buzz?' (possible; but it's frequency-specific, 50 beats 26 at the same strength, which argues against pure arousal). 'Why not just trust the 50 Hz brain wave?' (dead electrodes picked it up → it's largely machine pickup).</a:t>
+              <a:t>Likely questions: 'Is 50 Hz special or just strongest?' (strongest clean single-unit effect of the speeds tested). 'Could it be arousal — they just felt a strong buzz?' (possible; but it's frequency-specific — 50 beats 26 at the same strength — which argues against pure arousal). 'Why not trust the 50 Hz brain wave?' (dead electrodes picked it up → largely machine pickup).</a:t>
             </a:r>
           </a:p>
         </p:txBody>
@@ -1647,7 +1647,7 @@
           <a:lstStyle/>
           <a:p>
             <a:r>
-              <a:t>Here's the whole setup in plain terms. We put a little vibrating motor — a 'tactor', like the buzz in your phone — on the body. We buzz it for 3 seconds, then rest 3 seconds, over and over. We try different buzz SPEEDS: 5, 10, 26, and 50 buzzes per second. And different strengths. While that happens, we listen to the brain with fine electrodes. Then we ask: what changed in the brain during the buzz versus the rest?</a:t>
+              <a:t>Here's the whole setup in plain terms. We put a little vibrating motor — a 'tactor', like the buzz in your phone — on the body. We buzz it for 3 seconds, then rest 3 seconds, over and over. We try different buzz SPEEDS: 5, 10, 26, and 50 buzzes per second. And different strengths. While that happens, we listen to the brain with fine electrodes. Then we ask: what changed in the brain during the buzz versus the rest? [Tip: drop a setup photo here.]</a:t>
             </a:r>
           </a:p>
         </p:txBody>
@@ -1857,7 +1857,7 @@
           <a:lstStyle/>
           <a:p>
             <a:r>
-              <a:t>This is the single most important idea in the talk, so here's the analogy I want you to remember. Imagine a microphone hung over a packed stadium. You hear TWO things. First, the low ROAR of the whole crowd — rising and falling together. In the brain that's the 'field potential' (the LFP): the blended, slow electrical hum of thousands of cells. Second, if you listen closely, individual people SHOUTING — sharp, brief, distinct. In the brain those are 'spikes': single neurons firing, each a crisp ~1-millisecond blip. The crowd murmur is easy to hear but vague; the individual voices are harder to pick out but tell you exactly who said what. We'll use BOTH — and the difference between them is the whole plot.</a:t>
+              <a:t>This is the single most important idea in the talk. Imagine a microphone over a packed stadium. You hear TWO things. First, the low ROAR of the whole crowd — that's the 'field potential' (LFP): the blended, slow electrical hum of thousands of cells. Second, individual people SHOUTING — sharp, brief, distinct. Those are 'spikes': single neurons firing, each a crisp ~1-millisecond blip. The crowd murmur is easy to hear but vague; the individual voices are harder to pick out but tell you exactly who said what. We use BOTH — and the difference between them is the whole plot.</a:t>
             </a:r>
           </a:p>
         </p:txBody>
@@ -1927,7 +1927,7 @@
           <a:lstStyle/>
           <a:p>
             <a:r>
-              <a:t>Why care about the hard-to-hear individual voices? Because they're trustworthy. The crowd murmur can be contaminated by all sorts of background noise — a passing truck, a buzzing speaker. But an individual, identified shout is a real event from a real person. Same in the brain: a sorted single-neuron spike is a genuine cell doing its thing, and — as we'll see — it's much harder for the equipment's own electrical noise to fake one. Hold that thought; it becomes the hero of the story.</a:t>
+              <a:t>Why care about the hard-to-hear individual voices? Because they're trustworthy. The crowd murmur can be contaminated by background noise — a passing truck, a buzzing speaker. But an identified shout is a real event from a real person. Same in the brain: a sorted single-neuron spike is a genuine cell, and it's much harder for the equipment's electrical noise to fake one. Hold that thought; it becomes the hero of the story.</a:t>
             </a:r>
           </a:p>
         </p:txBody>
@@ -1997,7 +1997,7 @@
           <a:lstStyle/>
           <a:p>
             <a:r>
-              <a:t>First result. The crowd-murmur signal clearly changes when we buzz — so yes, the brain notices. But HOW it responds matters. It mostly reacts to the buzz turning ON and OFF — the transitions — not by settling into the buzz's rhythm. Analogy: a doorbell. Your attention spikes when it RINGS and when it STOPS, but you don't start vibrating at the doorbell's pitch. So far: the brain registers the event, but isn't obviously 'tuning in.' Which raises question 3...</a:t>
+              <a:t>First result. The crowd-murmur signal clearly changes when we buzz — so yes, the brain notices. But HOW: it mostly reacts to the buzz turning ON and OFF, not by settling into its rhythm. Analogy: a doorbell. Your attention spikes when it RINGS and when it STOPS, but you don't start vibrating at the doorbell's pitch. So the brain registers the event, but isn't obviously 'tuning in.'</a:t>
             </a:r>
           </a:p>
         </p:txBody>
@@ -2067,7 +2067,7 @@
           <a:lstStyle/>
           <a:p>
             <a:r>
-              <a:t>The dream is 'entrainment': the brain's own electrical waves locking onto the rhythm of the buzz. Analogy: pushing a child's swing. If you push exactly in time with the swing, it goes higher and higher — your rhythm drives its rhythm. If the brain entrained to a 50-per-second buzz, we'd see brain activity ticking along at 50 per second. That would be powerful — it'd mean you can DIAL IN a brain rhythm from the skin. So: does the brain hum along at the buzz frequency? Let's look.</a:t>
+              <a:t>The dream is 'entrainment': the brain's own waves locking onto the buzz's rhythm. Analogy: pushing a swing. If you push exactly in time, it goes higher and higher — your rhythm drives its rhythm. If the brain entrained to a 50-per-second buzz, we'd see brain activity ticking at 50 per second. That would mean you can DIAL IN a brain rhythm from the skin. So: does the brain hum along at the buzz frequency?</a:t>
             </a:r>
           </a:p>
         </p:txBody>
@@ -5176,14 +5176,14 @@
           <a:noFill/>
         </p:spPr>
         <p:txBody>
-          <a:bodyPr wrap="square" anchor="t">
+          <a:bodyPr wrap="square" anchor="ctr">
             <a:spAutoFit/>
           </a:bodyPr>
           <a:lstStyle/>
           <a:p>
             <a:pPr algn="l"/>
             <a:r>
-              <a:rPr sz="3800" b="1">
+              <a:rPr sz="3600" b="1">
                 <a:solidFill>
                   <a:srgbClr val="FFFFFF"/>
                 </a:solidFill>
@@ -5218,7 +5218,7 @@
           <a:p>
             <a:pPr algn="l"/>
             <a:r>
-              <a:rPr sz="2000" b="0">
+              <a:rPr sz="1900" b="0">
                 <a:solidFill>
                   <a:srgbClr val="BFD0DA"/>
                 </a:solidFill>
@@ -6167,7 +6167,7 @@
                 </a:solidFill>
                 <a:latin typeface="Calibri"/>
               </a:rPr>
-              <a:t>In the entorhinal region, a 50 Hz signal appears in the crowd murmur — and it grows with buzz strength. Exciting!</a:t>
+              <a:t>In the entorhinal region a 50 Hz signal appears in the crowd murmur — and it grows with buzz strength. Exciting!</a:t>
             </a:r>
           </a:p>
         </p:txBody>
@@ -7075,7 +7075,7 @@
                 </a:solidFill>
                 <a:latin typeface="Calibri"/>
               </a:rPr>
-              <a:t>(1) Strip out the slow hum to find the sharp spikes.  (2) Check the neuron isn't 'ticking like a clock' at 50 Hz.</a:t>
+              <a:t>(1) Strip out the slow hum to find the sharp spikes.   (2) Check the neuron isn't 'ticking like a clock' at 50 Hz.</a:t>
             </a:r>
           </a:p>
         </p:txBody>
@@ -7541,7 +7541,7 @@
                 </a:solidFill>
                 <a:latin typeface="Calibri"/>
               </a:rPr>
-              <a:t>Two orchestras can SOUND synced because of a hallway metronome (shared hum) — not because they're playing together.</a:t>
+              <a:t>Two orchestras can SOUND synced because of a hallway metronome (a shared hum) — not because they play together.</a:t>
             </a:r>
           </a:p>
         </p:txBody>
@@ -7805,7 +7805,7 @@
           <a:p>
             <a:pPr algn="l"/>
             <a:r>
-              <a:rPr sz="4000" b="1">
+              <a:rPr sz="3800" b="1">
                 <a:solidFill>
                   <a:srgbClr val="FFFFFF"/>
                 </a:solidFill>
@@ -8913,14 +8913,57 @@
       </p:sp>
       <p:sp>
         <p:nvSpPr>
-          <p:cNvPr id="3" name="TextBox 2"/>
+          <p:cNvPr id="3" name="Rectangle 2"/>
+          <p:cNvSpPr/>
+          <p:nvPr/>
+        </p:nvSpPr>
+        <p:spPr>
+          <a:xfrm>
+            <a:off x="0" y="4572000"/>
+            <a:ext cx="12191695" cy="73152"/>
+          </a:xfrm>
+          <a:prstGeom prst="rect">
+            <a:avLst/>
+          </a:prstGeom>
+          <a:solidFill>
+            <a:srgbClr val="1C6E8C"/>
+          </a:solidFill>
+          <a:ln>
+            <a:noFill/>
+          </a:ln>
+        </p:spPr>
+        <p:style>
+          <a:lnRef idx="1">
+            <a:schemeClr val="accent1"/>
+          </a:lnRef>
+          <a:fillRef idx="3">
+            <a:schemeClr val="accent1"/>
+          </a:fillRef>
+          <a:effectRef idx="2">
+            <a:schemeClr val="accent1"/>
+          </a:effectRef>
+          <a:fontRef idx="minor">
+            <a:schemeClr val="lt1"/>
+          </a:fontRef>
+        </p:style>
+        <p:txBody>
+          <a:bodyPr rtlCol="0" anchor="ctr"/>
+          <a:lstStyle/>
+          <a:p>
+            <a:pPr algn="ctr"/>
+          </a:p>
+        </p:txBody>
+      </p:sp>
+      <p:sp>
+        <p:nvSpPr>
+          <p:cNvPr id="4" name="TextBox 3"/>
           <p:cNvSpPr txBox="1"/>
           <p:nvPr/>
         </p:nvSpPr>
         <p:spPr>
           <a:xfrm>
             <a:off x="914400" y="2743200"/>
-            <a:ext cx="10362895" cy="1097280"/>
+            <a:ext cx="10362895" cy="1463040"/>
           </a:xfrm>
           <a:prstGeom prst="rect">
             <a:avLst/>
@@ -8935,7 +8978,7 @@
           <a:p>
             <a:pPr algn="l"/>
             <a:r>
-              <a:rPr sz="4000" b="1">
+              <a:rPr sz="3600" b="1">
                 <a:solidFill>
                   <a:srgbClr val="FFFFFF"/>
                 </a:solidFill>
@@ -8948,14 +8991,14 @@
       </p:sp>
       <p:sp>
         <p:nvSpPr>
-          <p:cNvPr id="4" name="TextBox 3"/>
+          <p:cNvPr id="5" name="TextBox 4"/>
           <p:cNvSpPr txBox="1"/>
           <p:nvPr/>
         </p:nvSpPr>
         <p:spPr>
           <a:xfrm>
             <a:off x="914400" y="3840480"/>
-            <a:ext cx="10362895" cy="731520"/>
+            <a:ext cx="10362895" cy="914400"/>
           </a:xfrm>
           <a:prstGeom prst="rect">
             <a:avLst/>
@@ -8970,7 +9013,7 @@
           <a:p>
             <a:pPr algn="l"/>
             <a:r>
-              <a:rPr sz="1800" b="0">
+              <a:rPr sz="1900" b="0">
                 <a:solidFill>
                   <a:srgbClr val="BFD0DA"/>
                 </a:solidFill>
@@ -9324,7 +9367,7 @@
                 </a:solidFill>
                 <a:latin typeface="Calibri"/>
               </a:rPr>
-              <a:t>(1) Does the brain notice?   (2) Does the buzz SPEED matter?   (3) Does the brain march in step with the buzz?</a:t>
+              <a:t>(1) Does the brain notice?    (2) Does the buzz SPEED matter?    (3) Does the brain march in step with the buzz?</a:t>
             </a:r>
           </a:p>
         </p:txBody>
@@ -9414,7 +9457,7 @@
           <a:p>
             <a:pPr algn="l"/>
             <a:r>
-              <a:rPr sz="4000" b="1">
+              <a:rPr sz="3800" b="1">
                 <a:solidFill>
                   <a:srgbClr val="FFFFFF"/>
                 </a:solidFill>
@@ -9629,7 +9672,7 @@
                 </a:solidFill>
                 <a:latin typeface="Calibri"/>
               </a:rPr>
-              <a:t>Hippocampus = the brain's inner GPS &amp; memory.  Entorhinal cortex = its main input hub. Two listening posts.</a:t>
+              <a:t>Hippocampus = the brain's inner GPS &amp; memory.   Entorhinal cortex = its main input hub. Two listening posts.</a:t>
             </a:r>
           </a:p>
         </p:txBody>
@@ -10047,7 +10090,7 @@
                 </a:solidFill>
                 <a:latin typeface="Calibri"/>
               </a:rPr>
-              <a:t>A real neuron firing is unambiguous — it's much harder for noise or equipment to fake than the crowd hum.</a:t>
+              <a:t>A real neuron firing is unambiguous — much harder for noise or equipment to fake than the crowd hum.</a:t>
             </a:r>
           </a:p>
         </p:txBody>
@@ -10137,7 +10180,7 @@
           <a:p>
             <a:pPr algn="l"/>
             <a:r>
-              <a:rPr sz="4000" b="1">
+              <a:rPr sz="3800" b="1">
                 <a:solidFill>
                   <a:srgbClr val="FFFFFF"/>
                 </a:solidFill>

</xml_diff>

<commit_message>
Presentation: add 6 schematic concept illustrations for the teaching slides
build_concept_figures.py generates clean navy/teal schematics, wired onto the
previously figure-free concept slides:
  3  experiment   (tactor->brain + ON/OFF timeline + speeds)
  6  two_regions  (entorhinal -> hippocampus)
  7  stadium      (crowd roar/LFP vs individual voices/spikes -- the key analogy)
  11 entrainment  (pushing a swing + buzz/brain waves locking)
  14 trap         (mic records brain AND the machine's 50 Hz hum)
  23 fix          (sync pin + force sensor + drive copy -> shared-clock Intan)
Deck rebuilt (pptx + pdf); now 15 figures total. The remaining text slides
(2,4,24,25) stay clean for a stock photo/icon in Slides.

Co-Authored-By: Claude Opus 4.8 (1M context) <noreply@anthropic.com>
</commit_message>
<xml_diff>
--- a/presentation/haptic_brain_talk.pptx
+++ b/presentation/haptic_brain_talk.pptx
@@ -5628,9 +5628,33 @@
           </a:p>
         </p:txBody>
       </p:sp>
-      <p:sp>
-        <p:nvSpPr>
-          <p:cNvPr id="5" name="Rectangle 4"/>
+      <p:pic>
+        <p:nvPicPr>
+          <p:cNvPr id="5" name="Picture 4" descr="entrainment.png"/>
+          <p:cNvPicPr>
+            <a:picLocks noChangeAspect="1"/>
+          </p:cNvPicPr>
+          <p:nvPr/>
+        </p:nvPicPr>
+        <p:blipFill>
+          <a:blip r:embed="rId2"/>
+          <a:stretch>
+            <a:fillRect/>
+          </a:stretch>
+        </p:blipFill>
+        <p:spPr>
+          <a:xfrm>
+            <a:off x="1512111" y="1965960"/>
+            <a:ext cx="9167471" cy="3931920"/>
+          </a:xfrm>
+          <a:prstGeom prst="rect">
+            <a:avLst/>
+          </a:prstGeom>
+        </p:spPr>
+      </p:pic>
+      <p:sp>
+        <p:nvSpPr>
+          <p:cNvPr id="6" name="Rectangle 5"/>
           <p:cNvSpPr/>
           <p:nvPr/>
         </p:nvSpPr>
@@ -5673,7 +5697,7 @@
       </p:sp>
       <p:sp>
         <p:nvSpPr>
-          <p:cNvPr id="6" name="TextBox 5"/>
+          <p:cNvPr id="7" name="TextBox 6"/>
           <p:cNvSpPr txBox="1"/>
           <p:nvPr/>
         </p:nvSpPr>
@@ -6303,9 +6327,33 @@
           </a:p>
         </p:txBody>
       </p:sp>
-      <p:sp>
-        <p:nvSpPr>
-          <p:cNvPr id="5" name="Rectangle 4"/>
+      <p:pic>
+        <p:nvPicPr>
+          <p:cNvPr id="5" name="Picture 4" descr="trap.png"/>
+          <p:cNvPicPr>
+            <a:picLocks noChangeAspect="1"/>
+          </p:cNvPicPr>
+          <p:nvPr/>
+        </p:nvPicPr>
+        <p:blipFill>
+          <a:blip r:embed="rId2"/>
+          <a:stretch>
+            <a:fillRect/>
+          </a:stretch>
+        </p:blipFill>
+        <p:spPr>
+          <a:xfrm>
+            <a:off x="1774039" y="1965960"/>
+            <a:ext cx="8643615" cy="3931920"/>
+          </a:xfrm>
+          <a:prstGeom prst="rect">
+            <a:avLst/>
+          </a:prstGeom>
+        </p:spPr>
+      </p:pic>
+      <p:sp>
+        <p:nvSpPr>
+          <p:cNvPr id="6" name="Rectangle 5"/>
           <p:cNvSpPr/>
           <p:nvPr/>
         </p:nvSpPr>
@@ -6348,7 +6396,7 @@
       </p:sp>
       <p:sp>
         <p:nvSpPr>
-          <p:cNvPr id="6" name="TextBox 5"/>
+          <p:cNvPr id="7" name="TextBox 6"/>
           <p:cNvSpPr txBox="1"/>
           <p:nvPr/>
         </p:nvSpPr>
@@ -8354,9 +8402,33 @@
           </a:p>
         </p:txBody>
       </p:sp>
-      <p:sp>
-        <p:nvSpPr>
-          <p:cNvPr id="4" name="Rectangle 3"/>
+      <p:pic>
+        <p:nvPicPr>
+          <p:cNvPr id="4" name="Picture 3" descr="fix.png"/>
+          <p:cNvPicPr>
+            <a:picLocks noChangeAspect="1"/>
+          </p:cNvPicPr>
+          <p:nvPr/>
+        </p:nvPicPr>
+        <p:blipFill>
+          <a:blip r:embed="rId2"/>
+          <a:stretch>
+            <a:fillRect/>
+          </a:stretch>
+        </p:blipFill>
+        <p:spPr>
+          <a:xfrm>
+            <a:off x="1769914" y="1554480"/>
+            <a:ext cx="8651866" cy="4343400"/>
+          </a:xfrm>
+          <a:prstGeom prst="rect">
+            <a:avLst/>
+          </a:prstGeom>
+        </p:spPr>
+      </p:pic>
+      <p:sp>
+        <p:nvSpPr>
+          <p:cNvPr id="5" name="Rectangle 4"/>
           <p:cNvSpPr/>
           <p:nvPr/>
         </p:nvSpPr>
@@ -8399,7 +8471,7 @@
       </p:sp>
       <p:sp>
         <p:nvSpPr>
-          <p:cNvPr id="5" name="TextBox 4"/>
+          <p:cNvPr id="6" name="TextBox 5"/>
           <p:cNvSpPr txBox="1"/>
           <p:nvPr/>
         </p:nvSpPr>
@@ -9120,9 +9192,33 @@
           </a:p>
         </p:txBody>
       </p:sp>
-      <p:sp>
-        <p:nvSpPr>
-          <p:cNvPr id="4" name="Rectangle 3"/>
+      <p:pic>
+        <p:nvPicPr>
+          <p:cNvPr id="4" name="Picture 3" descr="experiment.png"/>
+          <p:cNvPicPr>
+            <a:picLocks noChangeAspect="1"/>
+          </p:cNvPicPr>
+          <p:nvPr/>
+        </p:nvPicPr>
+        <p:blipFill>
+          <a:blip r:embed="rId2"/>
+          <a:stretch>
+            <a:fillRect/>
+          </a:stretch>
+        </p:blipFill>
+        <p:spPr>
+          <a:xfrm>
+            <a:off x="1416138" y="1554480"/>
+            <a:ext cx="9359418" cy="4343400"/>
+          </a:xfrm>
+          <a:prstGeom prst="rect">
+            <a:avLst/>
+          </a:prstGeom>
+        </p:spPr>
+      </p:pic>
+      <p:sp>
+        <p:nvSpPr>
+          <p:cNvPr id="5" name="Rectangle 4"/>
           <p:cNvSpPr/>
           <p:nvPr/>
         </p:nvSpPr>
@@ -9165,7 +9261,7 @@
       </p:sp>
       <p:sp>
         <p:nvSpPr>
-          <p:cNvPr id="5" name="TextBox 4"/>
+          <p:cNvPr id="6" name="TextBox 5"/>
           <p:cNvSpPr txBox="1"/>
           <p:nvPr/>
         </p:nvSpPr>
@@ -9599,9 +9695,33 @@
           </a:p>
         </p:txBody>
       </p:sp>
-      <p:sp>
-        <p:nvSpPr>
-          <p:cNvPr id="4" name="Rectangle 3"/>
+      <p:pic>
+        <p:nvPicPr>
+          <p:cNvPr id="4" name="Picture 3" descr="two_regions.png"/>
+          <p:cNvPicPr>
+            <a:picLocks noChangeAspect="1"/>
+          </p:cNvPicPr>
+          <p:nvPr/>
+        </p:nvPicPr>
+        <p:blipFill>
+          <a:blip r:embed="rId2"/>
+          <a:stretch>
+            <a:fillRect/>
+          </a:stretch>
+        </p:blipFill>
+        <p:spPr>
+          <a:xfrm>
+            <a:off x="815952" y="1554480"/>
+            <a:ext cx="10559790" cy="4343400"/>
+          </a:xfrm>
+          <a:prstGeom prst="rect">
+            <a:avLst/>
+          </a:prstGeom>
+        </p:spPr>
+      </p:pic>
+      <p:sp>
+        <p:nvSpPr>
+          <p:cNvPr id="5" name="Rectangle 4"/>
           <p:cNvSpPr/>
           <p:nvPr/>
         </p:nvSpPr>
@@ -9644,7 +9764,7 @@
       </p:sp>
       <p:sp>
         <p:nvSpPr>
-          <p:cNvPr id="5" name="TextBox 4"/>
+          <p:cNvPr id="6" name="TextBox 5"/>
           <p:cNvSpPr txBox="1"/>
           <p:nvPr/>
         </p:nvSpPr>
@@ -9808,9 +9928,33 @@
           </a:p>
         </p:txBody>
       </p:sp>
-      <p:sp>
-        <p:nvSpPr>
-          <p:cNvPr id="5" name="Rectangle 4"/>
+      <p:pic>
+        <p:nvPicPr>
+          <p:cNvPr id="5" name="Picture 4" descr="stadium.png"/>
+          <p:cNvPicPr>
+            <a:picLocks noChangeAspect="1"/>
+          </p:cNvPicPr>
+          <p:nvPr/>
+        </p:nvPicPr>
+        <p:blipFill>
+          <a:blip r:embed="rId2"/>
+          <a:stretch>
+            <a:fillRect/>
+          </a:stretch>
+        </p:blipFill>
+        <p:spPr>
+          <a:xfrm>
+            <a:off x="2014140" y="1965960"/>
+            <a:ext cx="8163414" cy="3931920"/>
+          </a:xfrm>
+          <a:prstGeom prst="rect">
+            <a:avLst/>
+          </a:prstGeom>
+        </p:spPr>
+      </p:pic>
+      <p:sp>
+        <p:nvSpPr>
+          <p:cNvPr id="6" name="Rectangle 5"/>
           <p:cNvSpPr/>
           <p:nvPr/>
         </p:nvSpPr>
@@ -9853,7 +9997,7 @@
       </p:sp>
       <p:sp>
         <p:nvSpPr>
-          <p:cNvPr id="6" name="TextBox 5"/>
+          <p:cNvPr id="7" name="TextBox 6"/>
           <p:cNvSpPr txBox="1"/>
           <p:nvPr/>
         </p:nvSpPr>

</xml_diff>

<commit_message>
Presentation: raise to researcher register + use real trial-window figure
- Rewrote all slide titles/takeaways/notes for a scientifically-literate, mixed-field
  audience: lead with precise terminology (LFP, single-unit activity, spike sorting,
  entrainment/phase-locking, 1/f background, ITPC, volume conduction, artifact),
  define only neuro-specific terms, keep analogies as intuition, quantify.
- Slide 3 (design) now uses the REAL trial-window diagram from results/dec3/13_*;
  data-finding slides already use real results/ figures. Schematics retained only
  for concepts with no real equivalent (regions, LFP-vs-units, entrainment,
  artifact-confound, next-round fix).
- Elevated the 6 concept-figure titles to match. Deck: 26 slides, 15 figures.

Co-Authored-By: Claude Opus 4.8 (1M context) <noreply@anthropic.com>
</commit_message>
<xml_diff>
--- a/presentation/haptic_brain_talk.pptx
+++ b/presentation/haptic_brain_talk.pptx
@@ -527,7 +527,7 @@
           <a:lstStyle/>
           <a:p>
             <a:r>
-              <a:t>Welcome. Today: a simple-sounding question with a surprisingly subtle answer. If you buzz someone's skin, does it actually change what their brain is doing — and can the brain 'tune in' to the rhythm of the buzz? No neuroscience background needed; I'll build up every idea with an analogy. (~35 min, stop me with questions.)</a:t>
+              <a:t>The question: does peripheral haptic stimulation produce a measurable, frequency-specific response in central circuits, and can it entrain neural activity? I'll define the few neuroscience-specific terms (LFP, single units, entrainment, spike sorting) as they come up; everything else assumes general research literacy. ~35 min — please interrupt.</a:t>
             </a:r>
           </a:p>
         </p:txBody>
@@ -597,7 +597,7 @@
           <a:lstStyle/>
           <a:p>
             <a:r>
-              <a:t>If the brain hummed at the buzz speed, we'd see a sharp spike of energy at that exact frequency, above the brain's normal background. We don't — at any speed. So in the hippocampus, no frequency-following: it notices the buzz but doesn't oscillate in step. And this replicated across two sessions. The swing isn't catching the push.</a:t>
+              <a:t>The test: frequency-following predicts a narrowband peak at the carrier above the 1/f aperiodic background, and above-chance inter-trial phase clustering (ITPC). We see neither, at any carrier, replicated across two sessions on the same probe. So no power- or phase-based frequency-following in hippocampus.</a:t>
             </a:r>
           </a:p>
         </p:txBody>
@@ -667,7 +667,7 @@
           <a:lstStyle/>
           <a:p>
             <a:r>
-              <a:t>Now it gets interesting. In the entorhinal inbox, a signal at exactly 50 per second DOES show up in the crowd murmur, and it grows as we buzz harder. We were excited — maybe THIS region entrains at 50! But there's a trap, and a careful scientist has to check it. Let me teach you the trap.</a:t>
+              <a:t>In entorhinal cortex there is a narrowband 50 Hz LFP power increase that scales with stimulus amplitude — superficially the entrainment signal we want. But recall the asymmetry: the LFP is precisely the readout that electrical pickup can mimic. So before interpreting it as neural, we have to exclude a stimulator-coupled artifact.</a:t>
             </a:r>
           </a:p>
         </p:txBody>
@@ -737,7 +737,7 @@
           <a:lstStyle/>
           <a:p>
             <a:r>
-              <a:t>Analogy: you're recording the crowd, but the stadium PA speaker hums at 50 Hz and your mic picks up THAT. Now your recording shows a clean 50 Hz — but it's the speaker, not the crowd. Same risk: the buzzing motor and its electronics can leak a 50-per-second electrical signal into our wires. That would look like a '50 Hz brain signal' but be pure equipment artifact. How do you tell brain from machine? We found a clean test.</a:t>
+              <a:t>The actuator and its drive electronics can couple a 50 Hz signal into the recording — volume-conducted through tissue or via the wiring. In the LFP that is indistinguishable from a neural 50 Hz oscillation (the PA-hum case of the stadium analogy). We need a discriminator the artifact cannot fool.</a:t>
             </a:r>
           </a:p>
         </p:txBody>
@@ -807,7 +807,7 @@
           <a:lstStyle/>
           <a:p>
             <a:r>
-              <a:t>The trick: some electrodes were broken/disconnected — they physically can't hear neurons. Dead microphones. If a dead mic still records a loud 50 Hz, that CANNOT be the brain — only the machine's hum leaking in. And that's what we saw: the dead electrodes picked up about SIX TIMES MORE 50 Hz than the live, in-brain ones (right panel, red). Verdict: the entorhinal '50 Hz brain wave' is largely equipment pickup. The crowd murmur fooled us — good thing we checked.</a:t>
+              <a:t>The discriminator: broken/disconnected channels cannot record neural activity but still act as antennas for electrical pickup. If they carry the 50 Hz, it is instrumental, not neural. They do — ~6× the in-tissue channels — so the entorhinal 50 Hz LFP is largely (not necessarily entirely) stimulator artifact. The headline LFP result is mostly the machine. This is the central twist.</a:t>
             </a:r>
           </a:p>
         </p:txBody>
@@ -877,7 +877,7 @@
           <a:lstStyle/>
           <a:p>
             <a:r>
-              <a:t>Now the hero arrives: the individual voices. Tracking single, identified neurons, they genuinely change how much they fire during the strong 50-per-second buzz — in BOTH regions. Why trustworthy when the crowd murmur wasn't? The machine's hum can make a recording wiggle, but it can't make a real, identified neuron decide to fire. This is the clean result: 50 Hz, strong buzz, is where the brain's actual cells respond — far more than at slower speeds. So question 2 — does speed matter? — yes: 50 is special.</a:t>
+              <a:t>Now the artifact-resistant readout: sorted single units change firing rate during the high-amplitude 50 Hz condition, in both regions, and far more than at lower carriers. Because pickup cannot drive a sorted neuron's spike train, this is the clean evidence. Question 2 — frequency specificity — is answered: 50 Hz is privileged, and the Dec-3 single-unit null is explained (Dec 3 only tested 5/26 Hz, where there is no effect).</a:t>
             </a:r>
           </a:p>
         </p:txBody>
@@ -947,7 +947,7 @@
           <a:lstStyle/>
           <a:p>
             <a:r>
-              <a:t>Two safeguards. First: to find spikes we throw away the slow part and keep only the fast, sharp blips — like turning up the treble to hear finger-snaps over a rumble. The 50 Hz hum is a slow rumble, so it's gone before we ever count a spike. Second: if the hum WERE sneaking in as fake spikes, the neuron would look like a metronome — ticking exactly every 1/50th of a second. We checked: NO such 50 Hz ticking, and it looks the same during buzz and rest. So these are real neurons. (This was the unit we scrutinized hardest; it passed.)</a:t>
+              <a:t>Two controls against residual artifact. (1) Spike detection operates on the &gt;~300 Hz band, so the 50 Hz LFP/pickup is filtered out before a spike is detected. (2) Were pickup nonetheless injecting spurious spikes at 50 Hz, the spike-train autocorrelogram would develop 20 ms periodicity during stimulation — it does not, and is identical ON vs OFF; refractory-violation rates also do not rise during ON. So the rate modulation is genuine single-unit activity. (Unit 87, the most exposed up-going unit, passes both screens.)</a:t>
             </a:r>
           </a:p>
         </p:txBody>
@@ -1017,7 +1017,7 @@
           <a:lstStyle/>
           <a:p>
             <a:r>
-              <a:t>The satisfying part: the two regions react to the SAME buzz in OPPOSITE directions — hippocampus revs a subset up, entorhinal mostly quiets down. Analogy: two people hearing the same news, one excited, one goes quiet. That difference means they're actively PROCESSING the input, not passively echoing it. (Bonus: the quieting-down is itself strong evidence it's real — equipment pickup can only ADD fake blips, it can't make a neuron go silent.)</a:t>
+              <a:t>The two regions transform the same input in opposite directions: a hippocampal subset increases firing (a few strongly driven units carry the positive mean), while entorhinal cortex is net-suppressed (~10/15 units down). Opposite-signed responses to identical input are inconsistent with a passive, volume-conducted relay and consistent with circuit-specific processing. The suppression is also intrinsically artifact-resistant — additive pickup adds, it cannot remove, spikes.</a:t>
             </a:r>
           </a:p>
         </p:txBody>
@@ -1087,7 +1087,7 @@
           <a:lstStyle/>
           <a:p>
             <a:r>
-              <a:t>Do they coordinate, like partners in a conversation? The crowd murmur made them look in sync. But analogy: two orchestras in separate rooms can SEEM synchronized just because both hear the same metronome in the hallway — not because they listen to each other. The trustworthy test is whether the actual MUSICIANS (neurons) time to the other room — they don't, not more during the buzz. So the apparent 'sync' is the shared hum (that 50 Hz pickup again), not teamwork. Honest answer: no clear coordination.</a:t>
+              <a:t>Do the regions interact at 50 Hz? LFP–LFP coherence increases — but a shared pickup inflates coherence, so that's the artifact-prone measure. The spike–field measure (one region's spikes vs the other region's LFP phase), which a shared LFP artifact cannot fake as easily, does not increase with stimulation. So the apparent coupling is most parsimoniously a shared signal, not genuine coordination.</a:t>
             </a:r>
           </a:p>
         </p:txBody>
@@ -1157,7 +1157,7 @@
           <a:lstStyle/>
           <a:p>
             <a:r>
-              <a:t>Back to the holy-grail question — does the brain entrain? We genuinely could not test it, for an honest reason. Analogy: to judge whether a dancer is on the beat, you need to have recorded the MUSIC. We recorded the dancer (the brain) beautifully — but never properly recorded the music (the exact timing of the buzz). No beat, no scoring. So 'we didn't show entrainment' is NOT 'the brain failed to entrain' — it's 'we were missing the measurement.'</a:t>
+              <a:t>Critically: testing entrainment (phase-locking) requires a time-aligned reference for the stimulus phase. We did not record a usable one — so 'no entrainment shown' is a measurement gap, not evidence of absence. Distinguishing 'untestable' from 'tested-and-negative' is essential for honest claims. (Note: the power/periodicity negatives above are real and testable; only the phase-locking claim is gated by the missing reference.)</a:t>
             </a:r>
           </a:p>
         </p:txBody>
@@ -1227,7 +1227,7 @@
           <a:lstStyle/>
           <a:p>
             <a:r>
-              <a:t>I proved this from the data. The signal that should have marked each buzz cycle updated only ~4 times a second — but the tactor buzzed 26 times a second. Analogy: tracking a hummingbird's wingbeats by glancing 4 times a second — between glances the wings flapped 6 times; you can't recover the motion. (Top: the actual recorded line, slow and irregular. Middle: what a real 26-per-second buzz looks like. Bottom: the gaps are ~6× too long.) So the 'music track' was effectively blank. That one missing signal is the main limitation of the study.</a:t>
+              <a:t>I verified this directly from the raw digital stream: the channel intended as a sync updated at ~4 Hz irrespective of carrier (the same ~6 pulses/trial for 5 and 26 Hz; ~78 expected at 26 Hz), never sustained a run at the carrier period anywhere in the 3 h session, and was misaligned with the trial schedule. It is undersampled and decoupled from the stimulus — so phase is unrecoverable. Sampling intuition: a ~4 Hz observer cannot resolve a 26 Hz oscillation.</a:t>
             </a:r>
           </a:p>
         </p:txBody>
@@ -1297,7 +1297,7 @@
           <a:lstStyle/>
           <a:p>
             <a:r>
-              <a:t>Big picture first. There's huge interest in wearables that touch your skin to shift a brain state — to help you sleep, focus, calm down, or aid therapy after injury. The skin is the easiest, safest door to the nervous system. But before any of that, we need the unglamorous groundwork: if I buzz the body, (1) does the brain even notice, (2) does it matter how FAST I buzz, and (3) can the brain lock onto the rhythm of the buzz? That third one — 'marching in step' with the stimulus — is the holy grail, because that's how you'd drive a brain rhythm on purpose.</a:t>
+              <a:t>There's growing interest in modulating brain state non-invasively through the periphery — the skin is the most accessible, lowest-risk interface. But the foundational, under-characterized question is whether peripheral haptic input produces a reliable, frequency-specific central response, and whether it can entrain endogenous activity (the precondition for 'driving' a rhythm). This study characterizes that response at two levels — field potentials and single neurons — and, importantly, the controls needed to interpret it.</a:t>
             </a:r>
           </a:p>
         </p:txBody>
@@ -1367,7 +1367,7 @@
           <a:lstStyle/>
           <a:p>
             <a:r>
-              <a:t>The good news: a wiring problem, not a dead end, and we've designed the fix. Next round we record the music three ways at once, all on the brain's clock: (1) a clean marker the buzzer's software emits once per cycle; (2) a tiny force sensor between tactor and skin measuring the ACTUAL vibration — proving the buzz happened and giving its exact beat; (3) a copy of the drive signal as backup. Plus a 2-minute test recording to CONFIRM it works before real data — the check that would have caught this. Then entrainment is directly testable.</a:t>
+              <a:t>The fix is design, not analysis: record the stimulus three ways on the acquisition clock — a firmware-emitted per-cycle marker (now implemented), a transduced measurement of the delivered vibration (PVDF or accelerometer, which also verifies delivery and captures mechanical phase), and a copy of the drive signal — then cross-validate, plus a short verification recording before the session. With redundancy on a shared clock, any single failed reference is caught immediately rather than months later in analysis.</a:t>
             </a:r>
           </a:p>
         </p:txBody>
@@ -1437,7 +1437,7 @@
           <a:lstStyle/>
           <a:p>
             <a:r>
-              <a:t>Three plain-language takeaways. ONE: a buzz on the body really does change the brain — real, not trivial. TWO: the most trustworthy effect is at the level of individual neurons, specifically at the fast 50-per-second buzz, and the two regions handle it differently — active processing, not a passive echo. THREE: the flashy 'brain wave at 50 Hz' was mostly the machine's hum, and whether the brain truly 'marches in step' we couldn't test yet — because the stimulus timing wasn't recorded. We know exactly how to fix that.</a:t>
+              <a:t>To summarize: (1) peripheral haptic stimulation produces a genuine central response; (2) the most rigorous evidence is frequency-specific, region-specific single-unit rate modulation at 50 Hz / high amplitude — driven-up subset in hippocampus, net suppression in entorhinal cortex; (3) the entorhinal 50 Hz LFP is largely stimulator artifact, established by the disconnected-channel control; (4) entrainment was untestable for want of a stimulus-phase reference — a fixable instrumentation gap, not a biological null. Caveats: single animal; modest responder fraction; an arousal/indirect-pathway contribution can't be fully excluded.</a:t>
             </a:r>
           </a:p>
         </p:txBody>
@@ -1507,7 +1507,7 @@
           <a:lstStyle/>
           <a:p>
             <a:r>
-              <a:t>Why should a non-neuroscientist care? If the next round shows the brain CAN be entrained through the skin, that's a foundation for safe, non-invasive wearables that nudge brain states — for sleep, focus, calm, rehabilitation — without surgery or drugs. This study did the honest groundwork: found a real neural effect, caught itself when a result was actually equipment noise, and pinpointed the one measurement we must add to ask the biggest question properly.</a:t>
+              <a:t>Implications: this establishes that peripheral haptic stimulation has a measurable, frequency-specific central signature — and, equally important, the methodological controls needed to separate neural signal from stimulator artifact (the disconnected-channel test, the high-pass/ACG/ISI spike screens). With the shared-clock stimulus recording, entrainment becomes directly testable — the gateway question for closed-loop peripheral neuromodulation.</a:t>
             </a:r>
           </a:p>
         </p:txBody>
@@ -1577,7 +1577,7 @@
           <a:lstStyle/>
           <a:p>
             <a:r>
-              <a:t>Likely questions: 'Is 50 Hz special or just strongest?' (strongest clean single-unit effect of the speeds tested). 'Could it be arousal — they just felt a strong buzz?' (possible; but it's frequency-specific — 50 beats 26 at the same strength — which argues against pure arousal). 'Why not trust the 50 Hz brain wave?' (dead electrodes picked it up → largely machine pickup).</a:t>
+              <a:t>Anticipated questions. 'Is 50 Hz special or just strongest?' — strongest clean single-unit effect of the carriers tested; the LFP transient was largest at 26 Hz but that's the artifact-prone/non-specific measure. 'Could it be arousal?' — possible, but it's frequency-specific (50 ≫ 26 at matched amplitude), which argues against pure intensity-driven arousal; an indirect sensory/state pathway is not excluded. 'Why distrust the 50 Hz LFP?' — disconnected channels carry it at ~6× tissue levels.</a:t>
             </a:r>
           </a:p>
         </p:txBody>
@@ -1647,7 +1647,7 @@
           <a:lstStyle/>
           <a:p>
             <a:r>
-              <a:t>Here's the whole setup in plain terms. We put a little vibrating motor — a 'tactor', like the buzz in your phone — on the body. We buzz it for 3 seconds, then rest 3 seconds, over and over. We try different buzz SPEEDS: 5, 10, 26, and 50 buzzes per second. And different strengths. While that happens, we listen to the brain with fine electrodes. Then we ask: what changed in the brain during the buzz versus the rest? [Tip: drop a setup photo here.]</a:t>
+              <a:t>A tactor delivers a sinusoidal vibration in 3 s ON / 3 s OFF blocks (figure shows the trial structure and the analysis windows we use). We vary carrier frequency — 5, 10, 26, 50 Hz — and amplitude, ~200 trials per condition, while recording extracellularly with linear silicon probes in two regions simultaneously. Each analysis window is referenced to the 1 s pre-stimulus baseline; 100 ms margins isolate onset/offset transients from sustained activity.</a:t>
             </a:r>
           </a:p>
         </p:txBody>
@@ -1717,7 +1717,7 @@
           <a:lstStyle/>
           <a:p>
             <a:r>
-              <a:t>Keep these three questions in your head — the whole talk answers them. One: does the brain register the buzz at all? Two: does it care how fast we buzz — is 50/sec different from 26/sec? Three, the big one: does the brain 'entrain' — literally oscillate in lockstep with the buzz, like marching to a drumbeat? Spoiler: yes, yes-ish, and 'we couldn't fully test it' — and WHY we couldn't is one of the most useful things we learned.</a:t>
+              <a:t>Three levels: detection (any response?), tuning (specific to stimulus frequency/amplitude?), and entrainment (do neural signals phase-lock to the stimulus waveform?). Entrainment is the strongest claim and the one that would justify peripheral rhythm-driving — and, as you'll see, the one we could not test, for an instructive instrumentation reason.</a:t>
             </a:r>
           </a:p>
         </p:txBody>
@@ -1787,7 +1787,7 @@
           <a:lstStyle/>
           <a:p>
             <a:r>
-              <a:t>We recorded from two spots that talk to each other: the hippocampus — think of it as the brain's inner GPS and memory-maker — and right next to it the entorhinal cortex, which is the hippocampus's main inbox, where a lot of sensory information arrives. So: two listening posts in a circuit that handles where-you-are and what-just-happened. Don't worry about the names; just 'two connected regions.'</a:t>
+              <a:t>For non-neuroscientists: the hippocampus supports spatial navigation and episodic memory; the entorhinal cortex is its principal cortical input/output interface. They form a tightly coupled circuit, so recording both lets us ask not only whether each responds but whether they interact.</a:t>
             </a:r>
           </a:p>
         </p:txBody>
@@ -1857,7 +1857,7 @@
           <a:lstStyle/>
           <a:p>
             <a:r>
-              <a:t>This is the single most important idea in the talk. Imagine a microphone over a packed stadium. You hear TWO things. First, the low ROAR of the whole crowd — that's the 'field potential' (LFP): the blended, slow electrical hum of thousands of cells. Second, individual people SHOUTING — sharp, brief, distinct. Those are 'spikes': single neurons firing, each a crisp ~1-millisecond blip. The crowd murmur is easy to hear but vague; the individual voices are harder to pick out but tell you exactly who said what. We use BOTH — and the difference between them is the whole plot.</a:t>
+              <a:t>An extracellular electrode captures two regimes. The local field potential (LFP) is the low-frequency aggregate of synaptic and transmembrane currents from many neurons — large and easy to measure, but spatially non-specific and susceptible to volume-conducted or instrumental noise. Single-unit activity is the spiking of individual neurons, isolated by spike sorting — sparser and harder to extract, but each spike is a discrete, unambiguous biological event. Intuition: a stadium microphone hears both the crowd's aggregate roar (LFP) and individual shouts (spikes); the roar is loud but can be contaminated by, say, a PA hum, whereas an identified shout is real. This LFP-vs-single-unit distinction is the crux of the entire talk.</a:t>
             </a:r>
           </a:p>
         </p:txBody>
@@ -1927,7 +1927,7 @@
           <a:lstStyle/>
           <a:p>
             <a:r>
-              <a:t>Why care about the hard-to-hear individual voices? Because they're trustworthy. The crowd murmur can be contaminated by background noise — a passing truck, a buzzing speaker. But an identified shout is a real event from a real person. Same in the brain: a sorted single-neuron spike is a genuine cell, and it's much harder for the equipment's electrical noise to fake one. Hold that thought; it becomes the hero of the story.</a:t>
+              <a:t>The asymmetry that drives the whole analysis: an electrical artifact can add power to the LFP at the stimulus frequency, but it cannot make a waveform-isolated, sorted neuron emit an action potential. So when we want to claim a genuine neural effect — rather than instrumental pickup — single-unit firing-rate changes are the evidence that survives scrutiny. Keep this asymmetry in mind; it resolves the central twist of the results.</a:t>
             </a:r>
           </a:p>
         </p:txBody>
@@ -1997,7 +1997,7 @@
           <a:lstStyle/>
           <a:p>
             <a:r>
-              <a:t>First result. The crowd-murmur signal clearly changes when we buzz — so yes, the brain notices. But HOW: it mostly reacts to the buzz turning ON and OFF, not by settling into its rhythm. Analogy: a doorbell. Your attention spikes when it RINGS and when it STOPS, but you don't start vibrating at the doorbell's pitch. So the brain registers the event, but isn't obviously 'tuning in.'</a:t>
+              <a:t>The broadband LFP shows a clear, amplitude-graded response — but it is concentrated at the ON and OFF transitions: an evoked transient, not a sustained oscillation at the drive frequency. Conceptually it's the difference between responding to the event of stimulation versus tracking its rhythm. So 'there is a response' — but not yet frequency-following.</a:t>
             </a:r>
           </a:p>
         </p:txBody>
@@ -2067,7 +2067,7 @@
           <a:lstStyle/>
           <a:p>
             <a:r>
-              <a:t>The dream is 'entrainment': the brain's own waves locking onto the buzz's rhythm. Analogy: pushing a swing. If you push exactly in time, it goes higher and higher — your rhythm drives its rhythm. If the brain entrained to a 50-per-second buzz, we'd see brain activity ticking at 50 per second. That would mean you can DIAL IN a brain rhythm from the skin. So: does the brain hum along at the buzz frequency?</a:t>
+              <a:t>Entrainment here means neural activity phase-locks to the periodic stimulus — a driven-oscillator relationship, analogous to resonantly pumping a pendulum. If these circuits entrained to a 50 Hz drive, we'd see neural power and spike timing organized at 50 Hz. That is the result that would justify driving a brain rhythm from the periphery. So: is there frequency-following?</a:t>
             </a:r>
           </a:p>
         </p:txBody>
@@ -5183,13 +5183,13 @@
           <a:p>
             <a:pPr algn="l"/>
             <a:r>
-              <a:rPr sz="3600" b="1">
+              <a:rPr sz="3400" b="1">
                 <a:solidFill>
                   <a:srgbClr val="FFFFFF"/>
                 </a:solidFill>
                 <a:latin typeface="Calibri"/>
               </a:rPr>
-              <a:t>Can we talk to the brain through the skin?</a:t>
+              <a:t>Can we drive the brain through the skin?</a:t>
             </a:r>
           </a:p>
         </p:txBody>
@@ -5202,8 +5202,8 @@
         </p:nvSpPr>
         <p:spPr>
           <a:xfrm>
-            <a:off x="914400" y="3291840"/>
-            <a:ext cx="10362895" cy="914400"/>
+            <a:off x="914400" y="3383280"/>
+            <a:ext cx="10362895" cy="1097280"/>
           </a:xfrm>
           <a:prstGeom prst="rect">
             <a:avLst/>
@@ -5218,13 +5218,13 @@
           <a:p>
             <a:pPr algn="l"/>
             <a:r>
-              <a:rPr sz="1900" b="0">
+              <a:rPr sz="1800" b="0">
                 <a:solidFill>
                   <a:srgbClr val="BFD0DA"/>
                 </a:solidFill>
                 <a:latin typeface="Calibri"/>
               </a:rPr>
-              <a:t>What happens in the brain when we buzz the body at different rhythms</a:t>
+              <a:t>Single-unit and LFP responses to amplitude- and frequency-varied haptic stimulation in hippocampus &amp; entorhinal cortex</a:t>
             </a:r>
           </a:p>
         </p:txBody>
@@ -5355,7 +5355,7 @@
                 </a:solidFill>
                 <a:latin typeface="Calibri"/>
               </a:rPr>
-              <a:t>FINDING 1 · ANALOGY</a:t>
+              <a:t>FINDING 1</a:t>
             </a:r>
           </a:p>
         </p:txBody>
@@ -5384,13 +5384,13 @@
           <a:p>
             <a:pPr algn="l"/>
             <a:r>
-              <a:rPr sz="2600" b="1">
+              <a:rPr sz="2400" b="1">
                 <a:solidFill>
                   <a:srgbClr val="1A1A2E"/>
                 </a:solidFill>
                 <a:latin typeface="Calibri"/>
               </a:rPr>
-              <a:t>Yes — the brain notices the buzz. But it reacts to the START and STOP</a:t>
+              <a:t>A robust LFP response — transition-weighted, not a sustained oscillation</a:t>
             </a:r>
           </a:p>
         </p:txBody>
@@ -5427,8 +5427,8 @@
         </p:nvSpPr>
         <p:spPr>
           <a:xfrm>
-            <a:off x="0" y="6080760"/>
-            <a:ext cx="12191695" cy="777240"/>
+            <a:off x="0" y="6035040"/>
+            <a:ext cx="12191695" cy="822960"/>
           </a:xfrm>
           <a:prstGeom prst="rect">
             <a:avLst/>
@@ -5470,8 +5470,8 @@
         </p:nvSpPr>
         <p:spPr>
           <a:xfrm>
-            <a:off x="548640" y="6108192"/>
-            <a:ext cx="11094415" cy="731520"/>
+            <a:off x="548640" y="6062472"/>
+            <a:ext cx="11094415" cy="777240"/>
           </a:xfrm>
           <a:prstGeom prst="rect">
             <a:avLst/>
@@ -5486,13 +5486,13 @@
           <a:p>
             <a:pPr algn="l"/>
             <a:r>
-              <a:rPr sz="1600" b="1">
+              <a:rPr sz="1500" b="1">
                 <a:solidFill>
                   <a:srgbClr val="1C6E8C"/>
                 </a:solidFill>
                 <a:latin typeface="Calibri"/>
               </a:rPr>
-              <a:t>Like a doorbell: the brain responds to the EVENT of the buzz turning on/off — not by humming along with it.</a:t>
+              <a:t>The broadband LFP responds at stimulus onset/offset (an evoked transient), not as a sustained rhythm at the carrier frequency.</a:t>
             </a:r>
           </a:p>
         </p:txBody>
@@ -5588,7 +5588,7 @@
                 </a:solidFill>
                 <a:latin typeface="Calibri"/>
               </a:rPr>
-              <a:t>CONCEPT · ANALOGY</a:t>
+              <a:t>DEFINITION</a:t>
             </a:r>
           </a:p>
         </p:txBody>
@@ -5617,13 +5617,13 @@
           <a:p>
             <a:pPr algn="l"/>
             <a:r>
-              <a:rPr sz="2600" b="1">
+              <a:rPr sz="2400" b="1">
                 <a:solidFill>
                   <a:srgbClr val="1A1A2E"/>
                 </a:solidFill>
                 <a:latin typeface="Calibri"/>
               </a:rPr>
-              <a:t>'Marching in step' has a name: entrainment</a:t>
+              <a:t>Entrainment, defined: phase-locking of neural activity to the stimulus</a:t>
             </a:r>
           </a:p>
         </p:txBody>
@@ -5660,8 +5660,8 @@
         </p:nvSpPr>
         <p:spPr>
           <a:xfrm>
-            <a:off x="0" y="6080760"/>
-            <a:ext cx="12191695" cy="777240"/>
+            <a:off x="0" y="6035040"/>
+            <a:ext cx="12191695" cy="822960"/>
           </a:xfrm>
           <a:prstGeom prst="rect">
             <a:avLst/>
@@ -5703,8 +5703,8 @@
         </p:nvSpPr>
         <p:spPr>
           <a:xfrm>
-            <a:off x="548640" y="6108192"/>
-            <a:ext cx="11094415" cy="731520"/>
+            <a:off x="548640" y="6062472"/>
+            <a:ext cx="11094415" cy="777240"/>
           </a:xfrm>
           <a:prstGeom prst="rect">
             <a:avLst/>
@@ -5719,13 +5719,13 @@
           <a:p>
             <a:pPr algn="l"/>
             <a:r>
-              <a:rPr sz="1600" b="1">
+              <a:rPr sz="1500" b="1">
                 <a:solidFill>
                   <a:srgbClr val="1C6E8C"/>
                 </a:solidFill>
                 <a:latin typeface="Calibri"/>
               </a:rPr>
-              <a:t>Pushing a swing in rhythm → if the brain entrains, its own waves line up with the buzz's beat.</a:t>
+              <a:t>Entrainment = endogenous activity aligns to the stimulus phase (a driven-oscillator relationship). The strong claim — and the most useful, if true.</a:t>
             </a:r>
           </a:p>
         </p:txBody>
@@ -5850,13 +5850,13 @@
           <a:p>
             <a:pPr algn="l"/>
             <a:r>
-              <a:rPr sz="2600" b="1">
+              <a:rPr sz="2400" b="1">
                 <a:solidFill>
                   <a:srgbClr val="1A1A2E"/>
                 </a:solidFill>
                 <a:latin typeface="Calibri"/>
               </a:rPr>
-              <a:t>The hippocampus does NOT hum along — at any buzz speed</a:t>
+              <a:t>No frequency-following in hippocampus at any carrier</a:t>
             </a:r>
           </a:p>
         </p:txBody>
@@ -5893,8 +5893,8 @@
         </p:nvSpPr>
         <p:spPr>
           <a:xfrm>
-            <a:off x="0" y="6080760"/>
-            <a:ext cx="12191695" cy="777240"/>
+            <a:off x="0" y="6035040"/>
+            <a:ext cx="12191695" cy="822960"/>
           </a:xfrm>
           <a:prstGeom prst="rect">
             <a:avLst/>
@@ -5936,8 +5936,8 @@
         </p:nvSpPr>
         <p:spPr>
           <a:xfrm>
-            <a:off x="548640" y="6108192"/>
-            <a:ext cx="11094415" cy="731520"/>
+            <a:off x="548640" y="6062472"/>
+            <a:ext cx="11094415" cy="777240"/>
           </a:xfrm>
           <a:prstGeom prst="rect">
             <a:avLst/>
@@ -5952,13 +5952,13 @@
           <a:p>
             <a:pPr algn="l"/>
             <a:r>
-              <a:rPr sz="1600" b="1">
+              <a:rPr sz="1500" b="1">
                 <a:solidFill>
                   <a:srgbClr val="1C6E8C"/>
                 </a:solidFill>
                 <a:latin typeface="Calibri"/>
               </a:rPr>
-              <a:t>No matter the buzz speed (5–50/sec), we see no matching brain rhythm above the normal background.</a:t>
+              <a:t>No narrowband spectral peak above the 1/f background, and inter-trial phase consistency at chance — across 5/10/26/50 Hz, replicated across sessions.</a:t>
             </a:r>
           </a:p>
         </p:txBody>
@@ -6083,13 +6083,13 @@
           <a:p>
             <a:pPr algn="l"/>
             <a:r>
-              <a:rPr sz="2600" b="1">
+              <a:rPr sz="2400" b="1">
                 <a:solidFill>
                   <a:srgbClr val="1A1A2E"/>
                 </a:solidFill>
                 <a:latin typeface="Calibri"/>
               </a:rPr>
-              <a:t>Plot twist: the OTHER region shows a 50-per-second signal</a:t>
+              <a:t>Entorhinal cortex shows an amplitude-graded 50 Hz LFP increase</a:t>
             </a:r>
           </a:p>
         </p:txBody>
@@ -6126,8 +6126,8 @@
         </p:nvSpPr>
         <p:spPr>
           <a:xfrm>
-            <a:off x="0" y="6080760"/>
-            <a:ext cx="12191695" cy="777240"/>
+            <a:off x="0" y="6035040"/>
+            <a:ext cx="12191695" cy="822960"/>
           </a:xfrm>
           <a:prstGeom prst="rect">
             <a:avLst/>
@@ -6169,8 +6169,8 @@
         </p:nvSpPr>
         <p:spPr>
           <a:xfrm>
-            <a:off x="548640" y="6108192"/>
-            <a:ext cx="11094415" cy="731520"/>
+            <a:off x="548640" y="6062472"/>
+            <a:ext cx="11094415" cy="777240"/>
           </a:xfrm>
           <a:prstGeom prst="rect">
             <a:avLst/>
@@ -6185,13 +6185,13 @@
           <a:p>
             <a:pPr algn="l"/>
             <a:r>
-              <a:rPr sz="1600" b="1">
+              <a:rPr sz="1500" b="1">
                 <a:solidFill>
                   <a:srgbClr val="1C6E8C"/>
                 </a:solidFill>
                 <a:latin typeface="Calibri"/>
               </a:rPr>
-              <a:t>In the entorhinal region a 50 Hz signal appears in the crowd murmur — and it grows with buzz strength. Exciting!</a:t>
+              <a:t>A narrowband 50 Hz LFP power increase, scaling with amplitude — the candidate entrainment signal. But the LFP is exactly the readout most vulnerable to artifact.</a:t>
             </a:r>
           </a:p>
         </p:txBody>
@@ -6287,7 +6287,7 @@
                 </a:solidFill>
                 <a:latin typeface="Calibri"/>
               </a:rPr>
-              <a:t>CONCEPT · ANALOGY</a:t>
+              <a:t>THE CONFOUND</a:t>
             </a:r>
           </a:p>
         </p:txBody>
@@ -6316,13 +6316,13 @@
           <a:p>
             <a:pPr algn="l"/>
             <a:r>
-              <a:rPr sz="2600" b="1">
+              <a:rPr sz="2400" b="1">
                 <a:solidFill>
                   <a:srgbClr val="1A1A2E"/>
                 </a:solidFill>
                 <a:latin typeface="Calibri"/>
               </a:rPr>
-              <a:t>The trap: the machine has its OWN electrical hum</a:t>
+              <a:t>The confound: stimulator-coupled 50 Hz electrical artifact</a:t>
             </a:r>
           </a:p>
         </p:txBody>
@@ -6359,8 +6359,8 @@
         </p:nvSpPr>
         <p:spPr>
           <a:xfrm>
-            <a:off x="0" y="6080760"/>
-            <a:ext cx="12191695" cy="777240"/>
+            <a:off x="0" y="6035040"/>
+            <a:ext cx="12191695" cy="822960"/>
           </a:xfrm>
           <a:prstGeom prst="rect">
             <a:avLst/>
@@ -6402,8 +6402,8 @@
         </p:nvSpPr>
         <p:spPr>
           <a:xfrm>
-            <a:off x="548640" y="6108192"/>
-            <a:ext cx="11094415" cy="731520"/>
+            <a:off x="548640" y="6062472"/>
+            <a:ext cx="11094415" cy="777240"/>
           </a:xfrm>
           <a:prstGeom prst="rect">
             <a:avLst/>
@@ -6418,13 +6418,13 @@
           <a:p>
             <a:pPr algn="l"/>
             <a:r>
-              <a:rPr sz="1600" b="1">
+              <a:rPr sz="1500" b="1">
                 <a:solidFill>
                   <a:srgbClr val="1C6E8C"/>
                 </a:solidFill>
                 <a:latin typeface="Calibri"/>
               </a:rPr>
-              <a:t>A microphone can pick up the speaker's buzz, not just the crowd. Electrical equipment leaks its own signal.</a:t>
+              <a:t>An electromechanical actuator can inject a 50 Hz electrical artifact directly into the recording — indistinguishable from a neural 50 Hz in the LFP alone.</a:t>
             </a:r>
           </a:p>
         </p:txBody>
@@ -6520,7 +6520,7 @@
                 </a:solidFill>
                 <a:latin typeface="Calibri"/>
               </a:rPr>
-              <a:t>FINDING 3B · THE KILLER TEST</a:t>
+              <a:t>FINDING 3, CONTROLLED</a:t>
             </a:r>
           </a:p>
         </p:txBody>
@@ -6549,13 +6549,13 @@
           <a:p>
             <a:pPr algn="l"/>
             <a:r>
-              <a:rPr sz="2600" b="1">
+              <a:rPr sz="2400" b="1">
                 <a:solidFill>
                   <a:srgbClr val="1A1A2E"/>
                 </a:solidFill>
                 <a:latin typeface="Calibri"/>
               </a:rPr>
-              <a:t>That 50 Hz is mostly the machine — the dead-electrode test proves it</a:t>
+              <a:t>Disconnected channels carry the 50 Hz — so it is largely pickup</a:t>
             </a:r>
           </a:p>
         </p:txBody>
@@ -6592,8 +6592,8 @@
         </p:nvSpPr>
         <p:spPr>
           <a:xfrm>
-            <a:off x="0" y="6080760"/>
-            <a:ext cx="12191695" cy="777240"/>
+            <a:off x="0" y="6035040"/>
+            <a:ext cx="12191695" cy="822960"/>
           </a:xfrm>
           <a:prstGeom prst="rect">
             <a:avLst/>
@@ -6635,8 +6635,8 @@
         </p:nvSpPr>
         <p:spPr>
           <a:xfrm>
-            <a:off x="548640" y="6108192"/>
-            <a:ext cx="11094415" cy="731520"/>
+            <a:off x="548640" y="6062472"/>
+            <a:ext cx="11094415" cy="777240"/>
           </a:xfrm>
           <a:prstGeom prst="rect">
             <a:avLst/>
@@ -6651,13 +6651,13 @@
           <a:p>
             <a:pPr algn="l"/>
             <a:r>
-              <a:rPr sz="1600" b="1">
+              <a:rPr sz="1500" b="1">
                 <a:solidFill>
                   <a:srgbClr val="1C6E8C"/>
                 </a:solidFill>
                 <a:latin typeface="Calibri"/>
               </a:rPr>
-              <a:t>Broken electrodes that CAN'T hear neurons still pick up the 50 Hz — ~6× more than the live ones. So it's pickup.</a:t>
+              <a:t>QC-failed/disconnected electrodes (which cannot record neural signal) show ~6× more 50 Hz than in-tissue channels. The entorhinal 50 Hz LFP is substantially artifact.</a:t>
             </a:r>
           </a:p>
         </p:txBody>
@@ -6753,7 +6753,7 @@
                 </a:solidFill>
                 <a:latin typeface="Calibri"/>
               </a:rPr>
-              <a:t>FINDING 4 · THE HEADLINE</a:t>
+              <a:t>FINDING 4 — THE ROBUST RESULT</a:t>
             </a:r>
           </a:p>
         </p:txBody>
@@ -6782,13 +6782,13 @@
           <a:p>
             <a:pPr algn="l"/>
             <a:r>
-              <a:rPr sz="2600" b="1">
+              <a:rPr sz="2400" b="1">
                 <a:solidFill>
                   <a:srgbClr val="1A1A2E"/>
                 </a:solidFill>
                 <a:latin typeface="Calibri"/>
               </a:rPr>
-              <a:t>The real result: individual neurons change their firing at 50 Hz</a:t>
+              <a:t>Frequency-specific single-unit rate modulation at 50 Hz</a:t>
             </a:r>
           </a:p>
         </p:txBody>
@@ -6825,8 +6825,8 @@
         </p:nvSpPr>
         <p:spPr>
           <a:xfrm>
-            <a:off x="0" y="6080760"/>
-            <a:ext cx="12191695" cy="777240"/>
+            <a:off x="0" y="6035040"/>
+            <a:ext cx="12191695" cy="822960"/>
           </a:xfrm>
           <a:prstGeom prst="rect">
             <a:avLst/>
@@ -6868,8 +6868,8 @@
         </p:nvSpPr>
         <p:spPr>
           <a:xfrm>
-            <a:off x="548640" y="6108192"/>
-            <a:ext cx="11094415" cy="731520"/>
+            <a:off x="548640" y="6062472"/>
+            <a:ext cx="11094415" cy="777240"/>
           </a:xfrm>
           <a:prstGeom prst="rect">
             <a:avLst/>
@@ -6884,13 +6884,13 @@
           <a:p>
             <a:pPr algn="l"/>
             <a:r>
-              <a:rPr sz="1600" b="1">
+              <a:rPr sz="1500" b="1">
                 <a:solidFill>
                   <a:srgbClr val="1C6E8C"/>
                 </a:solidFill>
                 <a:latin typeface="Calibri"/>
               </a:rPr>
-              <a:t>Single neurons fire differently during the 50 Hz buzz — in BOTH regions. Equipment hum can't fake a neuron firing.</a:t>
+              <a:t>Sorted single units change firing rate during 50 Hz / high-amplitude stimulation, in both regions — an effect electrical pickup cannot produce.</a:t>
             </a:r>
           </a:p>
         </p:txBody>
@@ -6986,7 +6986,7 @@
                 </a:solidFill>
                 <a:latin typeface="Calibri"/>
               </a:rPr>
-              <a:t>CONCEPT · ANALOGY</a:t>
+              <a:t>CONTROLS</a:t>
             </a:r>
           </a:p>
         </p:txBody>
@@ -7015,13 +7015,13 @@
           <a:p>
             <a:pPr algn="l"/>
             <a:r>
-              <a:rPr sz="2600" b="1">
+              <a:rPr sz="2400" b="1">
                 <a:solidFill>
                   <a:srgbClr val="1A1A2E"/>
                 </a:solidFill>
                 <a:latin typeface="Calibri"/>
               </a:rPr>
-              <a:t>How do we KNOW it's neurons and not the machine? Two filters</a:t>
+              <a:t>Controls: high-pass separation + autocorrelogram / ISI screens</a:t>
             </a:r>
           </a:p>
         </p:txBody>
@@ -7058,8 +7058,8 @@
         </p:nvSpPr>
         <p:spPr>
           <a:xfrm>
-            <a:off x="0" y="6080760"/>
-            <a:ext cx="12191695" cy="777240"/>
+            <a:off x="0" y="6035040"/>
+            <a:ext cx="12191695" cy="822960"/>
           </a:xfrm>
           <a:prstGeom prst="rect">
             <a:avLst/>
@@ -7101,8 +7101,8 @@
         </p:nvSpPr>
         <p:spPr>
           <a:xfrm>
-            <a:off x="548640" y="6108192"/>
-            <a:ext cx="11094415" cy="731520"/>
+            <a:off x="548640" y="6062472"/>
+            <a:ext cx="11094415" cy="777240"/>
           </a:xfrm>
           <a:prstGeom prst="rect">
             <a:avLst/>
@@ -7117,13 +7117,13 @@
           <a:p>
             <a:pPr algn="l"/>
             <a:r>
-              <a:rPr sz="1600" b="1">
+              <a:rPr sz="1500" b="1">
                 <a:solidFill>
                   <a:srgbClr val="1C6E8C"/>
                 </a:solidFill>
                 <a:latin typeface="Calibri"/>
               </a:rPr>
-              <a:t>(1) Strip out the slow hum to find the sharp spikes.   (2) Check the neuron isn't 'ticking like a clock' at 50 Hz.</a:t>
+              <a:t>Spikes are detected &gt;~300 Hz (50 Hz pickup is removed pre-detection); units show no stimulus-locked 50 Hz periodicity and no ON-rise in refractory violations.</a:t>
             </a:r>
           </a:p>
         </p:txBody>
@@ -7219,7 +7219,7 @@
                 </a:solidFill>
                 <a:latin typeface="Calibri"/>
               </a:rPr>
-              <a:t>FINDING 4B · ANALOGY</a:t>
+              <a:t>FINDING 5</a:t>
             </a:r>
           </a:p>
         </p:txBody>
@@ -7248,13 +7248,13 @@
           <a:p>
             <a:pPr algn="l"/>
             <a:r>
-              <a:rPr sz="2600" b="1">
+              <a:rPr sz="2400" b="1">
                 <a:solidFill>
                   <a:srgbClr val="1A1A2E"/>
                 </a:solidFill>
                 <a:latin typeface="Calibri"/>
               </a:rPr>
-              <a:t>Same buzz, opposite reactions — the brain is PROCESSING, not echoing</a:t>
+              <a:t>Region-specific, bidirectional modulation — not a passive relay</a:t>
             </a:r>
           </a:p>
         </p:txBody>
@@ -7291,8 +7291,8 @@
         </p:nvSpPr>
         <p:spPr>
           <a:xfrm>
-            <a:off x="0" y="6080760"/>
-            <a:ext cx="12191695" cy="777240"/>
+            <a:off x="0" y="6035040"/>
+            <a:ext cx="12191695" cy="822960"/>
           </a:xfrm>
           <a:prstGeom prst="rect">
             <a:avLst/>
@@ -7334,8 +7334,8 @@
         </p:nvSpPr>
         <p:spPr>
           <a:xfrm>
-            <a:off x="548640" y="6108192"/>
-            <a:ext cx="11094415" cy="731520"/>
+            <a:off x="548640" y="6062472"/>
+            <a:ext cx="11094415" cy="777240"/>
           </a:xfrm>
           <a:prstGeom prst="rect">
             <a:avLst/>
@@ -7350,13 +7350,13 @@
           <a:p>
             <a:pPr algn="l"/>
             <a:r>
-              <a:rPr sz="1600" b="1">
+              <a:rPr sz="1500" b="1">
                 <a:solidFill>
                   <a:srgbClr val="1C6E8C"/>
                 </a:solidFill>
                 <a:latin typeface="Calibri"/>
               </a:rPr>
-              <a:t>One region revs a subset of cells UP; the other quiets DOWN. A passive echo would look the same everywhere.</a:t>
+              <a:t>Hippocampus: a driven-up subset. Entorhinal cortex: net-suppressed. Opposite transformations of identical input argue for active, circuit-specific processing.</a:t>
             </a:r>
           </a:p>
         </p:txBody>
@@ -7452,7 +7452,7 @@
                 </a:solidFill>
                 <a:latin typeface="Calibri"/>
               </a:rPr>
-              <a:t>FINDING 5 · ANALOGY</a:t>
+              <a:t>FINDING 6</a:t>
             </a:r>
           </a:p>
         </p:txBody>
@@ -7481,13 +7481,13 @@
           <a:p>
             <a:pPr algn="l"/>
             <a:r>
-              <a:rPr sz="2600" b="1">
+              <a:rPr sz="2400" b="1">
                 <a:solidFill>
                   <a:srgbClr val="1A1A2E"/>
                 </a:solidFill>
                 <a:latin typeface="Calibri"/>
               </a:rPr>
-              <a:t>Do the two regions 'work together' at 50 Hz? Not clearly</a:t>
+              <a:t>No clear cross-regional coordination at 50 Hz</a:t>
             </a:r>
           </a:p>
         </p:txBody>
@@ -7524,8 +7524,8 @@
         </p:nvSpPr>
         <p:spPr>
           <a:xfrm>
-            <a:off x="0" y="6080760"/>
-            <a:ext cx="12191695" cy="777240"/>
+            <a:off x="0" y="6035040"/>
+            <a:ext cx="12191695" cy="822960"/>
           </a:xfrm>
           <a:prstGeom prst="rect">
             <a:avLst/>
@@ -7567,8 +7567,8 @@
         </p:nvSpPr>
         <p:spPr>
           <a:xfrm>
-            <a:off x="548640" y="6108192"/>
-            <a:ext cx="11094415" cy="731520"/>
+            <a:off x="548640" y="6062472"/>
+            <a:ext cx="11094415" cy="777240"/>
           </a:xfrm>
           <a:prstGeom prst="rect">
             <a:avLst/>
@@ -7583,13 +7583,13 @@
           <a:p>
             <a:pPr algn="l"/>
             <a:r>
-              <a:rPr sz="1600" b="1">
+              <a:rPr sz="1500" b="1">
                 <a:solidFill>
                   <a:srgbClr val="1C6E8C"/>
                 </a:solidFill>
                 <a:latin typeface="Calibri"/>
               </a:rPr>
-              <a:t>Two orchestras can SOUND synced because of a hallway metronome (a shared hum) — not because they play together.</a:t>
+              <a:t>LFP–LFP coherence rises, but the artifact-resistant cross-region spike–field measure does not — parsimoniously a shared signal, not interaction.</a:t>
             </a:r>
           </a:p>
         </p:txBody>
@@ -7679,13 +7679,13 @@
           <a:p>
             <a:pPr algn="l"/>
             <a:r>
-              <a:rPr sz="2600" b="1">
+              <a:rPr sz="2400" b="1">
                 <a:solidFill>
                   <a:srgbClr val="1A1A2E"/>
                 </a:solidFill>
                 <a:latin typeface="Calibri"/>
               </a:rPr>
-              <a:t>The dream: wearables that gently 'nudge' the brain through touch</a:t>
+              <a:t>Motivation: peripheral routes to non-invasive neuromodulation</a:t>
             </a:r>
           </a:p>
         </p:txBody>
@@ -7698,8 +7698,8 @@
         </p:nvSpPr>
         <p:spPr>
           <a:xfrm>
-            <a:off x="0" y="6080760"/>
-            <a:ext cx="12191695" cy="777240"/>
+            <a:off x="0" y="6035040"/>
+            <a:ext cx="12191695" cy="822960"/>
           </a:xfrm>
           <a:prstGeom prst="rect">
             <a:avLst/>
@@ -7741,8 +7741,8 @@
         </p:nvSpPr>
         <p:spPr>
           <a:xfrm>
-            <a:off x="548640" y="6108192"/>
-            <a:ext cx="11094415" cy="731520"/>
+            <a:off x="548640" y="6062472"/>
+            <a:ext cx="11094415" cy="777240"/>
           </a:xfrm>
           <a:prstGeom prst="rect">
             <a:avLst/>
@@ -7757,13 +7757,13 @@
           <a:p>
             <a:pPr algn="l"/>
             <a:r>
-              <a:rPr sz="1600" b="1">
+              <a:rPr sz="1500" b="1">
                 <a:solidFill>
                   <a:srgbClr val="1C6E8C"/>
                 </a:solidFill>
                 <a:latin typeface="Calibri"/>
               </a:rPr>
-              <a:t>To build that, we first have to answer a basic question: does a buzz on the body actually reach and change the brain?</a:t>
+              <a:t>Before targeting brain states via the skin, we need to know whether — and how — a cutaneous stimulus is represented centrally.</a:t>
             </a:r>
           </a:p>
         </p:txBody>
@@ -7853,13 +7853,13 @@
           <a:p>
             <a:pPr algn="l"/>
             <a:r>
-              <a:rPr sz="3800" b="1">
+              <a:rPr sz="3600" b="1">
                 <a:solidFill>
                   <a:srgbClr val="FFFFFF"/>
                 </a:solidFill>
                 <a:latin typeface="Calibri"/>
               </a:rPr>
-              <a:t>Part 3 — The one thing we couldn't test (and how we fix it)</a:t>
+              <a:t>Part 3 — The entrainment question, and an instrumentation limit</a:t>
             </a:r>
           </a:p>
         </p:txBody>
@@ -7955,7 +7955,7 @@
                 </a:solidFill>
                 <a:latin typeface="Calibri"/>
               </a:rPr>
-              <a:t>THE HONEST LIMIT · ANALOGY</a:t>
+              <a:t>THE LIMITATION</a:t>
             </a:r>
           </a:p>
         </p:txBody>
@@ -7984,13 +7984,13 @@
           <a:p>
             <a:pPr algn="l"/>
             <a:r>
-              <a:rPr sz="2600" b="1">
+              <a:rPr sz="2400" b="1">
                 <a:solidFill>
                   <a:srgbClr val="1A1A2E"/>
                 </a:solidFill>
                 <a:latin typeface="Calibri"/>
               </a:rPr>
-              <a:t>We could NOT test 'marching in step' — and it's not the brain's fault</a:t>
+              <a:t>Entrainment was untestable — a measurement gap, not a null</a:t>
             </a:r>
           </a:p>
         </p:txBody>
@@ -8003,8 +8003,8 @@
         </p:nvSpPr>
         <p:spPr>
           <a:xfrm>
-            <a:off x="0" y="6080760"/>
-            <a:ext cx="12191695" cy="777240"/>
+            <a:off x="0" y="6035040"/>
+            <a:ext cx="12191695" cy="822960"/>
           </a:xfrm>
           <a:prstGeom prst="rect">
             <a:avLst/>
@@ -8046,8 +8046,8 @@
         </p:nvSpPr>
         <p:spPr>
           <a:xfrm>
-            <a:off x="548640" y="6108192"/>
-            <a:ext cx="11094415" cy="731520"/>
+            <a:off x="548640" y="6062472"/>
+            <a:ext cx="11094415" cy="777240"/>
           </a:xfrm>
           <a:prstGeom prst="rect">
             <a:avLst/>
@@ -8062,13 +8062,13 @@
           <a:p>
             <a:pPr algn="l"/>
             <a:r>
-              <a:rPr sz="1600" b="1">
+              <a:rPr sz="1500" b="1">
                 <a:solidFill>
                   <a:srgbClr val="1C6E8C"/>
                 </a:solidFill>
                 <a:latin typeface="Calibri"/>
               </a:rPr>
-              <a:t>It's like judging whether a dancer is on-beat when you forgot to record the music. The reference was missing.</a:t>
+              <a:t>Phase-locking to the stimulus requires a recorded, time-aligned stimulus-phase reference. We lacked one — so entrainment is untestable here, not negative.</a:t>
             </a:r>
           </a:p>
         </p:txBody>
@@ -8164,7 +8164,7 @@
                 </a:solidFill>
                 <a:latin typeface="Calibri"/>
               </a:rPr>
-              <a:t>THE DIAGNOSIS</a:t>
+              <a:t>DIAGNOSIS</a:t>
             </a:r>
           </a:p>
         </p:txBody>
@@ -8193,13 +8193,13 @@
           <a:p>
             <a:pPr algn="l"/>
             <a:r>
-              <a:rPr sz="2600" b="1">
+              <a:rPr sz="2400" b="1">
                 <a:solidFill>
                   <a:srgbClr val="1A1A2E"/>
                 </a:solidFill>
                 <a:latin typeface="Calibri"/>
               </a:rPr>
-              <a:t>Why: the wire meant to record the buzz never captured it</a:t>
+              <a:t>The digital sync channel never captured the carrier</a:t>
             </a:r>
           </a:p>
         </p:txBody>
@@ -8236,8 +8236,8 @@
         </p:nvSpPr>
         <p:spPr>
           <a:xfrm>
-            <a:off x="0" y="6080760"/>
-            <a:ext cx="12191695" cy="777240"/>
+            <a:off x="0" y="6035040"/>
+            <a:ext cx="12191695" cy="822960"/>
           </a:xfrm>
           <a:prstGeom prst="rect">
             <a:avLst/>
@@ -8279,8 +8279,8 @@
         </p:nvSpPr>
         <p:spPr>
           <a:xfrm>
-            <a:off x="548640" y="6108192"/>
-            <a:ext cx="11094415" cy="731520"/>
+            <a:off x="548640" y="6062472"/>
+            <a:ext cx="11094415" cy="777240"/>
           </a:xfrm>
           <a:prstGeom prst="rect">
             <a:avLst/>
@@ -8295,13 +8295,13 @@
           <a:p>
             <a:pPr algn="l"/>
             <a:r>
-              <a:rPr sz="1600" b="1">
+              <a:rPr sz="1500" b="1">
                 <a:solidFill>
                   <a:srgbClr val="1C6E8C"/>
                 </a:solidFill>
                 <a:latin typeface="Calibri"/>
               </a:rPr>
-              <a:t>It updated ~4×/sec while the tactor buzzed 26×/sec — like checking a hummingbird's wings 4 times a second.</a:t>
+              <a:t>The recorded sync line updated at ~4 Hz, independent of carrier (identical pulse counts at 5 vs 26 Hz; ~78 expected at 26 Hz). No phase reference exists in the data.</a:t>
             </a:r>
           </a:p>
         </p:txBody>
@@ -8376,7 +8376,7 @@
         <p:spPr>
           <a:xfrm>
             <a:off x="548640" y="411480"/>
-            <a:ext cx="11094415" cy="1005840"/>
+            <a:ext cx="11094415" cy="365760"/>
           </a:xfrm>
           <a:prstGeom prst="rect">
             <a:avLst/>
@@ -8391,20 +8391,55 @@
           <a:p>
             <a:pPr algn="l"/>
             <a:r>
-              <a:rPr sz="2600" b="1">
+              <a:rPr sz="1400" b="1">
+                <a:solidFill>
+                  <a:srgbClr val="1C6E8C"/>
+                </a:solidFill>
+                <a:latin typeface="Calibri"/>
+              </a:rPr>
+              <a:t>THE FIX</a:t>
+            </a:r>
+          </a:p>
+        </p:txBody>
+      </p:sp>
+      <p:sp>
+        <p:nvSpPr>
+          <p:cNvPr id="4" name="TextBox 3"/>
+          <p:cNvSpPr txBox="1"/>
+          <p:nvPr/>
+        </p:nvSpPr>
+        <p:spPr>
+          <a:xfrm>
+            <a:off x="548640" y="822960"/>
+            <a:ext cx="11094415" cy="1005840"/>
+          </a:xfrm>
+          <a:prstGeom prst="rect">
+            <a:avLst/>
+          </a:prstGeom>
+          <a:noFill/>
+        </p:spPr>
+        <p:txBody>
+          <a:bodyPr wrap="square" anchor="t">
+            <a:spAutoFit/>
+          </a:bodyPr>
+          <a:lstStyle/>
+          <a:p>
+            <a:pPr algn="l"/>
+            <a:r>
+              <a:rPr sz="2400" b="1">
                 <a:solidFill>
                   <a:srgbClr val="1A1A2E"/>
                 </a:solidFill>
                 <a:latin typeface="Calibri"/>
               </a:rPr>
-              <a:t>The fix is concrete — next round records the buzz properly</a:t>
+              <a:t>Fix: redundant, clock-shared stimulus references</a:t>
             </a:r>
           </a:p>
         </p:txBody>
       </p:sp>
       <p:pic>
         <p:nvPicPr>
-          <p:cNvPr id="4" name="Picture 3" descr="fix.png"/>
+          <p:cNvPr id="5" name="Picture 4" descr="fix.png"/>
           <p:cNvPicPr>
             <a:picLocks noChangeAspect="1"/>
           </p:cNvPicPr>
@@ -8418,8 +8453,8 @@
         </p:blipFill>
         <p:spPr>
           <a:xfrm>
-            <a:off x="1769914" y="1554480"/>
-            <a:ext cx="8651866" cy="4343400"/>
+            <a:off x="2179739" y="1965960"/>
+            <a:ext cx="7832215" cy="3931920"/>
           </a:xfrm>
           <a:prstGeom prst="rect">
             <a:avLst/>
@@ -8428,14 +8463,14 @@
       </p:pic>
       <p:sp>
         <p:nvSpPr>
-          <p:cNvPr id="5" name="Rectangle 4"/>
+          <p:cNvPr id="6" name="Rectangle 5"/>
           <p:cNvSpPr/>
           <p:nvPr/>
         </p:nvSpPr>
         <p:spPr>
           <a:xfrm>
-            <a:off x="0" y="6080760"/>
-            <a:ext cx="12191695" cy="777240"/>
+            <a:off x="0" y="6035040"/>
+            <a:ext cx="12191695" cy="822960"/>
           </a:xfrm>
           <a:prstGeom prst="rect">
             <a:avLst/>
@@ -8471,14 +8506,14 @@
       </p:sp>
       <p:sp>
         <p:nvSpPr>
-          <p:cNvPr id="6" name="TextBox 5"/>
+          <p:cNvPr id="7" name="TextBox 6"/>
           <p:cNvSpPr txBox="1"/>
           <p:nvPr/>
         </p:nvSpPr>
         <p:spPr>
           <a:xfrm>
-            <a:off x="548640" y="6108192"/>
-            <a:ext cx="11094415" cy="731520"/>
+            <a:off x="548640" y="6062472"/>
+            <a:ext cx="11094415" cy="777240"/>
           </a:xfrm>
           <a:prstGeom prst="rect">
             <a:avLst/>
@@ -8493,13 +8528,13 @@
           <a:p>
             <a:pPr algn="l"/>
             <a:r>
-              <a:rPr sz="1600" b="1">
+              <a:rPr sz="1500" b="1">
                 <a:solidFill>
                   <a:srgbClr val="1C6E8C"/>
                 </a:solidFill>
                 <a:latin typeface="Calibri"/>
               </a:rPr>
-              <a:t>A per-cycle marker from the firmware + a tiny force sensor that measures the ACTUAL vibration, on the same clock.</a:t>
+              <a:t>Firmware per-cycle sync + a transduced force/accelerometer signal + a drive-signal copy, all on the acquisition clock — cross-checked, with pre-session verification.</a:t>
             </a:r>
           </a:p>
         </p:txBody>
@@ -8595,7 +8630,7 @@
                 </a:solidFill>
                 <a:latin typeface="Calibri"/>
               </a:rPr>
-              <a:t>TAKEAWAYS</a:t>
+              <a:t>SUMMARY</a:t>
             </a:r>
           </a:p>
         </p:txBody>
@@ -8624,13 +8659,13 @@
           <a:p>
             <a:pPr algn="l"/>
             <a:r>
-              <a:rPr sz="2600" b="1">
+              <a:rPr sz="2400" b="1">
                 <a:solidFill>
                   <a:srgbClr val="1A1A2E"/>
                 </a:solidFill>
                 <a:latin typeface="Calibri"/>
               </a:rPr>
-              <a:t>The big picture, in plain words</a:t>
+              <a:t>Summary</a:t>
             </a:r>
           </a:p>
         </p:txBody>
@@ -8643,8 +8678,8 @@
         </p:nvSpPr>
         <p:spPr>
           <a:xfrm>
-            <a:off x="0" y="6080760"/>
-            <a:ext cx="12191695" cy="777240"/>
+            <a:off x="0" y="6035040"/>
+            <a:ext cx="12191695" cy="822960"/>
           </a:xfrm>
           <a:prstGeom prst="rect">
             <a:avLst/>
@@ -8686,8 +8721,8 @@
         </p:nvSpPr>
         <p:spPr>
           <a:xfrm>
-            <a:off x="548640" y="6108192"/>
-            <a:ext cx="11094415" cy="731520"/>
+            <a:off x="548640" y="6062472"/>
+            <a:ext cx="11094415" cy="777240"/>
           </a:xfrm>
           <a:prstGeom prst="rect">
             <a:avLst/>
@@ -8702,13 +8737,13 @@
           <a:p>
             <a:pPr algn="l"/>
             <a:r>
-              <a:rPr sz="1600" b="1">
+              <a:rPr sz="1500" b="1">
                 <a:solidFill>
                   <a:srgbClr val="1C6E8C"/>
                 </a:solidFill>
                 <a:latin typeface="Calibri"/>
               </a:rPr>
-              <a:t>Buzzing the body DOES change the brain — most clearly as single-neuron activity at 50 Hz — but 'driving a brain rhythm' isn't shown yet.</a:t>
+              <a:t>Genuine central response to haptic stimulation; cleanest evidence is frequency-specific, region-specific single-unit modulation at 50 Hz; the 50 Hz LFP is largely artifact; entrainment untestable here.</a:t>
             </a:r>
           </a:p>
         </p:txBody>
@@ -8804,7 +8839,7 @@
                 </a:solidFill>
                 <a:latin typeface="Calibri"/>
               </a:rPr>
-              <a:t>THE ROAD AHEAD</a:t>
+              <a:t>IMPLICATIONS</a:t>
             </a:r>
           </a:p>
         </p:txBody>
@@ -8833,13 +8868,13 @@
           <a:p>
             <a:pPr algn="l"/>
             <a:r>
-              <a:rPr sz="2600" b="1">
+              <a:rPr sz="2400" b="1">
                 <a:solidFill>
                   <a:srgbClr val="1A1A2E"/>
                 </a:solidFill>
                 <a:latin typeface="Calibri"/>
               </a:rPr>
-              <a:t>Why it matters</a:t>
+              <a:t>Implications &amp; next step</a:t>
             </a:r>
           </a:p>
         </p:txBody>
@@ -8852,8 +8887,8 @@
         </p:nvSpPr>
         <p:spPr>
           <a:xfrm>
-            <a:off x="0" y="6080760"/>
-            <a:ext cx="12191695" cy="777240"/>
+            <a:off x="0" y="6035040"/>
+            <a:ext cx="12191695" cy="822960"/>
           </a:xfrm>
           <a:prstGeom prst="rect">
             <a:avLst/>
@@ -8895,8 +8930,8 @@
         </p:nvSpPr>
         <p:spPr>
           <a:xfrm>
-            <a:off x="548640" y="6108192"/>
-            <a:ext cx="11094415" cy="731520"/>
+            <a:off x="548640" y="6062472"/>
+            <a:ext cx="11094415" cy="777240"/>
           </a:xfrm>
           <a:prstGeom prst="rect">
             <a:avLst/>
@@ -8911,13 +8946,13 @@
           <a:p>
             <a:pPr algn="l"/>
             <a:r>
-              <a:rPr sz="1600" b="1">
+              <a:rPr sz="1500" b="1">
                 <a:solidFill>
                   <a:srgbClr val="1C6E8C"/>
                 </a:solidFill>
                 <a:latin typeface="Calibri"/>
               </a:rPr>
-              <a:t>If we can verify entrainment, we move toward wearables that gently and non-invasively steer brain states through touch.</a:t>
+              <a:t>Establishes a measurable central readout of peripheral haptic input and the controls to interpret it; with the instrumentation fix, entrainment becomes directly testable.</a:t>
             </a:r>
           </a:p>
         </p:txBody>
@@ -9050,13 +9085,13 @@
           <a:p>
             <a:pPr algn="l"/>
             <a:r>
-              <a:rPr sz="3600" b="1">
+              <a:rPr sz="3400" b="1">
                 <a:solidFill>
                   <a:srgbClr val="FFFFFF"/>
                 </a:solidFill>
                 <a:latin typeface="Calibri"/>
               </a:rPr>
-              <a:t>Thank you — questions?</a:t>
+              <a:t>Thank you — questions</a:t>
             </a:r>
           </a:p>
         </p:txBody>
@@ -9070,7 +9105,7 @@
         <p:spPr>
           <a:xfrm>
             <a:off x="914400" y="3840480"/>
-            <a:ext cx="10362895" cy="914400"/>
+            <a:ext cx="10362895" cy="1097280"/>
           </a:xfrm>
           <a:prstGeom prst="rect">
             <a:avLst/>
@@ -9085,13 +9120,13 @@
           <a:p>
             <a:pPr algn="l"/>
             <a:r>
-              <a:rPr sz="1900" b="0">
+              <a:rPr sz="1800" b="0">
                 <a:solidFill>
                   <a:srgbClr val="BFD0DA"/>
                 </a:solidFill>
                 <a:latin typeface="Calibri"/>
               </a:rPr>
-              <a:t>Happy to dig into any figure, the analogies, or the next-round design.</a:t>
+              <a:t>Happy to go into any figure, the artifact controls, or the next-round instrumentation.</a:t>
             </a:r>
           </a:p>
         </p:txBody>
@@ -9181,20 +9216,20 @@
           <a:p>
             <a:pPr algn="l"/>
             <a:r>
-              <a:rPr sz="2600" b="1">
+              <a:rPr sz="2400" b="1">
                 <a:solidFill>
                   <a:srgbClr val="1A1A2E"/>
                 </a:solidFill>
                 <a:latin typeface="Calibri"/>
               </a:rPr>
-              <a:t>The experiment, in one picture</a:t>
+              <a:t>Design: parametric haptic stimulation with simultaneous electrophysiology</a:t>
             </a:r>
           </a:p>
         </p:txBody>
       </p:sp>
       <p:pic>
         <p:nvPicPr>
-          <p:cNvPr id="4" name="Picture 3" descr="experiment.png"/>
+          <p:cNvPr id="4" name="Picture 3" descr="trial_window_diagram.png"/>
           <p:cNvPicPr>
             <a:picLocks noChangeAspect="1"/>
           </p:cNvPicPr>
@@ -9208,8 +9243,8 @@
         </p:blipFill>
         <p:spPr>
           <a:xfrm>
-            <a:off x="1416138" y="1554480"/>
-            <a:ext cx="9359418" cy="4343400"/>
+            <a:off x="1514917" y="1554480"/>
+            <a:ext cx="9161859" cy="4343400"/>
           </a:xfrm>
           <a:prstGeom prst="rect">
             <a:avLst/>
@@ -9224,8 +9259,8 @@
         </p:nvSpPr>
         <p:spPr>
           <a:xfrm>
-            <a:off x="0" y="6080760"/>
-            <a:ext cx="12191695" cy="777240"/>
+            <a:off x="0" y="6035040"/>
+            <a:ext cx="12191695" cy="822960"/>
           </a:xfrm>
           <a:prstGeom prst="rect">
             <a:avLst/>
@@ -9267,8 +9302,8 @@
         </p:nvSpPr>
         <p:spPr>
           <a:xfrm>
-            <a:off x="548640" y="6108192"/>
-            <a:ext cx="11094415" cy="731520"/>
+            <a:off x="548640" y="6062472"/>
+            <a:ext cx="11094415" cy="777240"/>
           </a:xfrm>
           <a:prstGeom prst="rect">
             <a:avLst/>
@@ -9283,13 +9318,13 @@
           <a:p>
             <a:pPr algn="l"/>
             <a:r>
-              <a:rPr sz="1600" b="1">
+              <a:rPr sz="1500" b="1">
                 <a:solidFill>
                   <a:srgbClr val="1C6E8C"/>
                 </a:solidFill>
                 <a:latin typeface="Calibri"/>
               </a:rPr>
-              <a:t>Buzz the body in 3-second bursts at different speeds; listen to the brain at the same time; repeat 200×.</a:t>
+              <a:t>3 s ON / 3 s OFF blocks across four carrier frequencies (5/10/26/50 Hz) and three amplitudes; ~200 repeats/condition; dual-region linear-probe recording.</a:t>
             </a:r>
           </a:p>
         </p:txBody>
@@ -9379,13 +9414,13 @@
           <a:p>
             <a:pPr algn="l"/>
             <a:r>
-              <a:rPr sz="2600" b="1">
+              <a:rPr sz="2400" b="1">
                 <a:solidFill>
                   <a:srgbClr val="1A1A2E"/>
                 </a:solidFill>
                 <a:latin typeface="Calibri"/>
               </a:rPr>
-              <a:t>Three questions</a:t>
+              <a:t>Three questions, increasing in strength of claim</a:t>
             </a:r>
           </a:p>
         </p:txBody>
@@ -9398,8 +9433,8 @@
         </p:nvSpPr>
         <p:spPr>
           <a:xfrm>
-            <a:off x="0" y="6080760"/>
-            <a:ext cx="12191695" cy="777240"/>
+            <a:off x="0" y="6035040"/>
+            <a:ext cx="12191695" cy="822960"/>
           </a:xfrm>
           <a:prstGeom prst="rect">
             <a:avLst/>
@@ -9441,8 +9476,8 @@
         </p:nvSpPr>
         <p:spPr>
           <a:xfrm>
-            <a:off x="548640" y="6108192"/>
-            <a:ext cx="11094415" cy="731520"/>
+            <a:off x="548640" y="6062472"/>
+            <a:ext cx="11094415" cy="777240"/>
           </a:xfrm>
           <a:prstGeom prst="rect">
             <a:avLst/>
@@ -9457,13 +9492,13 @@
           <a:p>
             <a:pPr algn="l"/>
             <a:r>
-              <a:rPr sz="1600" b="1">
+              <a:rPr sz="1500" b="1">
                 <a:solidFill>
                   <a:srgbClr val="1C6E8C"/>
                 </a:solidFill>
                 <a:latin typeface="Calibri"/>
               </a:rPr>
-              <a:t>(1) Does the brain notice?    (2) Does the buzz SPEED matter?    (3) Does the brain march in step with the buzz?</a:t>
+              <a:t>(1) Is there a central response?   (2) Is it frequency-specific?   (3) Does it entrain neural activity (phase-locking)?</a:t>
             </a:r>
           </a:p>
         </p:txBody>
@@ -9553,13 +9588,13 @@
           <a:p>
             <a:pPr algn="l"/>
             <a:r>
-              <a:rPr sz="3800" b="1">
+              <a:rPr sz="3600" b="1">
                 <a:solidFill>
                   <a:srgbClr val="FFFFFF"/>
                 </a:solidFill>
                 <a:latin typeface="Calibri"/>
               </a:rPr>
-              <a:t>Part 1 — How do you 'listen' to a brain?</a:t>
+              <a:t>Part 1 — Two readouts, two regions</a:t>
             </a:r>
           </a:p>
         </p:txBody>
@@ -9588,13 +9623,13 @@
           <a:p>
             <a:pPr algn="l"/>
             <a:r>
-              <a:rPr sz="2000" b="0">
+              <a:rPr sz="1900" b="0">
                 <a:solidFill>
                   <a:srgbClr val="D8E8EE"/>
                 </a:solidFill>
                 <a:latin typeface="Calibri"/>
               </a:rPr>
-              <a:t>Two ideas you need, both with analogies</a:t>
+              <a:t>The minimum background, with the key methodological distinction</a:t>
             </a:r>
           </a:p>
         </p:txBody>
@@ -9684,13 +9719,13 @@
           <a:p>
             <a:pPr algn="l"/>
             <a:r>
-              <a:rPr sz="2600" b="1">
+              <a:rPr sz="2400" b="1">
                 <a:solidFill>
                   <a:srgbClr val="1A1A2E"/>
                 </a:solidFill>
                 <a:latin typeface="Calibri"/>
               </a:rPr>
-              <a:t>We listened in two neighboring brain regions</a:t>
+              <a:t>Recording sites: hippocampus and entorhinal cortex</a:t>
             </a:r>
           </a:p>
         </p:txBody>
@@ -9727,8 +9762,8 @@
         </p:nvSpPr>
         <p:spPr>
           <a:xfrm>
-            <a:off x="0" y="6080760"/>
-            <a:ext cx="12191695" cy="777240"/>
+            <a:off x="0" y="6035040"/>
+            <a:ext cx="12191695" cy="822960"/>
           </a:xfrm>
           <a:prstGeom prst="rect">
             <a:avLst/>
@@ -9770,8 +9805,8 @@
         </p:nvSpPr>
         <p:spPr>
           <a:xfrm>
-            <a:off x="548640" y="6108192"/>
-            <a:ext cx="11094415" cy="731520"/>
+            <a:off x="548640" y="6062472"/>
+            <a:ext cx="11094415" cy="777240"/>
           </a:xfrm>
           <a:prstGeom prst="rect">
             <a:avLst/>
@@ -9786,13 +9821,13 @@
           <a:p>
             <a:pPr algn="l"/>
             <a:r>
-              <a:rPr sz="1600" b="1">
+              <a:rPr sz="1500" b="1">
                 <a:solidFill>
                   <a:srgbClr val="1C6E8C"/>
                 </a:solidFill>
                 <a:latin typeface="Calibri"/>
               </a:rPr>
-              <a:t>Hippocampus = the brain's inner GPS &amp; memory.   Entorhinal cortex = its main input hub. Two listening posts.</a:t>
+              <a:t>Entorhinal cortex = principal cortical input to hippocampus; hippocampus = spatial/mnemonic processing. A connected circuit, recorded simultaneously.</a:t>
             </a:r>
           </a:p>
         </p:txBody>
@@ -9888,7 +9923,7 @@
                 </a:solidFill>
                 <a:latin typeface="Calibri"/>
               </a:rPr>
-              <a:t>CONCEPT · ANALOGY</a:t>
+              <a:t>KEY METHODOLOGICAL DISTINCTION</a:t>
             </a:r>
           </a:p>
         </p:txBody>
@@ -9917,13 +9952,13 @@
           <a:p>
             <a:pPr algn="l"/>
             <a:r>
-              <a:rPr sz="2600" b="1">
+              <a:rPr sz="2400" b="1">
                 <a:solidFill>
                   <a:srgbClr val="1A1A2E"/>
                 </a:solidFill>
                 <a:latin typeface="Calibri"/>
               </a:rPr>
-              <a:t>THE key idea: a brain recording has two very different signals</a:t>
+              <a:t>One electrode yields two readouts: LFP and single-unit activity</a:t>
             </a:r>
           </a:p>
         </p:txBody>
@@ -9960,8 +9995,8 @@
         </p:nvSpPr>
         <p:spPr>
           <a:xfrm>
-            <a:off x="0" y="6080760"/>
-            <a:ext cx="12191695" cy="777240"/>
+            <a:off x="0" y="6035040"/>
+            <a:ext cx="12191695" cy="822960"/>
           </a:xfrm>
           <a:prstGeom prst="rect">
             <a:avLst/>
@@ -10003,8 +10038,8 @@
         </p:nvSpPr>
         <p:spPr>
           <a:xfrm>
-            <a:off x="548640" y="6108192"/>
-            <a:ext cx="11094415" cy="731520"/>
+            <a:off x="548640" y="6062472"/>
+            <a:ext cx="11094415" cy="777240"/>
           </a:xfrm>
           <a:prstGeom prst="rect">
             <a:avLst/>
@@ -10019,13 +10054,13 @@
           <a:p>
             <a:pPr algn="l"/>
             <a:r>
-              <a:rPr sz="1600" b="1">
+              <a:rPr sz="1500" b="1">
                 <a:solidFill>
                   <a:srgbClr val="1C6E8C"/>
                 </a:solidFill>
                 <a:latin typeface="Calibri"/>
               </a:rPr>
-              <a:t>Stadium analogy → the CROWD MURMUR (the field potential) vs. INDIVIDUAL VOICES (single neurons firing).</a:t>
+              <a:t>LFP = low-frequency aggregate field (synaptic/transmembrane currents of many cells). Spikes = action potentials of individual, sorted neurons. They differ in what can fake them.</a:t>
             </a:r>
           </a:p>
         </p:txBody>
@@ -10121,7 +10156,7 @@
                 </a:solidFill>
                 <a:latin typeface="Calibri"/>
               </a:rPr>
-              <a:t>CONCEPT</a:t>
+              <a:t>WHY IT MATTERS</a:t>
             </a:r>
           </a:p>
         </p:txBody>
@@ -10150,13 +10185,13 @@
           <a:p>
             <a:pPr algn="l"/>
             <a:r>
-              <a:rPr sz="2600" b="1">
+              <a:rPr sz="2400" b="1">
                 <a:solidFill>
                   <a:srgbClr val="1A1A2E"/>
                 </a:solidFill>
                 <a:latin typeface="Calibri"/>
               </a:rPr>
-              <a:t>Why single neurons are the gold standard</a:t>
+              <a:t>Single units are the more conservative readout</a:t>
             </a:r>
           </a:p>
         </p:txBody>
@@ -10169,8 +10204,8 @@
         </p:nvSpPr>
         <p:spPr>
           <a:xfrm>
-            <a:off x="0" y="6080760"/>
-            <a:ext cx="12191695" cy="777240"/>
+            <a:off x="0" y="6035040"/>
+            <a:ext cx="12191695" cy="822960"/>
           </a:xfrm>
           <a:prstGeom prst="rect">
             <a:avLst/>
@@ -10212,8 +10247,8 @@
         </p:nvSpPr>
         <p:spPr>
           <a:xfrm>
-            <a:off x="548640" y="6108192"/>
-            <a:ext cx="11094415" cy="731520"/>
+            <a:off x="548640" y="6062472"/>
+            <a:ext cx="11094415" cy="777240"/>
           </a:xfrm>
           <a:prstGeom prst="rect">
             <a:avLst/>
@@ -10228,13 +10263,13 @@
           <a:p>
             <a:pPr algn="l"/>
             <a:r>
-              <a:rPr sz="1600" b="1">
+              <a:rPr sz="1500" b="1">
                 <a:solidFill>
                   <a:srgbClr val="1C6E8C"/>
                 </a:solidFill>
                 <a:latin typeface="Calibri"/>
               </a:rPr>
-              <a:t>A real neuron firing is unambiguous — much harder for noise or equipment to fake than the crowd hum.</a:t>
+              <a:t>A sorted action potential is a discrete biological event; the LFP can be mimicked by volume-conducted electrical artifact. Spikes constrain interpretation far more tightly.</a:t>
             </a:r>
           </a:p>
         </p:txBody>
@@ -10324,13 +10359,13 @@
           <a:p>
             <a:pPr algn="l"/>
             <a:r>
-              <a:rPr sz="3800" b="1">
+              <a:rPr sz="3600" b="1">
                 <a:solidFill>
                   <a:srgbClr val="FFFFFF"/>
                 </a:solidFill>
                 <a:latin typeface="Calibri"/>
               </a:rPr>
-              <a:t>Part 2 — What the brain actually did</a:t>
+              <a:t>Part 2 — Results</a:t>
             </a:r>
           </a:p>
         </p:txBody>

</xml_diff>

<commit_message>
Presentation: apply Stanford color palette (Cardinal/Black/Cool Grey/Fog + secondary accents)
For a talk at Stanford: deck chrome -> Cardinal Red #8C1515 (accent bars, kickers,
takeaways, section dividers) on Stanford Black #2E2D29 (title/section bg + titles),
Cool Grey #53565A text, Fog #F4F4F4 panels. Concept figures recolored to the Stanford
secondary palette (Black, Bay teal #007C92, Poppy #E98300, Cardinal, Palo Alto green
#175E54). Data figures from results/ keep their own colors. Also elevated the
two-regions figure annotations to match register. Per identity.stanford.edu.

Co-Authored-By: Claude Opus 4.8 (1M context) <noreply@anthropic.com>
</commit_message>
<xml_diff>
--- a/presentation/haptic_brain_talk.pptx
+++ b/presentation/haptic_brain_talk.pptx
@@ -5088,7 +5088,7 @@
             <a:avLst/>
           </a:prstGeom>
           <a:solidFill>
-            <a:srgbClr val="1A1A2E"/>
+            <a:srgbClr val="2E2D29"/>
           </a:solidFill>
           <a:ln>
             <a:noFill/>
@@ -5131,7 +5131,7 @@
             <a:avLst/>
           </a:prstGeom>
           <a:solidFill>
-            <a:srgbClr val="1C6E8C"/>
+            <a:srgbClr val="8C1515"/>
           </a:solidFill>
           <a:ln>
             <a:noFill/>
@@ -5220,7 +5220,7 @@
             <a:r>
               <a:rPr sz="1800" b="0">
                 <a:solidFill>
-                  <a:srgbClr val="BFD0DA"/>
+                  <a:srgbClr val="D7D2CB"/>
                 </a:solidFill>
                 <a:latin typeface="Calibri"/>
               </a:rPr>
@@ -5255,7 +5255,7 @@
             <a:r>
               <a:rPr sz="1600" b="0">
                 <a:solidFill>
-                  <a:srgbClr val="9AA8B5"/>
+                  <a:srgbClr val="9A958C"/>
                 </a:solidFill>
                 <a:latin typeface="Calibri"/>
               </a:rPr>
@@ -5297,7 +5297,7 @@
             <a:avLst/>
           </a:prstGeom>
           <a:solidFill>
-            <a:srgbClr val="1C6E8C"/>
+            <a:srgbClr val="8C1515"/>
           </a:solidFill>
           <a:ln>
             <a:noFill/>
@@ -5351,7 +5351,7 @@
             <a:r>
               <a:rPr sz="1400" b="1">
                 <a:solidFill>
-                  <a:srgbClr val="1C6E8C"/>
+                  <a:srgbClr val="8C1515"/>
                 </a:solidFill>
                 <a:latin typeface="Calibri"/>
               </a:rPr>
@@ -5386,7 +5386,7 @@
             <a:r>
               <a:rPr sz="2400" b="1">
                 <a:solidFill>
-                  <a:srgbClr val="1A1A2E"/>
+                  <a:srgbClr val="2E2D29"/>
                 </a:solidFill>
                 <a:latin typeface="Calibri"/>
               </a:rPr>
@@ -5434,7 +5434,7 @@
             <a:avLst/>
           </a:prstGeom>
           <a:solidFill>
-            <a:srgbClr val="F2F5F7"/>
+            <a:srgbClr val="F4F4F4"/>
           </a:solidFill>
           <a:ln>
             <a:noFill/>
@@ -5488,7 +5488,7 @@
             <a:r>
               <a:rPr sz="1500" b="1">
                 <a:solidFill>
-                  <a:srgbClr val="1C6E8C"/>
+                  <a:srgbClr val="8C1515"/>
                 </a:solidFill>
                 <a:latin typeface="Calibri"/>
               </a:rPr>
@@ -5530,7 +5530,7 @@
             <a:avLst/>
           </a:prstGeom>
           <a:solidFill>
-            <a:srgbClr val="1C6E8C"/>
+            <a:srgbClr val="8C1515"/>
           </a:solidFill>
           <a:ln>
             <a:noFill/>
@@ -5584,7 +5584,7 @@
             <a:r>
               <a:rPr sz="1400" b="1">
                 <a:solidFill>
-                  <a:srgbClr val="1C6E8C"/>
+                  <a:srgbClr val="8C1515"/>
                 </a:solidFill>
                 <a:latin typeface="Calibri"/>
               </a:rPr>
@@ -5619,7 +5619,7 @@
             <a:r>
               <a:rPr sz="2400" b="1">
                 <a:solidFill>
-                  <a:srgbClr val="1A1A2E"/>
+                  <a:srgbClr val="2E2D29"/>
                 </a:solidFill>
                 <a:latin typeface="Calibri"/>
               </a:rPr>
@@ -5667,7 +5667,7 @@
             <a:avLst/>
           </a:prstGeom>
           <a:solidFill>
-            <a:srgbClr val="F2F5F7"/>
+            <a:srgbClr val="F4F4F4"/>
           </a:solidFill>
           <a:ln>
             <a:noFill/>
@@ -5721,7 +5721,7 @@
             <a:r>
               <a:rPr sz="1500" b="1">
                 <a:solidFill>
-                  <a:srgbClr val="1C6E8C"/>
+                  <a:srgbClr val="8C1515"/>
                 </a:solidFill>
                 <a:latin typeface="Calibri"/>
               </a:rPr>
@@ -5763,7 +5763,7 @@
             <a:avLst/>
           </a:prstGeom>
           <a:solidFill>
-            <a:srgbClr val="1C6E8C"/>
+            <a:srgbClr val="8C1515"/>
           </a:solidFill>
           <a:ln>
             <a:noFill/>
@@ -5817,7 +5817,7 @@
             <a:r>
               <a:rPr sz="1400" b="1">
                 <a:solidFill>
-                  <a:srgbClr val="1C6E8C"/>
+                  <a:srgbClr val="8C1515"/>
                 </a:solidFill>
                 <a:latin typeface="Calibri"/>
               </a:rPr>
@@ -5852,7 +5852,7 @@
             <a:r>
               <a:rPr sz="2400" b="1">
                 <a:solidFill>
-                  <a:srgbClr val="1A1A2E"/>
+                  <a:srgbClr val="2E2D29"/>
                 </a:solidFill>
                 <a:latin typeface="Calibri"/>
               </a:rPr>
@@ -5900,7 +5900,7 @@
             <a:avLst/>
           </a:prstGeom>
           <a:solidFill>
-            <a:srgbClr val="F2F5F7"/>
+            <a:srgbClr val="F4F4F4"/>
           </a:solidFill>
           <a:ln>
             <a:noFill/>
@@ -5954,7 +5954,7 @@
             <a:r>
               <a:rPr sz="1500" b="1">
                 <a:solidFill>
-                  <a:srgbClr val="1C6E8C"/>
+                  <a:srgbClr val="8C1515"/>
                 </a:solidFill>
                 <a:latin typeface="Calibri"/>
               </a:rPr>
@@ -5996,7 +5996,7 @@
             <a:avLst/>
           </a:prstGeom>
           <a:solidFill>
-            <a:srgbClr val="1C6E8C"/>
+            <a:srgbClr val="8C1515"/>
           </a:solidFill>
           <a:ln>
             <a:noFill/>
@@ -6050,7 +6050,7 @@
             <a:r>
               <a:rPr sz="1400" b="1">
                 <a:solidFill>
-                  <a:srgbClr val="1C6E8C"/>
+                  <a:srgbClr val="8C1515"/>
                 </a:solidFill>
                 <a:latin typeface="Calibri"/>
               </a:rPr>
@@ -6085,7 +6085,7 @@
             <a:r>
               <a:rPr sz="2400" b="1">
                 <a:solidFill>
-                  <a:srgbClr val="1A1A2E"/>
+                  <a:srgbClr val="2E2D29"/>
                 </a:solidFill>
                 <a:latin typeface="Calibri"/>
               </a:rPr>
@@ -6133,7 +6133,7 @@
             <a:avLst/>
           </a:prstGeom>
           <a:solidFill>
-            <a:srgbClr val="F2F5F7"/>
+            <a:srgbClr val="F4F4F4"/>
           </a:solidFill>
           <a:ln>
             <a:noFill/>
@@ -6187,7 +6187,7 @@
             <a:r>
               <a:rPr sz="1500" b="1">
                 <a:solidFill>
-                  <a:srgbClr val="1C6E8C"/>
+                  <a:srgbClr val="8C1515"/>
                 </a:solidFill>
                 <a:latin typeface="Calibri"/>
               </a:rPr>
@@ -6229,7 +6229,7 @@
             <a:avLst/>
           </a:prstGeom>
           <a:solidFill>
-            <a:srgbClr val="1C6E8C"/>
+            <a:srgbClr val="8C1515"/>
           </a:solidFill>
           <a:ln>
             <a:noFill/>
@@ -6283,7 +6283,7 @@
             <a:r>
               <a:rPr sz="1400" b="1">
                 <a:solidFill>
-                  <a:srgbClr val="1C6E8C"/>
+                  <a:srgbClr val="8C1515"/>
                 </a:solidFill>
                 <a:latin typeface="Calibri"/>
               </a:rPr>
@@ -6318,7 +6318,7 @@
             <a:r>
               <a:rPr sz="2400" b="1">
                 <a:solidFill>
-                  <a:srgbClr val="1A1A2E"/>
+                  <a:srgbClr val="2E2D29"/>
                 </a:solidFill>
                 <a:latin typeface="Calibri"/>
               </a:rPr>
@@ -6366,7 +6366,7 @@
             <a:avLst/>
           </a:prstGeom>
           <a:solidFill>
-            <a:srgbClr val="F2F5F7"/>
+            <a:srgbClr val="F4F4F4"/>
           </a:solidFill>
           <a:ln>
             <a:noFill/>
@@ -6420,7 +6420,7 @@
             <a:r>
               <a:rPr sz="1500" b="1">
                 <a:solidFill>
-                  <a:srgbClr val="1C6E8C"/>
+                  <a:srgbClr val="8C1515"/>
                 </a:solidFill>
                 <a:latin typeface="Calibri"/>
               </a:rPr>
@@ -6462,7 +6462,7 @@
             <a:avLst/>
           </a:prstGeom>
           <a:solidFill>
-            <a:srgbClr val="1C6E8C"/>
+            <a:srgbClr val="8C1515"/>
           </a:solidFill>
           <a:ln>
             <a:noFill/>
@@ -6516,7 +6516,7 @@
             <a:r>
               <a:rPr sz="1400" b="1">
                 <a:solidFill>
-                  <a:srgbClr val="1C6E8C"/>
+                  <a:srgbClr val="8C1515"/>
                 </a:solidFill>
                 <a:latin typeface="Calibri"/>
               </a:rPr>
@@ -6551,7 +6551,7 @@
             <a:r>
               <a:rPr sz="2400" b="1">
                 <a:solidFill>
-                  <a:srgbClr val="1A1A2E"/>
+                  <a:srgbClr val="2E2D29"/>
                 </a:solidFill>
                 <a:latin typeface="Calibri"/>
               </a:rPr>
@@ -6599,7 +6599,7 @@
             <a:avLst/>
           </a:prstGeom>
           <a:solidFill>
-            <a:srgbClr val="F2F5F7"/>
+            <a:srgbClr val="F4F4F4"/>
           </a:solidFill>
           <a:ln>
             <a:noFill/>
@@ -6653,7 +6653,7 @@
             <a:r>
               <a:rPr sz="1500" b="1">
                 <a:solidFill>
-                  <a:srgbClr val="1C6E8C"/>
+                  <a:srgbClr val="8C1515"/>
                 </a:solidFill>
                 <a:latin typeface="Calibri"/>
               </a:rPr>
@@ -6695,7 +6695,7 @@
             <a:avLst/>
           </a:prstGeom>
           <a:solidFill>
-            <a:srgbClr val="1C6E8C"/>
+            <a:srgbClr val="8C1515"/>
           </a:solidFill>
           <a:ln>
             <a:noFill/>
@@ -6749,7 +6749,7 @@
             <a:r>
               <a:rPr sz="1400" b="1">
                 <a:solidFill>
-                  <a:srgbClr val="1C6E8C"/>
+                  <a:srgbClr val="8C1515"/>
                 </a:solidFill>
                 <a:latin typeface="Calibri"/>
               </a:rPr>
@@ -6784,7 +6784,7 @@
             <a:r>
               <a:rPr sz="2400" b="1">
                 <a:solidFill>
-                  <a:srgbClr val="1A1A2E"/>
+                  <a:srgbClr val="2E2D29"/>
                 </a:solidFill>
                 <a:latin typeface="Calibri"/>
               </a:rPr>
@@ -6832,7 +6832,7 @@
             <a:avLst/>
           </a:prstGeom>
           <a:solidFill>
-            <a:srgbClr val="F2F5F7"/>
+            <a:srgbClr val="F4F4F4"/>
           </a:solidFill>
           <a:ln>
             <a:noFill/>
@@ -6886,7 +6886,7 @@
             <a:r>
               <a:rPr sz="1500" b="1">
                 <a:solidFill>
-                  <a:srgbClr val="1C6E8C"/>
+                  <a:srgbClr val="8C1515"/>
                 </a:solidFill>
                 <a:latin typeface="Calibri"/>
               </a:rPr>
@@ -6928,7 +6928,7 @@
             <a:avLst/>
           </a:prstGeom>
           <a:solidFill>
-            <a:srgbClr val="1C6E8C"/>
+            <a:srgbClr val="8C1515"/>
           </a:solidFill>
           <a:ln>
             <a:noFill/>
@@ -6982,7 +6982,7 @@
             <a:r>
               <a:rPr sz="1400" b="1">
                 <a:solidFill>
-                  <a:srgbClr val="1C6E8C"/>
+                  <a:srgbClr val="8C1515"/>
                 </a:solidFill>
                 <a:latin typeface="Calibri"/>
               </a:rPr>
@@ -7017,7 +7017,7 @@
             <a:r>
               <a:rPr sz="2400" b="1">
                 <a:solidFill>
-                  <a:srgbClr val="1A1A2E"/>
+                  <a:srgbClr val="2E2D29"/>
                 </a:solidFill>
                 <a:latin typeface="Calibri"/>
               </a:rPr>
@@ -7065,7 +7065,7 @@
             <a:avLst/>
           </a:prstGeom>
           <a:solidFill>
-            <a:srgbClr val="F2F5F7"/>
+            <a:srgbClr val="F4F4F4"/>
           </a:solidFill>
           <a:ln>
             <a:noFill/>
@@ -7119,7 +7119,7 @@
             <a:r>
               <a:rPr sz="1500" b="1">
                 <a:solidFill>
-                  <a:srgbClr val="1C6E8C"/>
+                  <a:srgbClr val="8C1515"/>
                 </a:solidFill>
                 <a:latin typeface="Calibri"/>
               </a:rPr>
@@ -7161,7 +7161,7 @@
             <a:avLst/>
           </a:prstGeom>
           <a:solidFill>
-            <a:srgbClr val="1C6E8C"/>
+            <a:srgbClr val="8C1515"/>
           </a:solidFill>
           <a:ln>
             <a:noFill/>
@@ -7215,7 +7215,7 @@
             <a:r>
               <a:rPr sz="1400" b="1">
                 <a:solidFill>
-                  <a:srgbClr val="1C6E8C"/>
+                  <a:srgbClr val="8C1515"/>
                 </a:solidFill>
                 <a:latin typeface="Calibri"/>
               </a:rPr>
@@ -7250,7 +7250,7 @@
             <a:r>
               <a:rPr sz="2400" b="1">
                 <a:solidFill>
-                  <a:srgbClr val="1A1A2E"/>
+                  <a:srgbClr val="2E2D29"/>
                 </a:solidFill>
                 <a:latin typeface="Calibri"/>
               </a:rPr>
@@ -7298,7 +7298,7 @@
             <a:avLst/>
           </a:prstGeom>
           <a:solidFill>
-            <a:srgbClr val="F2F5F7"/>
+            <a:srgbClr val="F4F4F4"/>
           </a:solidFill>
           <a:ln>
             <a:noFill/>
@@ -7352,7 +7352,7 @@
             <a:r>
               <a:rPr sz="1500" b="1">
                 <a:solidFill>
-                  <a:srgbClr val="1C6E8C"/>
+                  <a:srgbClr val="8C1515"/>
                 </a:solidFill>
                 <a:latin typeface="Calibri"/>
               </a:rPr>
@@ -7394,7 +7394,7 @@
             <a:avLst/>
           </a:prstGeom>
           <a:solidFill>
-            <a:srgbClr val="1C6E8C"/>
+            <a:srgbClr val="8C1515"/>
           </a:solidFill>
           <a:ln>
             <a:noFill/>
@@ -7448,7 +7448,7 @@
             <a:r>
               <a:rPr sz="1400" b="1">
                 <a:solidFill>
-                  <a:srgbClr val="1C6E8C"/>
+                  <a:srgbClr val="8C1515"/>
                 </a:solidFill>
                 <a:latin typeface="Calibri"/>
               </a:rPr>
@@ -7483,7 +7483,7 @@
             <a:r>
               <a:rPr sz="2400" b="1">
                 <a:solidFill>
-                  <a:srgbClr val="1A1A2E"/>
+                  <a:srgbClr val="2E2D29"/>
                 </a:solidFill>
                 <a:latin typeface="Calibri"/>
               </a:rPr>
@@ -7531,7 +7531,7 @@
             <a:avLst/>
           </a:prstGeom>
           <a:solidFill>
-            <a:srgbClr val="F2F5F7"/>
+            <a:srgbClr val="F4F4F4"/>
           </a:solidFill>
           <a:ln>
             <a:noFill/>
@@ -7585,7 +7585,7 @@
             <a:r>
               <a:rPr sz="1500" b="1">
                 <a:solidFill>
-                  <a:srgbClr val="1C6E8C"/>
+                  <a:srgbClr val="8C1515"/>
                 </a:solidFill>
                 <a:latin typeface="Calibri"/>
               </a:rPr>
@@ -7627,7 +7627,7 @@
             <a:avLst/>
           </a:prstGeom>
           <a:solidFill>
-            <a:srgbClr val="1C6E8C"/>
+            <a:srgbClr val="8C1515"/>
           </a:solidFill>
           <a:ln>
             <a:noFill/>
@@ -7681,7 +7681,7 @@
             <a:r>
               <a:rPr sz="2400" b="1">
                 <a:solidFill>
-                  <a:srgbClr val="1A1A2E"/>
+                  <a:srgbClr val="2E2D29"/>
                 </a:solidFill>
                 <a:latin typeface="Calibri"/>
               </a:rPr>
@@ -7705,7 +7705,7 @@
             <a:avLst/>
           </a:prstGeom>
           <a:solidFill>
-            <a:srgbClr val="F2F5F7"/>
+            <a:srgbClr val="F4F4F4"/>
           </a:solidFill>
           <a:ln>
             <a:noFill/>
@@ -7759,7 +7759,7 @@
             <a:r>
               <a:rPr sz="1500" b="1">
                 <a:solidFill>
-                  <a:srgbClr val="1C6E8C"/>
+                  <a:srgbClr val="8C1515"/>
                 </a:solidFill>
                 <a:latin typeface="Calibri"/>
               </a:rPr>
@@ -7801,7 +7801,7 @@
             <a:avLst/>
           </a:prstGeom>
           <a:solidFill>
-            <a:srgbClr val="1C6E8C"/>
+            <a:srgbClr val="8C1515"/>
           </a:solidFill>
           <a:ln>
             <a:noFill/>
@@ -7897,7 +7897,7 @@
             <a:avLst/>
           </a:prstGeom>
           <a:solidFill>
-            <a:srgbClr val="1C6E8C"/>
+            <a:srgbClr val="8C1515"/>
           </a:solidFill>
           <a:ln>
             <a:noFill/>
@@ -7951,7 +7951,7 @@
             <a:r>
               <a:rPr sz="1400" b="1">
                 <a:solidFill>
-                  <a:srgbClr val="1C6E8C"/>
+                  <a:srgbClr val="8C1515"/>
                 </a:solidFill>
                 <a:latin typeface="Calibri"/>
               </a:rPr>
@@ -7986,7 +7986,7 @@
             <a:r>
               <a:rPr sz="2400" b="1">
                 <a:solidFill>
-                  <a:srgbClr val="1A1A2E"/>
+                  <a:srgbClr val="2E2D29"/>
                 </a:solidFill>
                 <a:latin typeface="Calibri"/>
               </a:rPr>
@@ -8010,7 +8010,7 @@
             <a:avLst/>
           </a:prstGeom>
           <a:solidFill>
-            <a:srgbClr val="F2F5F7"/>
+            <a:srgbClr val="F4F4F4"/>
           </a:solidFill>
           <a:ln>
             <a:noFill/>
@@ -8064,7 +8064,7 @@
             <a:r>
               <a:rPr sz="1500" b="1">
                 <a:solidFill>
-                  <a:srgbClr val="1C6E8C"/>
+                  <a:srgbClr val="8C1515"/>
                 </a:solidFill>
                 <a:latin typeface="Calibri"/>
               </a:rPr>
@@ -8106,7 +8106,7 @@
             <a:avLst/>
           </a:prstGeom>
           <a:solidFill>
-            <a:srgbClr val="1C6E8C"/>
+            <a:srgbClr val="8C1515"/>
           </a:solidFill>
           <a:ln>
             <a:noFill/>
@@ -8160,7 +8160,7 @@
             <a:r>
               <a:rPr sz="1400" b="1">
                 <a:solidFill>
-                  <a:srgbClr val="1C6E8C"/>
+                  <a:srgbClr val="8C1515"/>
                 </a:solidFill>
                 <a:latin typeface="Calibri"/>
               </a:rPr>
@@ -8195,7 +8195,7 @@
             <a:r>
               <a:rPr sz="2400" b="1">
                 <a:solidFill>
-                  <a:srgbClr val="1A1A2E"/>
+                  <a:srgbClr val="2E2D29"/>
                 </a:solidFill>
                 <a:latin typeface="Calibri"/>
               </a:rPr>
@@ -8243,7 +8243,7 @@
             <a:avLst/>
           </a:prstGeom>
           <a:solidFill>
-            <a:srgbClr val="F2F5F7"/>
+            <a:srgbClr val="F4F4F4"/>
           </a:solidFill>
           <a:ln>
             <a:noFill/>
@@ -8297,7 +8297,7 @@
             <a:r>
               <a:rPr sz="1500" b="1">
                 <a:solidFill>
-                  <a:srgbClr val="1C6E8C"/>
+                  <a:srgbClr val="8C1515"/>
                 </a:solidFill>
                 <a:latin typeface="Calibri"/>
               </a:rPr>
@@ -8339,7 +8339,7 @@
             <a:avLst/>
           </a:prstGeom>
           <a:solidFill>
-            <a:srgbClr val="1C6E8C"/>
+            <a:srgbClr val="8C1515"/>
           </a:solidFill>
           <a:ln>
             <a:noFill/>
@@ -8393,7 +8393,7 @@
             <a:r>
               <a:rPr sz="1400" b="1">
                 <a:solidFill>
-                  <a:srgbClr val="1C6E8C"/>
+                  <a:srgbClr val="8C1515"/>
                 </a:solidFill>
                 <a:latin typeface="Calibri"/>
               </a:rPr>
@@ -8428,7 +8428,7 @@
             <a:r>
               <a:rPr sz="2400" b="1">
                 <a:solidFill>
-                  <a:srgbClr val="1A1A2E"/>
+                  <a:srgbClr val="2E2D29"/>
                 </a:solidFill>
                 <a:latin typeface="Calibri"/>
               </a:rPr>
@@ -8476,7 +8476,7 @@
             <a:avLst/>
           </a:prstGeom>
           <a:solidFill>
-            <a:srgbClr val="F2F5F7"/>
+            <a:srgbClr val="F4F4F4"/>
           </a:solidFill>
           <a:ln>
             <a:noFill/>
@@ -8530,7 +8530,7 @@
             <a:r>
               <a:rPr sz="1500" b="1">
                 <a:solidFill>
-                  <a:srgbClr val="1C6E8C"/>
+                  <a:srgbClr val="8C1515"/>
                 </a:solidFill>
                 <a:latin typeface="Calibri"/>
               </a:rPr>
@@ -8572,7 +8572,7 @@
             <a:avLst/>
           </a:prstGeom>
           <a:solidFill>
-            <a:srgbClr val="1C6E8C"/>
+            <a:srgbClr val="8C1515"/>
           </a:solidFill>
           <a:ln>
             <a:noFill/>
@@ -8626,7 +8626,7 @@
             <a:r>
               <a:rPr sz="1400" b="1">
                 <a:solidFill>
-                  <a:srgbClr val="1C6E8C"/>
+                  <a:srgbClr val="8C1515"/>
                 </a:solidFill>
                 <a:latin typeface="Calibri"/>
               </a:rPr>
@@ -8661,7 +8661,7 @@
             <a:r>
               <a:rPr sz="2400" b="1">
                 <a:solidFill>
-                  <a:srgbClr val="1A1A2E"/>
+                  <a:srgbClr val="2E2D29"/>
                 </a:solidFill>
                 <a:latin typeface="Calibri"/>
               </a:rPr>
@@ -8685,7 +8685,7 @@
             <a:avLst/>
           </a:prstGeom>
           <a:solidFill>
-            <a:srgbClr val="F2F5F7"/>
+            <a:srgbClr val="F4F4F4"/>
           </a:solidFill>
           <a:ln>
             <a:noFill/>
@@ -8739,7 +8739,7 @@
             <a:r>
               <a:rPr sz="1500" b="1">
                 <a:solidFill>
-                  <a:srgbClr val="1C6E8C"/>
+                  <a:srgbClr val="8C1515"/>
                 </a:solidFill>
                 <a:latin typeface="Calibri"/>
               </a:rPr>
@@ -8781,7 +8781,7 @@
             <a:avLst/>
           </a:prstGeom>
           <a:solidFill>
-            <a:srgbClr val="1C6E8C"/>
+            <a:srgbClr val="8C1515"/>
           </a:solidFill>
           <a:ln>
             <a:noFill/>
@@ -8835,7 +8835,7 @@
             <a:r>
               <a:rPr sz="1400" b="1">
                 <a:solidFill>
-                  <a:srgbClr val="1C6E8C"/>
+                  <a:srgbClr val="8C1515"/>
                 </a:solidFill>
                 <a:latin typeface="Calibri"/>
               </a:rPr>
@@ -8870,7 +8870,7 @@
             <a:r>
               <a:rPr sz="2400" b="1">
                 <a:solidFill>
-                  <a:srgbClr val="1A1A2E"/>
+                  <a:srgbClr val="2E2D29"/>
                 </a:solidFill>
                 <a:latin typeface="Calibri"/>
               </a:rPr>
@@ -8894,7 +8894,7 @@
             <a:avLst/>
           </a:prstGeom>
           <a:solidFill>
-            <a:srgbClr val="F2F5F7"/>
+            <a:srgbClr val="F4F4F4"/>
           </a:solidFill>
           <a:ln>
             <a:noFill/>
@@ -8948,7 +8948,7 @@
             <a:r>
               <a:rPr sz="1500" b="1">
                 <a:solidFill>
-                  <a:srgbClr val="1C6E8C"/>
+                  <a:srgbClr val="8C1515"/>
                 </a:solidFill>
                 <a:latin typeface="Calibri"/>
               </a:rPr>
@@ -8990,7 +8990,7 @@
             <a:avLst/>
           </a:prstGeom>
           <a:solidFill>
-            <a:srgbClr val="1A1A2E"/>
+            <a:srgbClr val="2E2D29"/>
           </a:solidFill>
           <a:ln>
             <a:noFill/>
@@ -9033,7 +9033,7 @@
             <a:avLst/>
           </a:prstGeom>
           <a:solidFill>
-            <a:srgbClr val="1C6E8C"/>
+            <a:srgbClr val="8C1515"/>
           </a:solidFill>
           <a:ln>
             <a:noFill/>
@@ -9122,7 +9122,7 @@
             <a:r>
               <a:rPr sz="1800" b="0">
                 <a:solidFill>
-                  <a:srgbClr val="BFD0DA"/>
+                  <a:srgbClr val="D7D2CB"/>
                 </a:solidFill>
                 <a:latin typeface="Calibri"/>
               </a:rPr>
@@ -9164,7 +9164,7 @@
             <a:avLst/>
           </a:prstGeom>
           <a:solidFill>
-            <a:srgbClr val="1C6E8C"/>
+            <a:srgbClr val="8C1515"/>
           </a:solidFill>
           <a:ln>
             <a:noFill/>
@@ -9218,7 +9218,7 @@
             <a:r>
               <a:rPr sz="2400" b="1">
                 <a:solidFill>
-                  <a:srgbClr val="1A1A2E"/>
+                  <a:srgbClr val="2E2D29"/>
                 </a:solidFill>
                 <a:latin typeface="Calibri"/>
               </a:rPr>
@@ -9266,7 +9266,7 @@
             <a:avLst/>
           </a:prstGeom>
           <a:solidFill>
-            <a:srgbClr val="F2F5F7"/>
+            <a:srgbClr val="F4F4F4"/>
           </a:solidFill>
           <a:ln>
             <a:noFill/>
@@ -9320,7 +9320,7 @@
             <a:r>
               <a:rPr sz="1500" b="1">
                 <a:solidFill>
-                  <a:srgbClr val="1C6E8C"/>
+                  <a:srgbClr val="8C1515"/>
                 </a:solidFill>
                 <a:latin typeface="Calibri"/>
               </a:rPr>
@@ -9362,7 +9362,7 @@
             <a:avLst/>
           </a:prstGeom>
           <a:solidFill>
-            <a:srgbClr val="1C6E8C"/>
+            <a:srgbClr val="8C1515"/>
           </a:solidFill>
           <a:ln>
             <a:noFill/>
@@ -9416,7 +9416,7 @@
             <a:r>
               <a:rPr sz="2400" b="1">
                 <a:solidFill>
-                  <a:srgbClr val="1A1A2E"/>
+                  <a:srgbClr val="2E2D29"/>
                 </a:solidFill>
                 <a:latin typeface="Calibri"/>
               </a:rPr>
@@ -9440,7 +9440,7 @@
             <a:avLst/>
           </a:prstGeom>
           <a:solidFill>
-            <a:srgbClr val="F2F5F7"/>
+            <a:srgbClr val="F4F4F4"/>
           </a:solidFill>
           <a:ln>
             <a:noFill/>
@@ -9494,7 +9494,7 @@
             <a:r>
               <a:rPr sz="1500" b="1">
                 <a:solidFill>
-                  <a:srgbClr val="1C6E8C"/>
+                  <a:srgbClr val="8C1515"/>
                 </a:solidFill>
                 <a:latin typeface="Calibri"/>
               </a:rPr>
@@ -9536,7 +9536,7 @@
             <a:avLst/>
           </a:prstGeom>
           <a:solidFill>
-            <a:srgbClr val="1C6E8C"/>
+            <a:srgbClr val="8C1515"/>
           </a:solidFill>
           <a:ln>
             <a:noFill/>
@@ -9625,7 +9625,7 @@
             <a:r>
               <a:rPr sz="1900" b="0">
                 <a:solidFill>
-                  <a:srgbClr val="D8E8EE"/>
+                  <a:srgbClr val="EDDDDD"/>
                 </a:solidFill>
                 <a:latin typeface="Calibri"/>
               </a:rPr>
@@ -9667,7 +9667,7 @@
             <a:avLst/>
           </a:prstGeom>
           <a:solidFill>
-            <a:srgbClr val="1C6E8C"/>
+            <a:srgbClr val="8C1515"/>
           </a:solidFill>
           <a:ln>
             <a:noFill/>
@@ -9721,7 +9721,7 @@
             <a:r>
               <a:rPr sz="2400" b="1">
                 <a:solidFill>
-                  <a:srgbClr val="1A1A2E"/>
+                  <a:srgbClr val="2E2D29"/>
                 </a:solidFill>
                 <a:latin typeface="Calibri"/>
               </a:rPr>
@@ -9769,7 +9769,7 @@
             <a:avLst/>
           </a:prstGeom>
           <a:solidFill>
-            <a:srgbClr val="F2F5F7"/>
+            <a:srgbClr val="F4F4F4"/>
           </a:solidFill>
           <a:ln>
             <a:noFill/>
@@ -9823,7 +9823,7 @@
             <a:r>
               <a:rPr sz="1500" b="1">
                 <a:solidFill>
-                  <a:srgbClr val="1C6E8C"/>
+                  <a:srgbClr val="8C1515"/>
                 </a:solidFill>
                 <a:latin typeface="Calibri"/>
               </a:rPr>
@@ -9865,7 +9865,7 @@
             <a:avLst/>
           </a:prstGeom>
           <a:solidFill>
-            <a:srgbClr val="1C6E8C"/>
+            <a:srgbClr val="8C1515"/>
           </a:solidFill>
           <a:ln>
             <a:noFill/>
@@ -9919,7 +9919,7 @@
             <a:r>
               <a:rPr sz="1400" b="1">
                 <a:solidFill>
-                  <a:srgbClr val="1C6E8C"/>
+                  <a:srgbClr val="8C1515"/>
                 </a:solidFill>
                 <a:latin typeface="Calibri"/>
               </a:rPr>
@@ -9954,7 +9954,7 @@
             <a:r>
               <a:rPr sz="2400" b="1">
                 <a:solidFill>
-                  <a:srgbClr val="1A1A2E"/>
+                  <a:srgbClr val="2E2D29"/>
                 </a:solidFill>
                 <a:latin typeface="Calibri"/>
               </a:rPr>
@@ -10002,7 +10002,7 @@
             <a:avLst/>
           </a:prstGeom>
           <a:solidFill>
-            <a:srgbClr val="F2F5F7"/>
+            <a:srgbClr val="F4F4F4"/>
           </a:solidFill>
           <a:ln>
             <a:noFill/>
@@ -10056,7 +10056,7 @@
             <a:r>
               <a:rPr sz="1500" b="1">
                 <a:solidFill>
-                  <a:srgbClr val="1C6E8C"/>
+                  <a:srgbClr val="8C1515"/>
                 </a:solidFill>
                 <a:latin typeface="Calibri"/>
               </a:rPr>
@@ -10098,7 +10098,7 @@
             <a:avLst/>
           </a:prstGeom>
           <a:solidFill>
-            <a:srgbClr val="1C6E8C"/>
+            <a:srgbClr val="8C1515"/>
           </a:solidFill>
           <a:ln>
             <a:noFill/>
@@ -10152,7 +10152,7 @@
             <a:r>
               <a:rPr sz="1400" b="1">
                 <a:solidFill>
-                  <a:srgbClr val="1C6E8C"/>
+                  <a:srgbClr val="8C1515"/>
                 </a:solidFill>
                 <a:latin typeface="Calibri"/>
               </a:rPr>
@@ -10187,7 +10187,7 @@
             <a:r>
               <a:rPr sz="2400" b="1">
                 <a:solidFill>
-                  <a:srgbClr val="1A1A2E"/>
+                  <a:srgbClr val="2E2D29"/>
                 </a:solidFill>
                 <a:latin typeface="Calibri"/>
               </a:rPr>
@@ -10211,7 +10211,7 @@
             <a:avLst/>
           </a:prstGeom>
           <a:solidFill>
-            <a:srgbClr val="F2F5F7"/>
+            <a:srgbClr val="F4F4F4"/>
           </a:solidFill>
           <a:ln>
             <a:noFill/>
@@ -10265,7 +10265,7 @@
             <a:r>
               <a:rPr sz="1500" b="1">
                 <a:solidFill>
-                  <a:srgbClr val="1C6E8C"/>
+                  <a:srgbClr val="8C1515"/>
                 </a:solidFill>
                 <a:latin typeface="Calibri"/>
               </a:rPr>
@@ -10307,7 +10307,7 @@
             <a:avLst/>
           </a:prstGeom>
           <a:solidFill>
-            <a:srgbClr val="1C6E8C"/>
+            <a:srgbClr val="8C1515"/>
           </a:solidFill>
           <a:ln>
             <a:noFill/>

</xml_diff>

<commit_message>
Presentation: SOM logo + Snyder×Buzsáki credit + page numbers (pptx & pdf)
- Stanford School of Medicine white logo on title/section/closing slides (both builders).
- Title footer credits 'a Snyder Lab (Stanford) × Buzsaki Lab (NYU) collaboration'.
- Page numbers 'N / 26' top-right on every slide except the title (both pptx & pdf).
- Rebuilt both haptic_brain_talk.pptx and .pdf. gitignore the dropped logo folder + .DS_Store.

Co-Authored-By: Claude Opus 4.8 (1M context) <noreply@anthropic.com>
</commit_message>
<xml_diff>
--- a/presentation/haptic_brain_talk.pptx
+++ b/presentation/haptic_brain_talk.pptx
@@ -5159,9 +5159,33 @@
           </a:p>
         </p:txBody>
       </p:sp>
-      <p:sp>
-        <p:nvSpPr>
-          <p:cNvPr id="4" name="TextBox 3"/>
+      <p:pic>
+        <p:nvPicPr>
+          <p:cNvPr id="4" name="Picture 3" descr="som_logo_white.png"/>
+          <p:cNvPicPr>
+            <a:picLocks noChangeAspect="1"/>
+          </p:cNvPicPr>
+          <p:nvPr/>
+        </p:nvPicPr>
+        <p:blipFill>
+          <a:blip r:embed="rId2"/>
+          <a:stretch>
+            <a:fillRect/>
+          </a:stretch>
+        </p:blipFill>
+        <p:spPr>
+          <a:xfrm>
+            <a:off x="502920" y="457200"/>
+            <a:ext cx="3291840" cy="420624"/>
+          </a:xfrm>
+          <a:prstGeom prst="rect">
+            <a:avLst/>
+          </a:prstGeom>
+        </p:spPr>
+      </p:pic>
+      <p:sp>
+        <p:nvSpPr>
+          <p:cNvPr id="5" name="TextBox 4"/>
           <p:cNvSpPr txBox="1"/>
           <p:nvPr/>
         </p:nvSpPr>
@@ -5196,7 +5220,7 @@
       </p:sp>
       <p:sp>
         <p:nvSpPr>
-          <p:cNvPr id="5" name="TextBox 4"/>
+          <p:cNvPr id="6" name="TextBox 5"/>
           <p:cNvSpPr txBox="1"/>
           <p:nvPr/>
         </p:nvSpPr>
@@ -5231,7 +5255,7 @@
       </p:sp>
       <p:sp>
         <p:nvSpPr>
-          <p:cNvPr id="6" name="TextBox 5"/>
+          <p:cNvPr id="7" name="TextBox 6"/>
           <p:cNvSpPr txBox="1"/>
           <p:nvPr/>
         </p:nvSpPr>
@@ -5259,7 +5283,7 @@
                 </a:solidFill>
                 <a:latin typeface="Calibri"/>
               </a:rPr>
-              <a:t>Pardis Miri  ·  Buzsáki Lab  ·  haptic-stimulation electrophysiology</a:t>
+              <a:t>Pardis Miri  ·  a Snyder Lab (Stanford) × Buzsáki Lab (NYU) collaboration  ·  haptic-stimulation electrophysiology</a:t>
             </a:r>
           </a:p>
         </p:txBody>
@@ -5497,6 +5521,41 @@
           </a:p>
         </p:txBody>
       </p:sp>
+      <p:sp>
+        <p:nvSpPr>
+          <p:cNvPr id="8" name="TextBox 7"/>
+          <p:cNvSpPr txBox="1"/>
+          <p:nvPr/>
+        </p:nvSpPr>
+        <p:spPr>
+          <a:xfrm>
+            <a:off x="10545775" y="246888"/>
+            <a:ext cx="1280160" cy="365760"/>
+          </a:xfrm>
+          <a:prstGeom prst="rect">
+            <a:avLst/>
+          </a:prstGeom>
+          <a:noFill/>
+        </p:spPr>
+        <p:txBody>
+          <a:bodyPr wrap="square" anchor="t">
+            <a:spAutoFit/>
+          </a:bodyPr>
+          <a:lstStyle/>
+          <a:p>
+            <a:pPr algn="r"/>
+            <a:r>
+              <a:rPr sz="1100" b="0">
+                <a:solidFill>
+                  <a:srgbClr val="53565A"/>
+                </a:solidFill>
+                <a:latin typeface="Calibri"/>
+              </a:rPr>
+              <a:t>10 / 26</a:t>
+            </a:r>
+          </a:p>
+        </p:txBody>
+      </p:sp>
     </p:spTree>
   </p:cSld>
   <p:clrMapOvr>
@@ -5730,6 +5789,41 @@
           </a:p>
         </p:txBody>
       </p:sp>
+      <p:sp>
+        <p:nvSpPr>
+          <p:cNvPr id="8" name="TextBox 7"/>
+          <p:cNvSpPr txBox="1"/>
+          <p:nvPr/>
+        </p:nvSpPr>
+        <p:spPr>
+          <a:xfrm>
+            <a:off x="10545775" y="246888"/>
+            <a:ext cx="1280160" cy="365760"/>
+          </a:xfrm>
+          <a:prstGeom prst="rect">
+            <a:avLst/>
+          </a:prstGeom>
+          <a:noFill/>
+        </p:spPr>
+        <p:txBody>
+          <a:bodyPr wrap="square" anchor="t">
+            <a:spAutoFit/>
+          </a:bodyPr>
+          <a:lstStyle/>
+          <a:p>
+            <a:pPr algn="r"/>
+            <a:r>
+              <a:rPr sz="1100" b="0">
+                <a:solidFill>
+                  <a:srgbClr val="53565A"/>
+                </a:solidFill>
+                <a:latin typeface="Calibri"/>
+              </a:rPr>
+              <a:t>11 / 26</a:t>
+            </a:r>
+          </a:p>
+        </p:txBody>
+      </p:sp>
     </p:spTree>
   </p:cSld>
   <p:clrMapOvr>
@@ -5963,6 +6057,41 @@
           </a:p>
         </p:txBody>
       </p:sp>
+      <p:sp>
+        <p:nvSpPr>
+          <p:cNvPr id="8" name="TextBox 7"/>
+          <p:cNvSpPr txBox="1"/>
+          <p:nvPr/>
+        </p:nvSpPr>
+        <p:spPr>
+          <a:xfrm>
+            <a:off x="10545775" y="246888"/>
+            <a:ext cx="1280160" cy="365760"/>
+          </a:xfrm>
+          <a:prstGeom prst="rect">
+            <a:avLst/>
+          </a:prstGeom>
+          <a:noFill/>
+        </p:spPr>
+        <p:txBody>
+          <a:bodyPr wrap="square" anchor="t">
+            <a:spAutoFit/>
+          </a:bodyPr>
+          <a:lstStyle/>
+          <a:p>
+            <a:pPr algn="r"/>
+            <a:r>
+              <a:rPr sz="1100" b="0">
+                <a:solidFill>
+                  <a:srgbClr val="53565A"/>
+                </a:solidFill>
+                <a:latin typeface="Calibri"/>
+              </a:rPr>
+              <a:t>12 / 26</a:t>
+            </a:r>
+          </a:p>
+        </p:txBody>
+      </p:sp>
     </p:spTree>
   </p:cSld>
   <p:clrMapOvr>
@@ -6196,6 +6325,41 @@
           </a:p>
         </p:txBody>
       </p:sp>
+      <p:sp>
+        <p:nvSpPr>
+          <p:cNvPr id="8" name="TextBox 7"/>
+          <p:cNvSpPr txBox="1"/>
+          <p:nvPr/>
+        </p:nvSpPr>
+        <p:spPr>
+          <a:xfrm>
+            <a:off x="10545775" y="246888"/>
+            <a:ext cx="1280160" cy="365760"/>
+          </a:xfrm>
+          <a:prstGeom prst="rect">
+            <a:avLst/>
+          </a:prstGeom>
+          <a:noFill/>
+        </p:spPr>
+        <p:txBody>
+          <a:bodyPr wrap="square" anchor="t">
+            <a:spAutoFit/>
+          </a:bodyPr>
+          <a:lstStyle/>
+          <a:p>
+            <a:pPr algn="r"/>
+            <a:r>
+              <a:rPr sz="1100" b="0">
+                <a:solidFill>
+                  <a:srgbClr val="53565A"/>
+                </a:solidFill>
+                <a:latin typeface="Calibri"/>
+              </a:rPr>
+              <a:t>13 / 26</a:t>
+            </a:r>
+          </a:p>
+        </p:txBody>
+      </p:sp>
     </p:spTree>
   </p:cSld>
   <p:clrMapOvr>
@@ -6429,6 +6593,41 @@
           </a:p>
         </p:txBody>
       </p:sp>
+      <p:sp>
+        <p:nvSpPr>
+          <p:cNvPr id="8" name="TextBox 7"/>
+          <p:cNvSpPr txBox="1"/>
+          <p:nvPr/>
+        </p:nvSpPr>
+        <p:spPr>
+          <a:xfrm>
+            <a:off x="10545775" y="246888"/>
+            <a:ext cx="1280160" cy="365760"/>
+          </a:xfrm>
+          <a:prstGeom prst="rect">
+            <a:avLst/>
+          </a:prstGeom>
+          <a:noFill/>
+        </p:spPr>
+        <p:txBody>
+          <a:bodyPr wrap="square" anchor="t">
+            <a:spAutoFit/>
+          </a:bodyPr>
+          <a:lstStyle/>
+          <a:p>
+            <a:pPr algn="r"/>
+            <a:r>
+              <a:rPr sz="1100" b="0">
+                <a:solidFill>
+                  <a:srgbClr val="53565A"/>
+                </a:solidFill>
+                <a:latin typeface="Calibri"/>
+              </a:rPr>
+              <a:t>14 / 26</a:t>
+            </a:r>
+          </a:p>
+        </p:txBody>
+      </p:sp>
     </p:spTree>
   </p:cSld>
   <p:clrMapOvr>
@@ -6662,6 +6861,41 @@
           </a:p>
         </p:txBody>
       </p:sp>
+      <p:sp>
+        <p:nvSpPr>
+          <p:cNvPr id="8" name="TextBox 7"/>
+          <p:cNvSpPr txBox="1"/>
+          <p:nvPr/>
+        </p:nvSpPr>
+        <p:spPr>
+          <a:xfrm>
+            <a:off x="10545775" y="246888"/>
+            <a:ext cx="1280160" cy="365760"/>
+          </a:xfrm>
+          <a:prstGeom prst="rect">
+            <a:avLst/>
+          </a:prstGeom>
+          <a:noFill/>
+        </p:spPr>
+        <p:txBody>
+          <a:bodyPr wrap="square" anchor="t">
+            <a:spAutoFit/>
+          </a:bodyPr>
+          <a:lstStyle/>
+          <a:p>
+            <a:pPr algn="r"/>
+            <a:r>
+              <a:rPr sz="1100" b="0">
+                <a:solidFill>
+                  <a:srgbClr val="53565A"/>
+                </a:solidFill>
+                <a:latin typeface="Calibri"/>
+              </a:rPr>
+              <a:t>15 / 26</a:t>
+            </a:r>
+          </a:p>
+        </p:txBody>
+      </p:sp>
     </p:spTree>
   </p:cSld>
   <p:clrMapOvr>
@@ -6895,6 +7129,41 @@
           </a:p>
         </p:txBody>
       </p:sp>
+      <p:sp>
+        <p:nvSpPr>
+          <p:cNvPr id="8" name="TextBox 7"/>
+          <p:cNvSpPr txBox="1"/>
+          <p:nvPr/>
+        </p:nvSpPr>
+        <p:spPr>
+          <a:xfrm>
+            <a:off x="10545775" y="246888"/>
+            <a:ext cx="1280160" cy="365760"/>
+          </a:xfrm>
+          <a:prstGeom prst="rect">
+            <a:avLst/>
+          </a:prstGeom>
+          <a:noFill/>
+        </p:spPr>
+        <p:txBody>
+          <a:bodyPr wrap="square" anchor="t">
+            <a:spAutoFit/>
+          </a:bodyPr>
+          <a:lstStyle/>
+          <a:p>
+            <a:pPr algn="r"/>
+            <a:r>
+              <a:rPr sz="1100" b="0">
+                <a:solidFill>
+                  <a:srgbClr val="53565A"/>
+                </a:solidFill>
+                <a:latin typeface="Calibri"/>
+              </a:rPr>
+              <a:t>16 / 26</a:t>
+            </a:r>
+          </a:p>
+        </p:txBody>
+      </p:sp>
     </p:spTree>
   </p:cSld>
   <p:clrMapOvr>
@@ -7128,6 +7397,41 @@
           </a:p>
         </p:txBody>
       </p:sp>
+      <p:sp>
+        <p:nvSpPr>
+          <p:cNvPr id="8" name="TextBox 7"/>
+          <p:cNvSpPr txBox="1"/>
+          <p:nvPr/>
+        </p:nvSpPr>
+        <p:spPr>
+          <a:xfrm>
+            <a:off x="10545775" y="246888"/>
+            <a:ext cx="1280160" cy="365760"/>
+          </a:xfrm>
+          <a:prstGeom prst="rect">
+            <a:avLst/>
+          </a:prstGeom>
+          <a:noFill/>
+        </p:spPr>
+        <p:txBody>
+          <a:bodyPr wrap="square" anchor="t">
+            <a:spAutoFit/>
+          </a:bodyPr>
+          <a:lstStyle/>
+          <a:p>
+            <a:pPr algn="r"/>
+            <a:r>
+              <a:rPr sz="1100" b="0">
+                <a:solidFill>
+                  <a:srgbClr val="53565A"/>
+                </a:solidFill>
+                <a:latin typeface="Calibri"/>
+              </a:rPr>
+              <a:t>17 / 26</a:t>
+            </a:r>
+          </a:p>
+        </p:txBody>
+      </p:sp>
     </p:spTree>
   </p:cSld>
   <p:clrMapOvr>
@@ -7361,6 +7665,41 @@
           </a:p>
         </p:txBody>
       </p:sp>
+      <p:sp>
+        <p:nvSpPr>
+          <p:cNvPr id="8" name="TextBox 7"/>
+          <p:cNvSpPr txBox="1"/>
+          <p:nvPr/>
+        </p:nvSpPr>
+        <p:spPr>
+          <a:xfrm>
+            <a:off x="10545775" y="246888"/>
+            <a:ext cx="1280160" cy="365760"/>
+          </a:xfrm>
+          <a:prstGeom prst="rect">
+            <a:avLst/>
+          </a:prstGeom>
+          <a:noFill/>
+        </p:spPr>
+        <p:txBody>
+          <a:bodyPr wrap="square" anchor="t">
+            <a:spAutoFit/>
+          </a:bodyPr>
+          <a:lstStyle/>
+          <a:p>
+            <a:pPr algn="r"/>
+            <a:r>
+              <a:rPr sz="1100" b="0">
+                <a:solidFill>
+                  <a:srgbClr val="53565A"/>
+                </a:solidFill>
+                <a:latin typeface="Calibri"/>
+              </a:rPr>
+              <a:t>18 / 26</a:t>
+            </a:r>
+          </a:p>
+        </p:txBody>
+      </p:sp>
     </p:spTree>
   </p:cSld>
   <p:clrMapOvr>
@@ -7594,6 +7933,41 @@
           </a:p>
         </p:txBody>
       </p:sp>
+      <p:sp>
+        <p:nvSpPr>
+          <p:cNvPr id="8" name="TextBox 7"/>
+          <p:cNvSpPr txBox="1"/>
+          <p:nvPr/>
+        </p:nvSpPr>
+        <p:spPr>
+          <a:xfrm>
+            <a:off x="10545775" y="246888"/>
+            <a:ext cx="1280160" cy="365760"/>
+          </a:xfrm>
+          <a:prstGeom prst="rect">
+            <a:avLst/>
+          </a:prstGeom>
+          <a:noFill/>
+        </p:spPr>
+        <p:txBody>
+          <a:bodyPr wrap="square" anchor="t">
+            <a:spAutoFit/>
+          </a:bodyPr>
+          <a:lstStyle/>
+          <a:p>
+            <a:pPr algn="r"/>
+            <a:r>
+              <a:rPr sz="1100" b="0">
+                <a:solidFill>
+                  <a:srgbClr val="53565A"/>
+                </a:solidFill>
+                <a:latin typeface="Calibri"/>
+              </a:rPr>
+              <a:t>19 / 26</a:t>
+            </a:r>
+          </a:p>
+        </p:txBody>
+      </p:sp>
     </p:spTree>
   </p:cSld>
   <p:clrMapOvr>
@@ -7768,6 +8142,41 @@
           </a:p>
         </p:txBody>
       </p:sp>
+      <p:sp>
+        <p:nvSpPr>
+          <p:cNvPr id="6" name="TextBox 5"/>
+          <p:cNvSpPr txBox="1"/>
+          <p:nvPr/>
+        </p:nvSpPr>
+        <p:spPr>
+          <a:xfrm>
+            <a:off x="10545775" y="246888"/>
+            <a:ext cx="1280160" cy="365760"/>
+          </a:xfrm>
+          <a:prstGeom prst="rect">
+            <a:avLst/>
+          </a:prstGeom>
+          <a:noFill/>
+        </p:spPr>
+        <p:txBody>
+          <a:bodyPr wrap="square" anchor="t">
+            <a:spAutoFit/>
+          </a:bodyPr>
+          <a:lstStyle/>
+          <a:p>
+            <a:pPr algn="r"/>
+            <a:r>
+              <a:rPr sz="1100" b="0">
+                <a:solidFill>
+                  <a:srgbClr val="53565A"/>
+                </a:solidFill>
+                <a:latin typeface="Calibri"/>
+              </a:rPr>
+              <a:t>2 / 26</a:t>
+            </a:r>
+          </a:p>
+        </p:txBody>
+      </p:sp>
     </p:spTree>
   </p:cSld>
   <p:clrMapOvr>
@@ -7829,9 +8238,33 @@
           </a:p>
         </p:txBody>
       </p:sp>
-      <p:sp>
-        <p:nvSpPr>
-          <p:cNvPr id="3" name="TextBox 2"/>
+      <p:pic>
+        <p:nvPicPr>
+          <p:cNvPr id="3" name="Picture 2" descr="som_logo_white.png"/>
+          <p:cNvPicPr>
+            <a:picLocks noChangeAspect="1"/>
+          </p:cNvPicPr>
+          <p:nvPr/>
+        </p:nvPicPr>
+        <p:blipFill>
+          <a:blip r:embed="rId2"/>
+          <a:stretch>
+            <a:fillRect/>
+          </a:stretch>
+        </p:blipFill>
+        <p:spPr>
+          <a:xfrm>
+            <a:off x="502920" y="457200"/>
+            <a:ext cx="2651760" cy="338836"/>
+          </a:xfrm>
+          <a:prstGeom prst="rect">
+            <a:avLst/>
+          </a:prstGeom>
+        </p:spPr>
+      </p:pic>
+      <p:sp>
+        <p:nvSpPr>
+          <p:cNvPr id="4" name="TextBox 3"/>
           <p:cNvSpPr txBox="1"/>
           <p:nvPr/>
         </p:nvSpPr>
@@ -7860,6 +8293,41 @@
                 <a:latin typeface="Calibri"/>
               </a:rPr>
               <a:t>Part 3 — The entrainment question, and an instrumentation limit</a:t>
+            </a:r>
+          </a:p>
+        </p:txBody>
+      </p:sp>
+      <p:sp>
+        <p:nvSpPr>
+          <p:cNvPr id="5" name="TextBox 4"/>
+          <p:cNvSpPr txBox="1"/>
+          <p:nvPr/>
+        </p:nvSpPr>
+        <p:spPr>
+          <a:xfrm>
+            <a:off x="10545775" y="246888"/>
+            <a:ext cx="1280160" cy="365760"/>
+          </a:xfrm>
+          <a:prstGeom prst="rect">
+            <a:avLst/>
+          </a:prstGeom>
+          <a:noFill/>
+        </p:spPr>
+        <p:txBody>
+          <a:bodyPr wrap="square" anchor="t">
+            <a:spAutoFit/>
+          </a:bodyPr>
+          <a:lstStyle/>
+          <a:p>
+            <a:pPr algn="r"/>
+            <a:r>
+              <a:rPr sz="1100" b="0">
+                <a:solidFill>
+                  <a:srgbClr val="FFFFFF"/>
+                </a:solidFill>
+                <a:latin typeface="Calibri"/>
+              </a:rPr>
+              <a:t>20 / 26</a:t>
             </a:r>
           </a:p>
         </p:txBody>
@@ -8073,6 +8541,41 @@
           </a:p>
         </p:txBody>
       </p:sp>
+      <p:sp>
+        <p:nvSpPr>
+          <p:cNvPr id="7" name="TextBox 6"/>
+          <p:cNvSpPr txBox="1"/>
+          <p:nvPr/>
+        </p:nvSpPr>
+        <p:spPr>
+          <a:xfrm>
+            <a:off x="10545775" y="246888"/>
+            <a:ext cx="1280160" cy="365760"/>
+          </a:xfrm>
+          <a:prstGeom prst="rect">
+            <a:avLst/>
+          </a:prstGeom>
+          <a:noFill/>
+        </p:spPr>
+        <p:txBody>
+          <a:bodyPr wrap="square" anchor="t">
+            <a:spAutoFit/>
+          </a:bodyPr>
+          <a:lstStyle/>
+          <a:p>
+            <a:pPr algn="r"/>
+            <a:r>
+              <a:rPr sz="1100" b="0">
+                <a:solidFill>
+                  <a:srgbClr val="53565A"/>
+                </a:solidFill>
+                <a:latin typeface="Calibri"/>
+              </a:rPr>
+              <a:t>21 / 26</a:t>
+            </a:r>
+          </a:p>
+        </p:txBody>
+      </p:sp>
     </p:spTree>
   </p:cSld>
   <p:clrMapOvr>
@@ -8306,6 +8809,41 @@
           </a:p>
         </p:txBody>
       </p:sp>
+      <p:sp>
+        <p:nvSpPr>
+          <p:cNvPr id="8" name="TextBox 7"/>
+          <p:cNvSpPr txBox="1"/>
+          <p:nvPr/>
+        </p:nvSpPr>
+        <p:spPr>
+          <a:xfrm>
+            <a:off x="10545775" y="246888"/>
+            <a:ext cx="1280160" cy="365760"/>
+          </a:xfrm>
+          <a:prstGeom prst="rect">
+            <a:avLst/>
+          </a:prstGeom>
+          <a:noFill/>
+        </p:spPr>
+        <p:txBody>
+          <a:bodyPr wrap="square" anchor="t">
+            <a:spAutoFit/>
+          </a:bodyPr>
+          <a:lstStyle/>
+          <a:p>
+            <a:pPr algn="r"/>
+            <a:r>
+              <a:rPr sz="1100" b="0">
+                <a:solidFill>
+                  <a:srgbClr val="53565A"/>
+                </a:solidFill>
+                <a:latin typeface="Calibri"/>
+              </a:rPr>
+              <a:t>22 / 26</a:t>
+            </a:r>
+          </a:p>
+        </p:txBody>
+      </p:sp>
     </p:spTree>
   </p:cSld>
   <p:clrMapOvr>
@@ -8539,6 +9077,41 @@
           </a:p>
         </p:txBody>
       </p:sp>
+      <p:sp>
+        <p:nvSpPr>
+          <p:cNvPr id="8" name="TextBox 7"/>
+          <p:cNvSpPr txBox="1"/>
+          <p:nvPr/>
+        </p:nvSpPr>
+        <p:spPr>
+          <a:xfrm>
+            <a:off x="10545775" y="246888"/>
+            <a:ext cx="1280160" cy="365760"/>
+          </a:xfrm>
+          <a:prstGeom prst="rect">
+            <a:avLst/>
+          </a:prstGeom>
+          <a:noFill/>
+        </p:spPr>
+        <p:txBody>
+          <a:bodyPr wrap="square" anchor="t">
+            <a:spAutoFit/>
+          </a:bodyPr>
+          <a:lstStyle/>
+          <a:p>
+            <a:pPr algn="r"/>
+            <a:r>
+              <a:rPr sz="1100" b="0">
+                <a:solidFill>
+                  <a:srgbClr val="53565A"/>
+                </a:solidFill>
+                <a:latin typeface="Calibri"/>
+              </a:rPr>
+              <a:t>23 / 26</a:t>
+            </a:r>
+          </a:p>
+        </p:txBody>
+      </p:sp>
     </p:spTree>
   </p:cSld>
   <p:clrMapOvr>
@@ -8748,6 +9321,41 @@
           </a:p>
         </p:txBody>
       </p:sp>
+      <p:sp>
+        <p:nvSpPr>
+          <p:cNvPr id="7" name="TextBox 6"/>
+          <p:cNvSpPr txBox="1"/>
+          <p:nvPr/>
+        </p:nvSpPr>
+        <p:spPr>
+          <a:xfrm>
+            <a:off x="10545775" y="246888"/>
+            <a:ext cx="1280160" cy="365760"/>
+          </a:xfrm>
+          <a:prstGeom prst="rect">
+            <a:avLst/>
+          </a:prstGeom>
+          <a:noFill/>
+        </p:spPr>
+        <p:txBody>
+          <a:bodyPr wrap="square" anchor="t">
+            <a:spAutoFit/>
+          </a:bodyPr>
+          <a:lstStyle/>
+          <a:p>
+            <a:pPr algn="r"/>
+            <a:r>
+              <a:rPr sz="1100" b="0">
+                <a:solidFill>
+                  <a:srgbClr val="53565A"/>
+                </a:solidFill>
+                <a:latin typeface="Calibri"/>
+              </a:rPr>
+              <a:t>24 / 26</a:t>
+            </a:r>
+          </a:p>
+        </p:txBody>
+      </p:sp>
     </p:spTree>
   </p:cSld>
   <p:clrMapOvr>
@@ -8957,6 +9565,41 @@
           </a:p>
         </p:txBody>
       </p:sp>
+      <p:sp>
+        <p:nvSpPr>
+          <p:cNvPr id="7" name="TextBox 6"/>
+          <p:cNvSpPr txBox="1"/>
+          <p:nvPr/>
+        </p:nvSpPr>
+        <p:spPr>
+          <a:xfrm>
+            <a:off x="10545775" y="246888"/>
+            <a:ext cx="1280160" cy="365760"/>
+          </a:xfrm>
+          <a:prstGeom prst="rect">
+            <a:avLst/>
+          </a:prstGeom>
+          <a:noFill/>
+        </p:spPr>
+        <p:txBody>
+          <a:bodyPr wrap="square" anchor="t">
+            <a:spAutoFit/>
+          </a:bodyPr>
+          <a:lstStyle/>
+          <a:p>
+            <a:pPr algn="r"/>
+            <a:r>
+              <a:rPr sz="1100" b="0">
+                <a:solidFill>
+                  <a:srgbClr val="53565A"/>
+                </a:solidFill>
+                <a:latin typeface="Calibri"/>
+              </a:rPr>
+              <a:t>25 / 26</a:t>
+            </a:r>
+          </a:p>
+        </p:txBody>
+      </p:sp>
     </p:spTree>
   </p:cSld>
   <p:clrMapOvr>
@@ -9061,9 +9704,33 @@
           </a:p>
         </p:txBody>
       </p:sp>
-      <p:sp>
-        <p:nvSpPr>
-          <p:cNvPr id="4" name="TextBox 3"/>
+      <p:pic>
+        <p:nvPicPr>
+          <p:cNvPr id="4" name="Picture 3" descr="som_logo_white.png"/>
+          <p:cNvPicPr>
+            <a:picLocks noChangeAspect="1"/>
+          </p:cNvPicPr>
+          <p:nvPr/>
+        </p:nvPicPr>
+        <p:blipFill>
+          <a:blip r:embed="rId2"/>
+          <a:stretch>
+            <a:fillRect/>
+          </a:stretch>
+        </p:blipFill>
+        <p:spPr>
+          <a:xfrm>
+            <a:off x="502920" y="457200"/>
+            <a:ext cx="3291840" cy="420624"/>
+          </a:xfrm>
+          <a:prstGeom prst="rect">
+            <a:avLst/>
+          </a:prstGeom>
+        </p:spPr>
+      </p:pic>
+      <p:sp>
+        <p:nvSpPr>
+          <p:cNvPr id="5" name="TextBox 4"/>
           <p:cNvSpPr txBox="1"/>
           <p:nvPr/>
         </p:nvSpPr>
@@ -9098,7 +9765,7 @@
       </p:sp>
       <p:sp>
         <p:nvSpPr>
-          <p:cNvPr id="5" name="TextBox 4"/>
+          <p:cNvPr id="6" name="TextBox 5"/>
           <p:cNvSpPr txBox="1"/>
           <p:nvPr/>
         </p:nvSpPr>
@@ -9127,6 +9794,41 @@
                 <a:latin typeface="Calibri"/>
               </a:rPr>
               <a:t>Happy to go into any figure, the artifact controls, or the next-round instrumentation.</a:t>
+            </a:r>
+          </a:p>
+        </p:txBody>
+      </p:sp>
+      <p:sp>
+        <p:nvSpPr>
+          <p:cNvPr id="7" name="TextBox 6"/>
+          <p:cNvSpPr txBox="1"/>
+          <p:nvPr/>
+        </p:nvSpPr>
+        <p:spPr>
+          <a:xfrm>
+            <a:off x="10545775" y="246888"/>
+            <a:ext cx="1280160" cy="365760"/>
+          </a:xfrm>
+          <a:prstGeom prst="rect">
+            <a:avLst/>
+          </a:prstGeom>
+          <a:noFill/>
+        </p:spPr>
+        <p:txBody>
+          <a:bodyPr wrap="square" anchor="t">
+            <a:spAutoFit/>
+          </a:bodyPr>
+          <a:lstStyle/>
+          <a:p>
+            <a:pPr algn="r"/>
+            <a:r>
+              <a:rPr sz="1100" b="0">
+                <a:solidFill>
+                  <a:srgbClr val="FFFFFF"/>
+                </a:solidFill>
+                <a:latin typeface="Calibri"/>
+              </a:rPr>
+              <a:t>26 / 26</a:t>
             </a:r>
           </a:p>
         </p:txBody>
@@ -9329,6 +10031,41 @@
           </a:p>
         </p:txBody>
       </p:sp>
+      <p:sp>
+        <p:nvSpPr>
+          <p:cNvPr id="7" name="TextBox 6"/>
+          <p:cNvSpPr txBox="1"/>
+          <p:nvPr/>
+        </p:nvSpPr>
+        <p:spPr>
+          <a:xfrm>
+            <a:off x="10545775" y="246888"/>
+            <a:ext cx="1280160" cy="365760"/>
+          </a:xfrm>
+          <a:prstGeom prst="rect">
+            <a:avLst/>
+          </a:prstGeom>
+          <a:noFill/>
+        </p:spPr>
+        <p:txBody>
+          <a:bodyPr wrap="square" anchor="t">
+            <a:spAutoFit/>
+          </a:bodyPr>
+          <a:lstStyle/>
+          <a:p>
+            <a:pPr algn="r"/>
+            <a:r>
+              <a:rPr sz="1100" b="0">
+                <a:solidFill>
+                  <a:srgbClr val="53565A"/>
+                </a:solidFill>
+                <a:latin typeface="Calibri"/>
+              </a:rPr>
+              <a:t>3 / 26</a:t>
+            </a:r>
+          </a:p>
+        </p:txBody>
+      </p:sp>
     </p:spTree>
   </p:cSld>
   <p:clrMapOvr>
@@ -9503,6 +10240,41 @@
           </a:p>
         </p:txBody>
       </p:sp>
+      <p:sp>
+        <p:nvSpPr>
+          <p:cNvPr id="6" name="TextBox 5"/>
+          <p:cNvSpPr txBox="1"/>
+          <p:nvPr/>
+        </p:nvSpPr>
+        <p:spPr>
+          <a:xfrm>
+            <a:off x="10545775" y="246888"/>
+            <a:ext cx="1280160" cy="365760"/>
+          </a:xfrm>
+          <a:prstGeom prst="rect">
+            <a:avLst/>
+          </a:prstGeom>
+          <a:noFill/>
+        </p:spPr>
+        <p:txBody>
+          <a:bodyPr wrap="square" anchor="t">
+            <a:spAutoFit/>
+          </a:bodyPr>
+          <a:lstStyle/>
+          <a:p>
+            <a:pPr algn="r"/>
+            <a:r>
+              <a:rPr sz="1100" b="0">
+                <a:solidFill>
+                  <a:srgbClr val="53565A"/>
+                </a:solidFill>
+                <a:latin typeface="Calibri"/>
+              </a:rPr>
+              <a:t>4 / 26</a:t>
+            </a:r>
+          </a:p>
+        </p:txBody>
+      </p:sp>
     </p:spTree>
   </p:cSld>
   <p:clrMapOvr>
@@ -9564,9 +10336,33 @@
           </a:p>
         </p:txBody>
       </p:sp>
-      <p:sp>
-        <p:nvSpPr>
-          <p:cNvPr id="3" name="TextBox 2"/>
+      <p:pic>
+        <p:nvPicPr>
+          <p:cNvPr id="3" name="Picture 2" descr="som_logo_white.png"/>
+          <p:cNvPicPr>
+            <a:picLocks noChangeAspect="1"/>
+          </p:cNvPicPr>
+          <p:nvPr/>
+        </p:nvPicPr>
+        <p:blipFill>
+          <a:blip r:embed="rId2"/>
+          <a:stretch>
+            <a:fillRect/>
+          </a:stretch>
+        </p:blipFill>
+        <p:spPr>
+          <a:xfrm>
+            <a:off x="502920" y="457200"/>
+            <a:ext cx="2651760" cy="338836"/>
+          </a:xfrm>
+          <a:prstGeom prst="rect">
+            <a:avLst/>
+          </a:prstGeom>
+        </p:spPr>
+      </p:pic>
+      <p:sp>
+        <p:nvSpPr>
+          <p:cNvPr id="4" name="TextBox 3"/>
           <p:cNvSpPr txBox="1"/>
           <p:nvPr/>
         </p:nvSpPr>
@@ -9601,7 +10397,7 @@
       </p:sp>
       <p:sp>
         <p:nvSpPr>
-          <p:cNvPr id="4" name="TextBox 3"/>
+          <p:cNvPr id="5" name="TextBox 4"/>
           <p:cNvSpPr txBox="1"/>
           <p:nvPr/>
         </p:nvSpPr>
@@ -9630,6 +10426,41 @@
                 <a:latin typeface="Calibri"/>
               </a:rPr>
               <a:t>The minimum background, with the key methodological distinction</a:t>
+            </a:r>
+          </a:p>
+        </p:txBody>
+      </p:sp>
+      <p:sp>
+        <p:nvSpPr>
+          <p:cNvPr id="6" name="TextBox 5"/>
+          <p:cNvSpPr txBox="1"/>
+          <p:nvPr/>
+        </p:nvSpPr>
+        <p:spPr>
+          <a:xfrm>
+            <a:off x="10545775" y="246888"/>
+            <a:ext cx="1280160" cy="365760"/>
+          </a:xfrm>
+          <a:prstGeom prst="rect">
+            <a:avLst/>
+          </a:prstGeom>
+          <a:noFill/>
+        </p:spPr>
+        <p:txBody>
+          <a:bodyPr wrap="square" anchor="t">
+            <a:spAutoFit/>
+          </a:bodyPr>
+          <a:lstStyle/>
+          <a:p>
+            <a:pPr algn="r"/>
+            <a:r>
+              <a:rPr sz="1100" b="0">
+                <a:solidFill>
+                  <a:srgbClr val="FFFFFF"/>
+                </a:solidFill>
+                <a:latin typeface="Calibri"/>
+              </a:rPr>
+              <a:t>5 / 26</a:t>
             </a:r>
           </a:p>
         </p:txBody>
@@ -9832,6 +10663,41 @@
           </a:p>
         </p:txBody>
       </p:sp>
+      <p:sp>
+        <p:nvSpPr>
+          <p:cNvPr id="7" name="TextBox 6"/>
+          <p:cNvSpPr txBox="1"/>
+          <p:nvPr/>
+        </p:nvSpPr>
+        <p:spPr>
+          <a:xfrm>
+            <a:off x="10545775" y="246888"/>
+            <a:ext cx="1280160" cy="365760"/>
+          </a:xfrm>
+          <a:prstGeom prst="rect">
+            <a:avLst/>
+          </a:prstGeom>
+          <a:noFill/>
+        </p:spPr>
+        <p:txBody>
+          <a:bodyPr wrap="square" anchor="t">
+            <a:spAutoFit/>
+          </a:bodyPr>
+          <a:lstStyle/>
+          <a:p>
+            <a:pPr algn="r"/>
+            <a:r>
+              <a:rPr sz="1100" b="0">
+                <a:solidFill>
+                  <a:srgbClr val="53565A"/>
+                </a:solidFill>
+                <a:latin typeface="Calibri"/>
+              </a:rPr>
+              <a:t>6 / 26</a:t>
+            </a:r>
+          </a:p>
+        </p:txBody>
+      </p:sp>
     </p:spTree>
   </p:cSld>
   <p:clrMapOvr>
@@ -10065,6 +10931,41 @@
           </a:p>
         </p:txBody>
       </p:sp>
+      <p:sp>
+        <p:nvSpPr>
+          <p:cNvPr id="8" name="TextBox 7"/>
+          <p:cNvSpPr txBox="1"/>
+          <p:nvPr/>
+        </p:nvSpPr>
+        <p:spPr>
+          <a:xfrm>
+            <a:off x="10545775" y="246888"/>
+            <a:ext cx="1280160" cy="365760"/>
+          </a:xfrm>
+          <a:prstGeom prst="rect">
+            <a:avLst/>
+          </a:prstGeom>
+          <a:noFill/>
+        </p:spPr>
+        <p:txBody>
+          <a:bodyPr wrap="square" anchor="t">
+            <a:spAutoFit/>
+          </a:bodyPr>
+          <a:lstStyle/>
+          <a:p>
+            <a:pPr algn="r"/>
+            <a:r>
+              <a:rPr sz="1100" b="0">
+                <a:solidFill>
+                  <a:srgbClr val="53565A"/>
+                </a:solidFill>
+                <a:latin typeface="Calibri"/>
+              </a:rPr>
+              <a:t>7 / 26</a:t>
+            </a:r>
+          </a:p>
+        </p:txBody>
+      </p:sp>
     </p:spTree>
   </p:cSld>
   <p:clrMapOvr>
@@ -10274,6 +11175,41 @@
           </a:p>
         </p:txBody>
       </p:sp>
+      <p:sp>
+        <p:nvSpPr>
+          <p:cNvPr id="7" name="TextBox 6"/>
+          <p:cNvSpPr txBox="1"/>
+          <p:nvPr/>
+        </p:nvSpPr>
+        <p:spPr>
+          <a:xfrm>
+            <a:off x="10545775" y="246888"/>
+            <a:ext cx="1280160" cy="365760"/>
+          </a:xfrm>
+          <a:prstGeom prst="rect">
+            <a:avLst/>
+          </a:prstGeom>
+          <a:noFill/>
+        </p:spPr>
+        <p:txBody>
+          <a:bodyPr wrap="square" anchor="t">
+            <a:spAutoFit/>
+          </a:bodyPr>
+          <a:lstStyle/>
+          <a:p>
+            <a:pPr algn="r"/>
+            <a:r>
+              <a:rPr sz="1100" b="0">
+                <a:solidFill>
+                  <a:srgbClr val="53565A"/>
+                </a:solidFill>
+                <a:latin typeface="Calibri"/>
+              </a:rPr>
+              <a:t>8 / 26</a:t>
+            </a:r>
+          </a:p>
+        </p:txBody>
+      </p:sp>
     </p:spTree>
   </p:cSld>
   <p:clrMapOvr>
@@ -10335,9 +11271,33 @@
           </a:p>
         </p:txBody>
       </p:sp>
-      <p:sp>
-        <p:nvSpPr>
-          <p:cNvPr id="3" name="TextBox 2"/>
+      <p:pic>
+        <p:nvPicPr>
+          <p:cNvPr id="3" name="Picture 2" descr="som_logo_white.png"/>
+          <p:cNvPicPr>
+            <a:picLocks noChangeAspect="1"/>
+          </p:cNvPicPr>
+          <p:nvPr/>
+        </p:nvPicPr>
+        <p:blipFill>
+          <a:blip r:embed="rId2"/>
+          <a:stretch>
+            <a:fillRect/>
+          </a:stretch>
+        </p:blipFill>
+        <p:spPr>
+          <a:xfrm>
+            <a:off x="502920" y="457200"/>
+            <a:ext cx="2651760" cy="338836"/>
+          </a:xfrm>
+          <a:prstGeom prst="rect">
+            <a:avLst/>
+          </a:prstGeom>
+        </p:spPr>
+      </p:pic>
+      <p:sp>
+        <p:nvSpPr>
+          <p:cNvPr id="4" name="TextBox 3"/>
           <p:cNvSpPr txBox="1"/>
           <p:nvPr/>
         </p:nvSpPr>
@@ -10366,6 +11326,41 @@
                 <a:latin typeface="Calibri"/>
               </a:rPr>
               <a:t>Part 2 — Results</a:t>
+            </a:r>
+          </a:p>
+        </p:txBody>
+      </p:sp>
+      <p:sp>
+        <p:nvSpPr>
+          <p:cNvPr id="5" name="TextBox 4"/>
+          <p:cNvSpPr txBox="1"/>
+          <p:nvPr/>
+        </p:nvSpPr>
+        <p:spPr>
+          <a:xfrm>
+            <a:off x="10545775" y="246888"/>
+            <a:ext cx="1280160" cy="365760"/>
+          </a:xfrm>
+          <a:prstGeom prst="rect">
+            <a:avLst/>
+          </a:prstGeom>
+          <a:noFill/>
+        </p:spPr>
+        <p:txBody>
+          <a:bodyPr wrap="square" anchor="t">
+            <a:spAutoFit/>
+          </a:bodyPr>
+          <a:lstStyle/>
+          <a:p>
+            <a:pPr algn="r"/>
+            <a:r>
+              <a:rPr sz="1100" b="0">
+                <a:solidFill>
+                  <a:srgbClr val="FFFFFF"/>
+                </a:solidFill>
+                <a:latin typeface="Calibri"/>
+              </a:rPr>
+              <a:t>9 / 26</a:t>
             </a:r>
           </a:p>
         </p:txBody>

</xml_diff>

<commit_message>
Presentation: title -> 'Can vibrotactile stimulation drive brain clearance?'; haptic/touch -> vibrotactile throughout
Per review: use 'vibrotactile stimulation' (not touch/haptic) and a less-childish
clearance phrasing while keeping the question form. Global haptic->vibrotactile
(output filename protected); modality list 'light, sound, touch' kept as natural.
Rebuilt pptx + pdf.

Co-Authored-By: Claude Opus 4.8 (1M context) <noreply@anthropic.com>
</commit_message>
<xml_diff>
--- a/presentation/haptic_brain_talk.pptx
+++ b/presentation/haptic_brain_talk.pptx
@@ -532,7 +532,7 @@
           <a:lstStyle/>
           <a:p>
             <a:r>
-              <a:t>The program question: can a wearable, touch-based stimulus engage brain rhythms in a way that helps the brain clear waste (the glymphatic system), with Alzheimer's relevance? I'll motivate it from the literature, lay out what to test, then show a first electrophysiology study testing the premise. I separate 'plausible mechanism' from 'proven' throughout. ~35 min — please interrupt.</a:t>
+              <a:t>The program question: can a wearable, vibrotactile stimulus engage brain rhythms in a way that helps the brain clear waste (the glymphatic system), with Alzheimer's relevance? I'll motivate it from the literature, lay out what to test, then show a first electrophysiology study testing the premise. I separate 'plausible mechanism' from 'proven' throughout. ~35 min — please interrupt.</a:t>
             </a:r>
           </a:p>
         </p:txBody>
@@ -1092,7 +1092,7 @@
           <a:lstStyle/>
           <a:p>
             <a:r>
-              <a:t>The artifact-resistant readout: sorted single units change firing rate during the high-amplitude 50 Hz condition, in both regions, and far more than at lower carriers. Pickup cannot drive a sorted neuron's spike train, so this is the clean evidence — and it answers the program's hardest objection: touch does reach and frequency-specifically drive these neurons.</a:t>
+              <a:t>The artifact-resistant readout: sorted single units change firing rate during the high-amplitude 50 Hz condition, in both regions, and far more than at lower carriers. Pickup cannot drive a sorted neuron's spike train, so this is the clean evidence — and it answers the program's hardest objection: vibrotactile stimulation does reach and frequency-specifically drive these neurons.</a:t>
             </a:r>
           </a:p>
         </p:txBody>
@@ -1302,7 +1302,7 @@
           <a:lstStyle/>
           <a:p>
             <a:r>
-              <a:t>Framing the gap. Pharmacology for Alzheimer's has struggled; the most credible non-drug clinical evidence is multidomain lifestyle intervention (FINGER, US POINTER). Non-invasive neuromodulation — light, sound, touch — is an emerging but mostly unproven frontier. The question is what a wearable, touch-based approach could add, and we should hold it to the bar those lifestyle trials set.</a:t>
+              <a:t>Framing the gap. Pharmacology for Alzheimer's has struggled; the most credible non-drug clinical evidence is multidomain lifestyle intervention (FINGER, US POINTER). Non-invasive neuromodulation — light, sound, touch — is an emerging but mostly unproven frontier. The question is what a wearable, vibrotactile approach could add, and we should hold it to the bar those lifestyle trials set.</a:t>
             </a:r>
           </a:p>
         </p:txBody>
@@ -1652,7 +1652,7 @@
           <a:lstStyle/>
           <a:p>
             <a:r>
-              <a:t>How it fits. The program's hardest objection (Part 2) is whether sensory stimulation engages the relevant circuits or just produces a surface steady-state. This study answers it for touch: peripheral vibration drives frequency-specific single-unit responses in hippocampus and entorhinal cortex — AD-relevant medial-temporal circuits — and they're frequency-tuned, peaking near 50 Hz. That converts 'haptic 40 Hz' from an assumption into a measured, tunable target-engagement parameter — the prerequisite before any clearance or clinical claim, and it sharpens the parameter list (40 vs 50 vs slow) for the next studies.</a:t>
+              <a:t>How it fits. The program's hardest objection (Part 2) is whether sensory stimulation engages the relevant circuits or just produces a surface steady-state. This study answers it for vibrotactile stimulation: peripheral vibration drives frequency-specific single-unit responses in hippocampus and entorhinal cortex — AD-relevant medial-temporal circuits — and they're frequency-tuned, peaking near 50 Hz. That converts 'vibrotactile 40 Hz' from an assumption into a measured, tunable target-engagement parameter — the prerequisite before any clearance or clinical claim, and it sharpens the parameter list (40 vs 50 vs slow) for the next studies.</a:t>
             </a:r>
           </a:p>
         </p:txBody>
@@ -1722,7 +1722,7 @@
           <a:lstStyle/>
           <a:p>
             <a:r>
-              <a:t>The five anchors: the origin of sensory-gamma (Tsai 2016); the gamma→glymphatic bridge (Murdock 2024); the haptic anchor (Suk 2023); the mechanism legitimizing brain-state stimulation of clearance (Jiang-Xie–Kipnis 2024); and the guardrail that keeps us honest (Buzsáki/Soula: a steady-state response is not entrainment). Full lit-review repository available on request.</a:t>
+              <a:t>The five anchors: the origin of sensory-gamma (Tsai 2016); the gamma→glymphatic bridge (Murdock 2024); the vibrotactile anchor (Suk 2023); the mechanism legitimizing brain-state stimulation of clearance (Jiang-Xie–Kipnis 2024); and the guardrail that keeps us honest (Buzsáki/Soula: a steady-state response is not entrainment). Full lit-review repository available on request.</a:t>
             </a:r>
           </a:p>
         </p:txBody>
@@ -1932,7 +1932,7 @@
           <a:lstStyle/>
           <a:p>
             <a:r>
-              <a:t>The niche. The established sensory-stimulation approach is audiovisual 40 Hz (GENUS). Its practical limits are daily wearability, comfort, and sleep use — exactly when clearance peaks. Touch/vibration is comparatively unexplored, is wearable, can run during sleep, and integrates with the wearable-sensing ecosystem (the Snyder-lab angle). That combination is the white space this program targets.</a:t>
+              <a:t>The niche. The established sensory-stimulation approach is audiovisual 40 Hz (GENUS). Its practical limits are daily wearability, comfort, and sleep use — exactly when clearance peaks. Vibrotactile stimulation is comparatively unexplored, is wearable, can run during sleep, and integrates with the wearable-sensing ecosystem (the Snyder-lab angle). That combination is the white space this program targets.</a:t>
             </a:r>
           </a:p>
         </p:txBody>
@@ -2212,7 +2212,7 @@
           <a:lstStyle/>
           <a:p>
             <a:r>
-              <a:t>The touch-specific evidence. Suk 2023 (Tsai lab) showed 40 Hz whole-body vibration reduces pathology and improves motor function in mouse AD models — the central haptic anchor, though not yet a human AD trial. And classic somatosensory physiology (Romo, Mountcastle flutter coding) shows primary somatosensory cortex faithfully encodes vibration frequency — so a frequency-specific tactile drive is biologically grounded, not wishful.</a:t>
+              <a:t>The vibrotactile-specific evidence. Suk 2023 (Tsai lab) showed 40 Hz whole-body vibration reduces pathology and improves motor function in mouse AD models — the central vibrotactile anchor, though not yet a human AD trial. And classic somatosensory physiology (Romo, Mountcastle flutter coding) shows primary somatosensory cortex faithfully encodes vibration frequency — so a frequency-specific tactile drive is biologically grounded, not wishful.</a:t>
             </a:r>
           </a:p>
         </p:txBody>
@@ -5452,7 +5452,7 @@
                 </a:solidFill>
                 <a:latin typeface="Calibri"/>
               </a:rPr>
-              <a:t>Can touch help the brain clear itself?</a:t>
+              <a:t>Can vibrotactile stimulation drive brain clearance?</a:t>
             </a:r>
           </a:p>
         </p:txBody>
@@ -5487,7 +5487,7 @@
                 </a:solidFill>
                 <a:latin typeface="Calibri"/>
               </a:rPr>
-              <a:t>Wearable haptic stimulation, brain rhythms, and glymphatic clearance — rationale, plan, and first electrophysiology (in the mouse)</a:t>
+              <a:t>Wearable vibrotactile stimulation, brain rhythms, and glymphatic clearance — rationale, plan, and first electrophysiology (in the mouse)</a:t>
             </a:r>
           </a:p>
         </p:txBody>
@@ -5618,7 +5618,7 @@
                 </a:solidFill>
                 <a:latin typeface="Calibri"/>
               </a:rPr>
-              <a:t>EVIDENCE · HAPTIC</a:t>
+              <a:t>EVIDENCE · VIBROTACTILE</a:t>
             </a:r>
           </a:p>
         </p:txBody>
@@ -5653,7 +5653,7 @@
                 </a:solidFill>
                 <a:latin typeface="Calibri"/>
               </a:rPr>
-              <a:t>The haptic anchor: 40 Hz vibration helps in mouse AD models, and cortex codes vibration frequency</a:t>
+              <a:t>The vibrotactile anchor: 40 Hz vibration helps in mouse AD models, and cortex codes vibration frequency</a:t>
             </a:r>
           </a:p>
         </p:txBody>
@@ -5731,7 +5731,7 @@
                 </a:solidFill>
                 <a:latin typeface="Calibri"/>
               </a:rPr>
-              <a:t>40 Hz whole-body vibration reduces pathology and improves function in AD-model mice (Suk 2023). Somatosensory cortex faithfully encodes vibration frequency (Romo, Mountcastle) — touch can carry a frequency code.</a:t>
+              <a:t>40 Hz whole-body vibration reduces pathology and improves function in AD-model mice (Suk 2023). Somatosensory cortex faithfully encodes vibration frequency (Romo, Mountcastle) — vibrotactile input can carry a frequency code.</a:t>
             </a:r>
           </a:p>
         </p:txBody>
@@ -5897,7 +5897,7 @@
                 </a:solidFill>
                 <a:latin typeface="Calibri"/>
               </a:rPr>
-              <a:t>So which haptic parameters should we test?</a:t>
+              <a:t>So which vibrotactile parameters should we test?</a:t>
             </a:r>
           </a:p>
         </p:txBody>
@@ -6130,7 +6130,7 @@
                 </a:solidFill>
                 <a:latin typeface="Calibri"/>
               </a:rPr>
-              <a:t>Part 3 · Does touch even reach the brain? A first study</a:t>
+              <a:t>Part 3 · Does vibrotactile stimulation reach the brain? A first study</a:t>
             </a:r>
           </a:p>
         </p:txBody>
@@ -6296,7 +6296,7 @@
                 </a:solidFill>
                 <a:latin typeface="Calibri"/>
               </a:rPr>
-              <a:t>Design: parametric haptic stimulation with simultaneous electrophysiology</a:t>
+              <a:t>Design: parametric vibrotactile stimulation with simultaneous electrophysiology</a:t>
             </a:r>
           </a:p>
         </p:txBody>
@@ -8161,7 +8161,7 @@
                 </a:solidFill>
                 <a:latin typeface="Calibri"/>
               </a:rPr>
-              <a:t>Part 1 · The vision — clearing the brain through touch</a:t>
+              <a:t>Part 1 · The vision — clearing the brain with vibrotactile stimulation</a:t>
             </a:r>
           </a:p>
         </p:txBody>
@@ -11454,7 +11454,7 @@
                 </a:solidFill>
                 <a:latin typeface="Calibri"/>
               </a:rPr>
-              <a:t>The proposal: engage brain rhythms through touch to drive the brain's clearance system</a:t>
+              <a:t>The proposal: use vibrotactile stimulation to engage brain rhythms and drive clearance</a:t>
             </a:r>
           </a:p>
         </p:txBody>
@@ -11532,7 +11532,7 @@
                 </a:solidFill>
                 <a:latin typeface="Calibri"/>
               </a:rPr>
-              <a:t>Wearable haptic stimulation → entrain brain rhythms → engage glymphatic clearance of amyloid-β / tau. A mechanism hypothesis — explicitly not yet a treatment claim.</a:t>
+              <a:t>Wearable vibrotactile stimulation → entrain brain rhythms → engage glymphatic clearance of amyloid-β / tau. A mechanism hypothesis — explicitly not yet a treatment claim.</a:t>
             </a:r>
           </a:p>
         </p:txBody>
@@ -11663,7 +11663,7 @@
                 </a:solidFill>
                 <a:latin typeface="Calibri"/>
               </a:rPr>
-              <a:t>WHY TOUCH</a:t>
+              <a:t>WHY VIBROTACTILE</a:t>
             </a:r>
           </a:p>
         </p:txBody>
@@ -11698,7 +11698,7 @@
                 </a:solidFill>
                 <a:latin typeface="Calibri"/>
               </a:rPr>
-              <a:t>Why haptic, and why wearable: the white space next to light and sound</a:t>
+              <a:t>Why vibrotactile, and why wearable: the white space next to light and sound</a:t>
             </a:r>
           </a:p>
         </p:txBody>
@@ -11776,7 +11776,7 @@
                 </a:solidFill>
                 <a:latin typeface="Calibri"/>
               </a:rPr>
-              <a:t>40 Hz light/sound (GENUS) is the developed approach but hard to wear daily. Touch is the open frontier — wearable, sleep-compatible, and pairs naturally with sensing.</a:t>
+              <a:t>40 Hz light/sound (GENUS) is the developed approach but hard to wear daily. Vibrotactile stimulation is the open frontier — wearable, sleep-compatible, and pairs naturally with sensing.</a:t>
             </a:r>
           </a:p>
         </p:txBody>

</xml_diff>

<commit_message>
Presentation: build the slide 3->4 glymphatic story + real references
- New bridge figures: glymphatic clearance schematic + "clearance can be
  driven" (40 Hz / focused ultrasound) diagram.
- Two new Part 1 slides between the problem and the proposal:
  "why clearance" (glymphatic hypothesis, framed as leading-but-unsettled)
  and "and it can be driven" (Murdock 2024 + Stanford ultrasound).
- Inline citations on the claim slides; FINGER (Ngandu 2015) / US POINTER
  (Baker 2025) added to "the problem".
- Enriched the Key references slide (grouped: lifestyle / clearance /
  stimulation / guardrail).
- Deck rebuilt: 33 slides, pptx + pdf; page-number total auto-updates.

Co-Authored-By: Claude Opus 4.8 <noreply@anthropic.com>
</commit_message>
<xml_diff>
--- a/presentation/haptic_brain_talk.pptx
+++ b/presentation/haptic_brain_talk.pptx
@@ -36,6 +36,8 @@
     <p:sldId id="284" r:id="rId36"/>
     <p:sldId id="285" r:id="rId37"/>
     <p:sldId id="286" r:id="rId38"/>
+    <p:sldId id="287" r:id="rId39"/>
+    <p:sldId id="288" r:id="rId40"/>
   </p:sldIdLst>
   <p:sldSz cx="12191695" cy="6858000" type="screen4x3"/>
   <p:notesSz cx="6858000" cy="9144000"/>
@@ -602,7 +604,7 @@
           <a:lstStyle/>
           <a:p>
             <a:r>
-              <a:t>A tactor delivers a sinusoidal vibration in 3 s ON / 3 s OFF blocks (figure: trial structure + analysis windows). We vary carrier frequency (5, 10, 26, 50 Hz) and amplitude, ~200 trials/condition, recording extracellularly with linear silicon probes in two connected regions at once: hippocampus (spatial/memory) and entorhinal cortex (its principal cortical input). Each window is referenced to the 1 s pre-stimulus baseline; 100 ms margins isolate onset/offset transients.</a:t>
+              <a:t>The vibrotactile-specific evidence. Suk 2023 (Tsai lab) showed 40 Hz whole-body vibration reduces pathology and improves motor function in mouse AD models — the central vibrotactile anchor, though not yet a human AD trial. And classic somatosensory physiology (Romo, Mountcastle flutter coding) shows primary somatosensory cortex faithfully encodes vibration frequency — so a frequency-specific tactile drive is biologically grounded, not wishful.</a:t>
             </a:r>
           </a:p>
         </p:txBody>
@@ -672,7 +674,7 @@
           <a:lstStyle/>
           <a:p>
             <a:r>
-              <a:t>The crux of the whole study. An extracellular electrode captures two regimes. The local field potential (LFP) is the low-frequency aggregate of synaptic/transmembrane currents from many neurons — large, but non-specific and susceptible to volume-conducted or instrumental noise. A 'single unit' is one individual neuron's spiking, isolated by spike sorting (clustering spikes by waveform). Stadium intuition: the crowd's roar (LFP) versus one identified shout (a single unit). The asymmetry that matters: an electrical artifact can add power to the LFP, but it cannot make a sorted neuron fire — so single-unit rate changes are the conservative, artifact-resistant evidence.</a:t>
+              <a:t>The payoff of Part 2. The literature defines a parameter space: 40 Hz (the GENUS anchor); ~50 Hz (where our own single-unit data peak — coming in Part 3); slow ~1 Hz / sleep-band (because clearance tracks slow waves); patterning — steady single-site versus spatiotemporal 'coordinated reset', which produces lasting plasticity rather than transient entrainment in Parkinson's (Tass vibrotactile glove); and rigorous controls — a non-40 frequency like 20 Hz, sham, and perceptually matched salience to exclude pure arousal. This is the experimental program the current study begins to ground.</a:t>
             </a:r>
           </a:p>
         </p:txBody>
@@ -742,7 +744,7 @@
           <a:lstStyle/>
           <a:p>
             <a:r>
-              <a:t>The broadband LFP shows a clear, amplitude-graded response — but concentrated at the ON and OFF transitions: an evoked transient, not a sustained oscillation at the drive frequency. The difference between responding to the event of stimulation versus tracking its rhythm. So there is a response — but not yet frequency-following.</a:t>
+              <a:t>A tactor delivers a sinusoidal vibration in 3 s ON / 3 s OFF blocks (figure: trial structure + analysis windows). We vary carrier frequency (5, 10, 26, 50 Hz) and amplitude, ~200 trials/condition, recording extracellularly with linear silicon probes in two connected regions at once: hippocampus (spatial/memory) and entorhinal cortex (its principal cortical input). Each window is referenced to the 1 s pre-stimulus baseline; 100 ms margins isolate onset/offset transients.</a:t>
             </a:r>
           </a:p>
         </p:txBody>
@@ -812,7 +814,7 @@
           <a:lstStyle/>
           <a:p>
             <a:r>
-              <a:t>The entrainment test (recall Part 2's definition). Frequency-following predicts a narrowband peak at the carrier above the 1/f background plus above-chance inter-trial phase consistency. We see neither, at any carrier, replicated across two sessions — no power- or phase-based frequency-following in hippocampus.</a:t>
+              <a:t>The crux of the whole study. An extracellular electrode captures two regimes. The local field potential (LFP) is the low-frequency aggregate of synaptic/transmembrane currents from many neurons — large, but non-specific and susceptible to volume-conducted or instrumental noise. A 'single unit' is one individual neuron's spiking, isolated by spike sorting (clustering spikes by waveform). Stadium intuition: the crowd's roar (LFP) versus one identified shout (a single unit). The asymmetry that matters: an electrical artifact can add power to the LFP, but it cannot make a sorted neuron fire — so single-unit rate changes are the conservative, artifact-resistant evidence.</a:t>
             </a:r>
           </a:p>
         </p:txBody>
@@ -882,7 +884,7 @@
           <a:lstStyle/>
           <a:p>
             <a:r>
-              <a:t>In entorhinal cortex there is a narrowband 50 Hz LFP power increase that scales with amplitude — superficially the entrainment signal we want. But the LFP is precisely the readout electrical pickup can mimic, so before interpreting it as neural we must exclude a stimulator-coupled artifact.</a:t>
+              <a:t>The broadband LFP shows a clear, amplitude-graded response — but concentrated at the ON and OFF transitions: an evoked transient, not a sustained oscillation at the drive frequency. The difference between responding to the event of stimulation versus tracking its rhythm. So there is a response — but not yet frequency-following.</a:t>
             </a:r>
           </a:p>
         </p:txBody>
@@ -952,7 +954,7 @@
           <a:lstStyle/>
           <a:p>
             <a:r>
-              <a:t>The actuator and its drive electronics can couple a 50 Hz signal into the recording — volume-conducted or via wiring. In the LFP that's indistinguishable from a neural 50 Hz. We need a discriminator the artifact can't fool.</a:t>
+              <a:t>The entrainment test (recall Part 2's definition). Frequency-following predicts a narrowband peak at the carrier above the 1/f background plus above-chance inter-trial phase consistency. We see neither, at any carrier, replicated across two sessions — no power- or phase-based frequency-following in hippocampus.</a:t>
             </a:r>
           </a:p>
         </p:txBody>
@@ -1022,7 +1024,7 @@
           <a:lstStyle/>
           <a:p>
             <a:r>
-              <a:t>The discriminator: broken/disconnected channels cannot record neurons but still act as antennas for pickup. If they carry the 50 Hz, it's instrumental. They do — ~6× the in-tissue channels — so the entorhinal 50 Hz LFP is largely stimulator artifact. The headline LFP result is mostly the machine. This is the central twist, and exactly the 'steady-state response ≠ real engagement' caution from Part 2, caught in our own data.</a:t>
+              <a:t>In entorhinal cortex there is a narrowband 50 Hz LFP power increase that scales with amplitude — superficially the entrainment signal we want. But the LFP is precisely the readout electrical pickup can mimic, so before interpreting it as neural we must exclude a stimulator-coupled artifact.</a:t>
             </a:r>
           </a:p>
         </p:txBody>
@@ -1092,7 +1094,7 @@
           <a:lstStyle/>
           <a:p>
             <a:r>
-              <a:t>The artifact-resistant readout: sorted single units change firing rate during the high-amplitude 50 Hz condition, in both regions, and far more than at lower carriers. Pickup cannot drive a sorted neuron's spike train, so this is the clean evidence — and it answers the program's hardest objection: vibrotactile stimulation does reach and frequency-specifically drive these neurons.</a:t>
+              <a:t>The actuator and its drive electronics can couple a 50 Hz signal into the recording — volume-conducted or via wiring. In the LFP that's indistinguishable from a neural 50 Hz. We need a discriminator the artifact can't fool.</a:t>
             </a:r>
           </a:p>
         </p:txBody>
@@ -1162,7 +1164,7 @@
           <a:lstStyle/>
           <a:p>
             <a:r>
-              <a:t>Two controls. Spike detection operates above ~300 Hz, so 50 Hz pickup is filtered out before a spike is detected. And were pickup injecting spurious spikes at 50 Hz, the autocorrelogram would develop 20 ms periodicity during stimulation — it does not, and is identical ON vs OFF; refractory-violation rates don't rise either. So the rate modulation is genuine single-unit activity.</a:t>
+              <a:t>The discriminator: broken/disconnected channels cannot record neurons but still act as antennas for pickup. If they carry the 50 Hz, it's instrumental. They do — ~6× the in-tissue channels — so the entorhinal 50 Hz LFP is largely stimulator artifact. The headline LFP result is mostly the machine. This is the central twist, and exactly the 'steady-state response ≠ real engagement' caution from Part 2, caught in our own data.</a:t>
             </a:r>
           </a:p>
         </p:txBody>
@@ -1232,7 +1234,7 @@
           <a:lstStyle/>
           <a:p>
             <a:r>
-              <a:t>The two regions transform the same input in opposite directions: a hippocampal subset increases firing while entorhinal cortex is net-suppressed. Opposite-signed responses to identical input are inconsistent with a passive relay and consistent with circuit-specific processing — and the suppression is itself artifact-resistant (pickup adds, it can't remove, spikes).</a:t>
+              <a:t>The artifact-resistant readout: sorted single units change firing rate during the high-amplitude 50 Hz condition, in both regions, and far more than at lower carriers. Pickup cannot drive a sorted neuron's spike train, so this is the clean evidence — and it answers the program's hardest objection: vibrotactile stimulation does reach and frequency-specifically drive these neurons.</a:t>
             </a:r>
           </a:p>
         </p:txBody>
@@ -1302,7 +1304,7 @@
           <a:lstStyle/>
           <a:p>
             <a:r>
-              <a:t>Framing the gap. Pharmacology for Alzheimer's has struggled; the most credible non-drug clinical evidence is multidomain lifestyle intervention (FINGER, US POINTER). Non-invasive neuromodulation — light, sound, touch — is an emerging but mostly unproven frontier. The question is what a wearable, vibrotactile approach could add, and we should hold it to the bar those lifestyle trials set.</a:t>
+              <a:t>Framing the gap. Pharmacology for Alzheimer's has struggled — anti-amyloid drugs give small effects and carry safety costs. The most credible non-drug clinical evidence is multidomain lifestyle intervention: FINGER (Ngandu, Lancet 2015) — a 2-year diet + exercise + cognitive-training + vascular-care RCT that slowed cognitive decline — and its U.S. replication, U.S. POINTER (Baker, JAMA 2025). The takeaway: the best non-drug evidence today is a lifestyle package, not a device. Non-invasive neuromodulation — light, sound, vibrotactile — is an emerging but mostly unproven frontier. The question is what a wearable, vibrotactile approach could add, held to the bar those lifestyle trials set.</a:t>
             </a:r>
           </a:p>
         </p:txBody>
@@ -1372,7 +1374,7 @@
           <a:lstStyle/>
           <a:p>
             <a:r>
-              <a:t>LFP–LFP coherence increases, but a shared pickup inflates coherence. The spike–field measure (one region's spikes vs the other's LFP phase), which a shared artifact can't fake as easily, does not increase — so the apparent coupling is most parsimoniously a shared signal, not genuine coordination.</a:t>
+              <a:t>Two controls. Spike detection operates above ~300 Hz, so 50 Hz pickup is filtered out before a spike is detected. And were pickup injecting spurious spikes at 50 Hz, the autocorrelogram would develop 20 ms periodicity during stimulation — it does not, and is identical ON vs OFF; refractory-violation rates don't rise either. So the rate modulation is genuine single-unit activity.</a:t>
             </a:r>
           </a:p>
         </p:txBody>
@@ -1442,7 +1444,7 @@
           <a:lstStyle/>
           <a:p>
             <a:r>
-              <a:t>Testing entrainment (phase-locking) requires a time-aligned reference for the stimulus phase. We didn't record a usable one — so 'no entrainment shown' is a measurement gap, not evidence of absence. The power/periodicity negatives are real; only the phase-locking claim is gated by the missing reference. Separately, we found post hoc that the lower-frequency stimuli (5/10/26 Hz) were not clean sine waves — so the 50 Hz frequency-specificity is partly confounded with stimulus quality; recording the delivered waveform fixes that too.</a:t>
+              <a:t>The two regions transform the same input in opposite directions: a hippocampal subset increases firing while entorhinal cortex is net-suppressed. Opposite-signed responses to identical input are inconsistent with a passive relay and consistent with circuit-specific processing — and the suppression is itself artifact-resistant (pickup adds, it can't remove, spikes).</a:t>
             </a:r>
           </a:p>
         </p:txBody>
@@ -1512,7 +1514,7 @@
           <a:lstStyle/>
           <a:p>
             <a:r>
-              <a:t>Verified from the raw digital stream: the sync channel updated at ~4 Hz irrespective of carrier (same ~6 pulses/trial for 5 and 26 Hz; ~78 expected at 26 Hz), never sustained a run at the carrier period, and was misaligned with the schedule. Undersampled and decoupled — phase unrecoverable. A ~4 Hz observer can't resolve a 26 Hz oscillation.</a:t>
+              <a:t>LFP–LFP coherence increases, but a shared pickup inflates coherence. The spike–field measure (one region's spikes vs the other's LFP phase), which a shared artifact can't fake as easily, does not increase — so the apparent coupling is most parsimoniously a shared signal, not genuine coordination.</a:t>
             </a:r>
           </a:p>
         </p:txBody>
@@ -1582,7 +1584,7 @@
           <a:lstStyle/>
           <a:p>
             <a:r>
-              <a:t>Design, not analysis: record the stimulus three ways on the acquisition clock — a firmware per-cycle marker (implemented), a transduced measurement of the delivered vibration (PVDF or accelerometer, which also verifies delivery), and a drive-signal copy — then cross-validate, plus a short verification recording before the session. With redundancy on a shared clock, a failed reference is caught immediately rather than months later. This is what makes entrainment — and eventually clearance readouts — testable.</a:t>
+              <a:t>Testing entrainment (phase-locking) requires a time-aligned reference for the stimulus phase. We didn't record a usable one — so 'no entrainment shown' is a measurement gap, not evidence of absence. The power/periodicity negatives are real; only the phase-locking claim is gated by the missing reference. Separately, we found post hoc that the lower-frequency stimuli (5/10/26 Hz) were not clean sine waves — so the 50 Hz frequency-specificity is partly confounded with stimulus quality; recording the delivered waveform fixes that too.</a:t>
             </a:r>
           </a:p>
         </p:txBody>
@@ -1652,7 +1654,7 @@
           <a:lstStyle/>
           <a:p>
             <a:r>
-              <a:t>How it fits. The program's hardest objection (Part 2) is whether sensory stimulation engages the relevant circuits or just produces a surface steady-state. This study answers it for vibrotactile stimulation: peripheral vibration drives frequency-specific single-unit responses in hippocampus and entorhinal cortex — AD-relevant medial-temporal circuits — and they're frequency-tuned, peaking near 50 Hz. That converts 'vibrotactile 40 Hz' from an assumption into a measured, tunable target-engagement parameter — the prerequisite before any clearance or clinical claim, and it sharpens the parameter list (40 vs 50 vs slow) for the next studies.</a:t>
+              <a:t>Verified from the raw digital stream: the sync channel updated at ~4 Hz irrespective of carrier (same ~6 pulses/trial for 5 and 26 Hz; ~78 expected at 26 Hz), never sustained a run at the carrier period, and was misaligned with the schedule. Undersampled and decoupled — phase unrecoverable. A ~4 Hz observer can't resolve a 26 Hz oscillation.</a:t>
             </a:r>
           </a:p>
         </p:txBody>
@@ -1722,7 +1724,7 @@
           <a:lstStyle/>
           <a:p>
             <a:r>
-              <a:t>The five anchors: the origin of sensory-gamma (Tsai 2016); the gamma→glymphatic bridge (Murdock 2024); the vibrotactile anchor (Suk 2023); the mechanism legitimizing brain-state stimulation of clearance (Jiang-Xie–Kipnis 2024); and the guardrail that keeps us rigorous (Buzsáki/Soula: a steady-state response is not entrainment). Full lit-review repository available on request.</a:t>
+              <a:t>Design, not analysis: record the stimulus three ways on the acquisition clock — a firmware per-cycle marker (implemented), a transduced measurement of the delivered vibration (PVDF or accelerometer, which also verifies delivery), and a drive-signal copy — then cross-validate, plus a short verification recording before the session. With redundancy on a shared clock, a failed reference is caught immediately rather than months later. This is what makes entrainment — and eventually clearance readouts — testable.</a:t>
             </a:r>
           </a:p>
         </p:txBody>
@@ -1792,6 +1794,146 @@
           <a:lstStyle/>
           <a:p>
             <a:r>
+              <a:t>How it fits. The program's hardest objection (Part 2) is whether sensory stimulation engages the relevant circuits or just produces a surface steady-state. This study answers it for vibrotactile stimulation: peripheral vibration drives frequency-specific single-unit responses in hippocampus and entorhinal cortex — AD-relevant medial-temporal circuits — and they're frequency-tuned, peaking near 50 Hz. That converts 'vibrotactile 40 Hz' from an assumption into a measured, tunable target-engagement parameter — the prerequisite before any clearance or clinical claim, and it sharpens the parameter list (40 vs 50 vs slow) for the next studies.</a:t>
+            </a:r>
+          </a:p>
+        </p:txBody>
+      </p:sp>
+      <p:sp>
+        <p:nvSpPr>
+          <p:cNvPr id="4" name="Slide Number Placeholder 3"/>
+          <p:cNvSpPr>
+            <a:spLocks noGrp="1"/>
+          </p:cNvSpPr>
+          <p:nvPr>
+            <p:ph type="sldNum" idx="5" sz="quarter"/>
+          </p:nvPr>
+        </p:nvSpPr>
+        <p:spPr/>
+      </p:sp>
+    </p:spTree>
+  </p:cSld>
+  <p:clrMapOvr>
+    <a:masterClrMapping/>
+  </p:clrMapOvr>
+</p:notes>
+</file>
+
+<file path=ppt/notesSlides/notesSlide27.xml><?xml version="1.0" encoding="utf-8"?>
+<p:notes xmlns:a="http://schemas.openxmlformats.org/drawingml/2006/main" xmlns:p="http://schemas.openxmlformats.org/presentationml/2006/main" xmlns:r="http://schemas.openxmlformats.org/officeDocument/2006/relationships">
+  <p:cSld>
+    <p:spTree>
+      <p:nvGrpSpPr>
+        <p:cNvPr id="1" name=""/>
+        <p:cNvGrpSpPr/>
+        <p:nvPr/>
+      </p:nvGrpSpPr>
+      <p:grpSpPr>
+        <a:xfrm>
+          <a:off x="0" y="0"/>
+          <a:ext cx="0" cy="0"/>
+          <a:chOff x="0" y="0"/>
+          <a:chExt cx="0" cy="0"/>
+        </a:xfrm>
+      </p:grpSpPr>
+      <p:sp>
+        <p:nvSpPr>
+          <p:cNvPr id="2" name="Slide Image Placeholder 1"/>
+          <p:cNvSpPr>
+            <a:spLocks noGrp="1"/>
+          </p:cNvSpPr>
+          <p:nvPr>
+            <p:ph type="sldImg" idx="2"/>
+          </p:nvPr>
+        </p:nvSpPr>
+        <p:spPr/>
+      </p:sp>
+      <p:sp>
+        <p:nvSpPr>
+          <p:cNvPr id="3" name="Notes Placeholder 2"/>
+          <p:cNvSpPr>
+            <a:spLocks noGrp="1"/>
+          </p:cNvSpPr>
+          <p:nvPr>
+            <p:ph type="body" idx="3" sz="quarter"/>
+          </p:nvPr>
+        </p:nvSpPr>
+        <p:spPr/>
+        <p:txBody>
+          <a:bodyPr/>
+          <a:lstStyle/>
+          <a:p>
+            <a:r>
+              <a:t>Grouped anchors. Lifestyle bar — FINGER (Ngandu, Lancet 2015) and U.S. POINTER (Baker, JAMA 2025). Clearance hypothesis &amp; drivers — glymphatic discovery (Iliff, Sci Transl Med 2012), sleep clearance (Xie, Science 2013), slowed Aβ clearance in AD (Mawuenyega, Science 2010), 40 Hz → glymphatic clearance, AQP4-dependent (Murdock, Nature 2024), and Stanford focused ultrasound (Aryal, J Control Release 2022; Azadian, Nat Biotech 2025). Stimulation — origin of sensory-gamma (Tsai 2016), the vibrotactile anchor (Suk 2023), and the mechanism legitimizing brain-state stimulation of clearance (Jiang-Xie–Kipnis 2024). Guardrail — Buzsáki/Soula: a steady-state response is not entrainment. Full lit-review repository available on request.</a:t>
+            </a:r>
+          </a:p>
+        </p:txBody>
+      </p:sp>
+      <p:sp>
+        <p:nvSpPr>
+          <p:cNvPr id="4" name="Slide Number Placeholder 3"/>
+          <p:cNvSpPr>
+            <a:spLocks noGrp="1"/>
+          </p:cNvSpPr>
+          <p:nvPr>
+            <p:ph type="sldNum" idx="5" sz="quarter"/>
+          </p:nvPr>
+        </p:nvSpPr>
+        <p:spPr/>
+      </p:sp>
+    </p:spTree>
+  </p:cSld>
+  <p:clrMapOvr>
+    <a:masterClrMapping/>
+  </p:clrMapOvr>
+</p:notes>
+</file>
+
+<file path=ppt/notesSlides/notesSlide28.xml><?xml version="1.0" encoding="utf-8"?>
+<p:notes xmlns:a="http://schemas.openxmlformats.org/drawingml/2006/main" xmlns:p="http://schemas.openxmlformats.org/presentationml/2006/main" xmlns:r="http://schemas.openxmlformats.org/officeDocument/2006/relationships">
+  <p:cSld>
+    <p:spTree>
+      <p:nvGrpSpPr>
+        <p:cNvPr id="1" name=""/>
+        <p:cNvGrpSpPr/>
+        <p:nvPr/>
+      </p:nvGrpSpPr>
+      <p:grpSpPr>
+        <a:xfrm>
+          <a:off x="0" y="0"/>
+          <a:ext cx="0" cy="0"/>
+          <a:chOff x="0" y="0"/>
+          <a:chExt cx="0" cy="0"/>
+        </a:xfrm>
+      </p:grpSpPr>
+      <p:sp>
+        <p:nvSpPr>
+          <p:cNvPr id="2" name="Slide Image Placeholder 1"/>
+          <p:cNvSpPr>
+            <a:spLocks noGrp="1"/>
+          </p:cNvSpPr>
+          <p:nvPr>
+            <p:ph type="sldImg" idx="2"/>
+          </p:nvPr>
+        </p:nvSpPr>
+        <p:spPr/>
+      </p:sp>
+      <p:sp>
+        <p:nvSpPr>
+          <p:cNvPr id="3" name="Notes Placeholder 2"/>
+          <p:cNvSpPr>
+            <a:spLocks noGrp="1"/>
+          </p:cNvSpPr>
+          <p:nvPr>
+            <p:ph type="body" idx="3" sz="quarter"/>
+          </p:nvPr>
+        </p:nvSpPr>
+        <p:spPr/>
+        <p:txBody>
+          <a:bodyPr/>
+          <a:lstStyle/>
+          <a:p>
+            <a:r>
               <a:t>Anticipated questions. 'Is 50 Hz special or just strongest?' — strongest clean single-unit effect of the carriers tested; the LFP transient was largest at 26 Hz but that's the artifact-prone measure. 'Could it be arousal?' — possible, but frequency-specific (50 ≫ 26 at matched amplitude); an indirect sensory/state pathway isn't excluded. 'Why distrust the 50 Hz LFP?' — disconnected channels carry it at ~6× tissue. 'Is this a treatment?' — no; this is target-engagement evidence for a mechanism hypothesis, deliberately separated from any clinical claim.</a:t>
             </a:r>
           </a:p>
@@ -1862,7 +2004,7 @@
           <a:lstStyle/>
           <a:p>
             <a:r>
-              <a:t>The core chain. The glymphatic system is the brain's waste-clearance pathway — CSF/interstitial-fluid exchange that removes amyloid-β and tau. The hypothesis: if we can drive the right rhythms or brain-states from the skin, we may enhance that clearance. This is a mechanism hypothesis to test, not a clinical claim — I'll be explicit about that distinction the whole way through.</a:t>
+              <a:t>The mechanistic bridge — why stimulating the brain might help at all. One leading hypothesis is that AD is partly a clearance failure. The glymphatic system (Iliff 2012) moves CSF along perivascular spaces to wash amyloid-β and tau out toward the cervical lymph nodes; it is strongly boosted during sleep (Xie 2013) and by vascular pulsation, and depends on the AQP4 water channel. In AD, amyloid is cleared more slowly (Mawuenyega 2010), and impaired glymphatic flow on DTI-ALPS imaging appears to precede amyloid deposition (ADNI 2024). Important caveat for this audience: it remains contested — DTI-ALPS may index vascular rather than glymphatic function (Mayo 2025), and some studies find clearance reduced rather than increased in sleep. So present it as an active, plausible contributor, not the proven sole cause.</a:t>
             </a:r>
           </a:p>
         </p:txBody>
@@ -1932,7 +2074,7 @@
           <a:lstStyle/>
           <a:p>
             <a:r>
-              <a:t>The niche. The established sensory-stimulation approach is audiovisual 40 Hz (GENUS). Its practical limits are daily wearability, comfort, and sleep use — exactly when clearance peaks. Vibrotactile stimulation is comparatively unexplored, is wearable, can run during sleep, and integrates with the wearable-sensing ecosystem (the Snyder-lab angle). That combination is the white space this program targets.</a:t>
+              <a:t>The proof-of-principle that motivates the program. Murdock et al. (2024, Nature) showed 40 Hz multisensory (light + sound) stimulation in AD-model mice increased CSF tracer influx ~4-fold, lowered frontal-cortex amyloid ~30%, and pushed more amyloid into the deep cervical lymph nodes — and blocking the AQP4 water channel abolished it, tying the effect directly to the glymphatic route. Separately, Stanford's focused-ultrasound work (Aryal 2022, J Control Release; Azadian 2025, Nat Biotech) shows another non-invasive route to drive CSF influx and clear debris. Together they say clearance is drivable from outside the skull. The gap none fills: a comfortable, wearable, sleep-compatible modality — the case for vibrotactile, and the bridge to the proposal.</a:t>
             </a:r>
           </a:p>
         </p:txBody>
@@ -2002,7 +2144,7 @@
           <a:lstStyle/>
           <a:p>
             <a:r>
-              <a:t>The anchor evidence chain. In mice, 40 Hz visual/auditory stimulation (GENUS, Tsai lab 2016) reduces amyloid and engages microglia; Murdock 2024 in Nature shows 40 Hz gamma drives CSF influx and amyloid clearance, AQP4-dependent — the gamma-to-glymphatic bridge. Early human trials (Chan 2022) report safety, neural entrainment, and good compliance. This is why 40 Hz is the canonical frequency to start from.</a:t>
+              <a:t>The core chain. The glymphatic system is the brain's waste-clearance pathway — CSF/interstitial-fluid exchange that removes amyloid-β and tau. The hypothesis: if we can drive the right rhythms or brain-states from the skin, we may enhance that clearance. This is a mechanism hypothesis to test, not a clinical claim — I'll be explicit about that distinction the whole way through.</a:t>
             </a:r>
           </a:p>
         </p:txBody>
@@ -2072,7 +2214,7 @@
           <a:lstStyle/>
           <a:p>
             <a:r>
-              <a:t>Essential for credibility — especially at Stanford. The Buzsáki lab and others caution that an evoked steady-state response at the stimulus frequency is not the same as entraining the brain's endogenous oscillator; some studies find 40 Hz light does not entrain native gamma in AD models. So the program holds two questions apart: did we engage the circuit, versus did we change the disease. Building that discipline in is part of the design, not a footnote.</a:t>
+              <a:t>The niche. The established sensory-stimulation approach is audiovisual 40 Hz (GENUS). Its practical limits are daily wearability, comfort, and sleep use — exactly when clearance peaks. Vibrotactile stimulation is comparatively unexplored, is wearable, can run during sleep, and integrates with the wearable-sensing ecosystem (the Snyder-lab angle). That combination is the white space this program targets.</a:t>
             </a:r>
           </a:p>
         </p:txBody>
@@ -2142,7 +2284,7 @@
           <a:lstStyle/>
           <a:p>
             <a:r>
-              <a:t>Why targeting clearance via brain-state is reasonable. Glymphatic/CSF flow isn't passive: it's driven by neural activity, vascular pulsation, and especially sleep slow waves — Fultz 2019 (human, NREM slow waves drive CSF oscillations), Hablitz 2019 (influx tracks EEG delta), Mestre 2018 (arterial pulsation), and Jiang-Xie–Kipnis 2024 in Nature (neuronal ionic waves actively direct CSF perfusion). In humans, sleep clearance raises morning plasma Aβ/tau (Dagum 2026). So if stimulation can shape brain state, engaging clearance is mechanistically plausible — and this points to slow / sleep-band stimulation, not only 40 Hz.</a:t>
+              <a:t>The anchor evidence chain. In mice, 40 Hz visual/auditory stimulation (GENUS, Tsai lab 2016) reduces amyloid and engages microglia; Murdock 2024 in Nature shows 40 Hz gamma drives CSF influx and amyloid clearance, AQP4-dependent — the gamma-to-glymphatic bridge. Early human trials (Chan 2022) report safety, neural entrainment, and good compliance. This is why 40 Hz is the canonical frequency to start from.</a:t>
             </a:r>
           </a:p>
         </p:txBody>
@@ -2212,7 +2354,7 @@
           <a:lstStyle/>
           <a:p>
             <a:r>
-              <a:t>The vibrotactile-specific evidence. Suk 2023 (Tsai lab) showed 40 Hz whole-body vibration reduces pathology and improves motor function in mouse AD models — the central vibrotactile anchor, though not yet a human AD trial. And classic somatosensory physiology (Romo, Mountcastle flutter coding) shows primary somatosensory cortex faithfully encodes vibration frequency — so a frequency-specific tactile drive is biologically grounded, not wishful.</a:t>
+              <a:t>Essential for credibility — especially at Stanford. The Buzsáki lab and others caution that an evoked steady-state response at the stimulus frequency is not the same as entraining the brain's endogenous oscillator; some studies find 40 Hz light does not entrain native gamma in AD models. So the program holds two questions apart: did we engage the circuit, versus did we change the disease. Building that discipline in is part of the design, not a footnote.</a:t>
             </a:r>
           </a:p>
         </p:txBody>
@@ -2282,7 +2424,7 @@
           <a:lstStyle/>
           <a:p>
             <a:r>
-              <a:t>The payoff of Part 2. The literature defines a parameter space: 40 Hz (the GENUS anchor); ~50 Hz (where our own single-unit data peak — coming in Part 3); slow ~1 Hz / sleep-band (because clearance tracks slow waves); patterning — steady single-site versus spatiotemporal 'coordinated reset', which produces lasting plasticity rather than transient entrainment in Parkinson's (Tass vibrotactile glove); and rigorous controls — a non-40 frequency like 20 Hz, sham, and perceptually matched salience to exclude pure arousal. This is the experimental program the current study begins to ground.</a:t>
+              <a:t>Why targeting clearance via brain-state is reasonable. Glymphatic/CSF flow isn't passive: it's driven by neural activity, vascular pulsation, and especially sleep slow waves — Fultz 2019 (human, NREM slow waves drive CSF oscillations), Hablitz 2019 (influx tracks EEG delta), Mestre 2018 (arterial pulsation), and Jiang-Xie–Kipnis 2024 in Nature (neuronal ionic waves actively direct CSF perfusion). In humans, sleep clearance raises morning plasma Aβ/tau (Dagum 2026). So if stimulation can shape brain state, engaging clearance is mechanistically plausible — and this points to slow / sleep-band stimulation, not only 40 Hz.</a:t>
             </a:r>
           </a:p>
         </p:txBody>
@@ -5618,7 +5760,7 @@
                 </a:solidFill>
                 <a:latin typeface="Calibri"/>
               </a:rPr>
-              <a:t>EVIDENCE · VIBROTACTILE</a:t>
+              <a:t>THE KEY CAVEAT</a:t>
             </a:r>
           </a:p>
         </p:txBody>
@@ -5653,7 +5795,7 @@
                 </a:solidFill>
                 <a:latin typeface="Calibri"/>
               </a:rPr>
-              <a:t>The vibrotactile anchor: 40 Hz vibration helps in mouse AD models, and cortex codes vibration frequency</a:t>
+              <a:t>But a steady-state response is not the same as entraining the brain's own rhythm</a:t>
             </a:r>
           </a:p>
         </p:txBody>
@@ -5731,7 +5873,7 @@
                 </a:solidFill>
                 <a:latin typeface="Calibri"/>
               </a:rPr>
-              <a:t>40 Hz whole-body vibration reduces pathology and improves function in AD-model mice (Suk 2023). Somatosensory cortex faithfully encodes vibration frequency (Romo, Mountcastle) — vibrotactile input can carry a frequency code.</a:t>
+              <a:t>A driven 40 Hz response ≠ engaging native gamma (Buzsáki/Soula; some studies find 40 Hz light fails to entrain native gamma in AD-model mice). We separate target engagement from disease modification.</a:t>
             </a:r>
           </a:p>
         </p:txBody>
@@ -5766,7 +5908,7 @@
                 </a:solidFill>
                 <a:latin typeface="Calibri"/>
               </a:rPr>
-              <a:t>10 / 31</a:t>
+              <a:t>10 / 33</a:t>
             </a:r>
           </a:p>
         </p:txBody>
@@ -5862,7 +6004,7 @@
                 </a:solidFill>
                 <a:latin typeface="Calibri"/>
               </a:rPr>
-              <a:t>→ WHAT TO TEST</a:t>
+              <a:t>EVIDENCE · CLEARANCE</a:t>
             </a:r>
           </a:p>
         </p:txBody>
@@ -5897,7 +6039,7 @@
                 </a:solidFill>
                 <a:latin typeface="Calibri"/>
               </a:rPr>
-              <a:t>So which vibrotactile parameters should we test?</a:t>
+              <a:t>Clearance is actively driven by neural, vascular &amp; sleep dynamics — so 'brain-state' stimulation is plausible</a:t>
             </a:r>
           </a:p>
         </p:txBody>
@@ -5975,7 +6117,7 @@
                 </a:solidFill>
                 <a:latin typeface="Calibri"/>
               </a:rPr>
-              <a:t>40 Hz (gamma) · ~50 Hz (our electrophysiology, Part 3) · slow ~1 Hz / sleep-band (clearance biology) · steady vs coordinated-reset patterning · controls: 20 Hz, sham, matched salience.</a:t>
+              <a:t>CSF flow tracks NREM slow waves (Fultz 2019) and EEG delta (Hablitz 2019); neuronal dynamics actively direct CSF perfusion (Jiang-Xie–Kipnis 2024, Nature); human sleep clearance moves plasma Aβ/tau (Dagum 2026).</a:t>
             </a:r>
           </a:p>
         </p:txBody>
@@ -6010,7 +6152,7 @@
                 </a:solidFill>
                 <a:latin typeface="Calibri"/>
               </a:rPr>
-              <a:t>11 / 31</a:t>
+              <a:t>11 / 33</a:t>
             </a:r>
           </a:p>
         </p:txBody>
@@ -6042,7 +6184,7 @@
         <p:spPr>
           <a:xfrm>
             <a:off x="0" y="0"/>
-            <a:ext cx="12191695" cy="6858000"/>
+            <a:ext cx="12191695" cy="164592"/>
           </a:xfrm>
           <a:prstGeom prst="rect">
             <a:avLst/>
@@ -6076,30 +6218,41 @@
           </a:p>
         </p:txBody>
       </p:sp>
-      <p:pic>
-        <p:nvPicPr>
-          <p:cNvPr id="3" name="Picture 2" descr="som_logo_white.png"/>
-          <p:cNvPicPr>
-            <a:picLocks noChangeAspect="1"/>
-          </p:cNvPicPr>
-          <p:nvPr/>
-        </p:nvPicPr>
-        <p:blipFill>
-          <a:blip r:embed="rId2"/>
-          <a:stretch>
-            <a:fillRect/>
-          </a:stretch>
-        </p:blipFill>
-        <p:spPr>
-          <a:xfrm>
-            <a:off x="502920" y="457200"/>
-            <a:ext cx="2651760" cy="338836"/>
-          </a:xfrm>
-          <a:prstGeom prst="rect">
-            <a:avLst/>
-          </a:prstGeom>
-        </p:spPr>
-      </p:pic>
+      <p:sp>
+        <p:nvSpPr>
+          <p:cNvPr id="3" name="TextBox 2"/>
+          <p:cNvSpPr txBox="1"/>
+          <p:nvPr/>
+        </p:nvSpPr>
+        <p:spPr>
+          <a:xfrm>
+            <a:off x="548640" y="411480"/>
+            <a:ext cx="11094415" cy="365760"/>
+          </a:xfrm>
+          <a:prstGeom prst="rect">
+            <a:avLst/>
+          </a:prstGeom>
+          <a:noFill/>
+        </p:spPr>
+        <p:txBody>
+          <a:bodyPr wrap="square" anchor="t">
+            <a:spAutoFit/>
+          </a:bodyPr>
+          <a:lstStyle/>
+          <a:p>
+            <a:pPr algn="l"/>
+            <a:r>
+              <a:rPr sz="1400" b="1">
+                <a:solidFill>
+                  <a:srgbClr val="8C1515"/>
+                </a:solidFill>
+                <a:latin typeface="Calibri"/>
+              </a:rPr>
+              <a:t>EVIDENCE · VIBROTACTILE</a:t>
+            </a:r>
+          </a:p>
+        </p:txBody>
+      </p:sp>
       <p:sp>
         <p:nvSpPr>
           <p:cNvPr id="4" name="TextBox 3"/>
@@ -6108,8 +6261,86 @@
         </p:nvSpPr>
         <p:spPr>
           <a:xfrm>
-            <a:off x="914400" y="2468880"/>
-            <a:ext cx="10362895" cy="1371600"/>
+            <a:off x="548640" y="822960"/>
+            <a:ext cx="11094415" cy="1005840"/>
+          </a:xfrm>
+          <a:prstGeom prst="rect">
+            <a:avLst/>
+          </a:prstGeom>
+          <a:noFill/>
+        </p:spPr>
+        <p:txBody>
+          <a:bodyPr wrap="square" anchor="t">
+            <a:spAutoFit/>
+          </a:bodyPr>
+          <a:lstStyle/>
+          <a:p>
+            <a:pPr algn="l"/>
+            <a:r>
+              <a:rPr sz="2400" b="1">
+                <a:solidFill>
+                  <a:srgbClr val="2E2D29"/>
+                </a:solidFill>
+                <a:latin typeface="Calibri"/>
+              </a:rPr>
+              <a:t>The vibrotactile anchor: 40 Hz vibration helps in mouse AD models, and cortex codes vibration frequency</a:t>
+            </a:r>
+          </a:p>
+        </p:txBody>
+      </p:sp>
+      <p:sp>
+        <p:nvSpPr>
+          <p:cNvPr id="5" name="Rectangle 4"/>
+          <p:cNvSpPr/>
+          <p:nvPr/>
+        </p:nvSpPr>
+        <p:spPr>
+          <a:xfrm>
+            <a:off x="0" y="6035040"/>
+            <a:ext cx="12191695" cy="822960"/>
+          </a:xfrm>
+          <a:prstGeom prst="rect">
+            <a:avLst/>
+          </a:prstGeom>
+          <a:solidFill>
+            <a:srgbClr val="F4F4F4"/>
+          </a:solidFill>
+          <a:ln>
+            <a:noFill/>
+          </a:ln>
+        </p:spPr>
+        <p:style>
+          <a:lnRef idx="1">
+            <a:schemeClr val="accent1"/>
+          </a:lnRef>
+          <a:fillRef idx="3">
+            <a:schemeClr val="accent1"/>
+          </a:fillRef>
+          <a:effectRef idx="2">
+            <a:schemeClr val="accent1"/>
+          </a:effectRef>
+          <a:fontRef idx="minor">
+            <a:schemeClr val="lt1"/>
+          </a:fontRef>
+        </p:style>
+        <p:txBody>
+          <a:bodyPr rtlCol="0" anchor="ctr"/>
+          <a:lstStyle/>
+          <a:p>
+            <a:pPr algn="ctr"/>
+          </a:p>
+        </p:txBody>
+      </p:sp>
+      <p:sp>
+        <p:nvSpPr>
+          <p:cNvPr id="6" name="TextBox 5"/>
+          <p:cNvSpPr txBox="1"/>
+          <p:nvPr/>
+        </p:nvSpPr>
+        <p:spPr>
+          <a:xfrm>
+            <a:off x="548640" y="6062472"/>
+            <a:ext cx="11094415" cy="777240"/>
           </a:xfrm>
           <a:prstGeom prst="rect">
             <a:avLst/>
@@ -6124,27 +6355,27 @@
           <a:p>
             <a:pPr algn="l"/>
             <a:r>
-              <a:rPr sz="3400" b="1">
+              <a:rPr sz="1500" b="1">
                 <a:solidFill>
-                  <a:srgbClr val="FFFFFF"/>
+                  <a:srgbClr val="8C1515"/>
                 </a:solidFill>
                 <a:latin typeface="Calibri"/>
               </a:rPr>
-              <a:t>Part 3 · Does vibrotactile stimulation reach the brain? A first study</a:t>
-            </a:r>
-          </a:p>
-        </p:txBody>
-      </p:sp>
-      <p:sp>
-        <p:nvSpPr>
-          <p:cNvPr id="5" name="TextBox 4"/>
+              <a:t>40 Hz whole-body vibration reduces pathology and improves function in AD-model mice (Suk 2023). Somatosensory cortex faithfully encodes vibration frequency (Romo, Mountcastle) — vibrotactile input can carry a frequency code.</a:t>
+            </a:r>
+          </a:p>
+        </p:txBody>
+      </p:sp>
+      <p:sp>
+        <p:nvSpPr>
+          <p:cNvPr id="7" name="TextBox 6"/>
           <p:cNvSpPr txBox="1"/>
           <p:nvPr/>
         </p:nvSpPr>
         <p:spPr>
           <a:xfrm>
-            <a:off x="914400" y="3749039"/>
-            <a:ext cx="10362895" cy="914400"/>
+            <a:off x="10545775" y="246888"/>
+            <a:ext cx="1280160" cy="365760"/>
           </a:xfrm>
           <a:prstGeom prst="rect">
             <a:avLst/>
@@ -6157,50 +6388,15 @@
           </a:bodyPr>
           <a:lstStyle/>
           <a:p>
-            <a:pPr algn="l"/>
-            <a:r>
-              <a:rPr sz="1900" b="0">
+            <a:pPr algn="r"/>
+            <a:r>
+              <a:rPr sz="1100" b="0">
                 <a:solidFill>
-                  <a:srgbClr val="EDDDDD"/>
+                  <a:srgbClr val="53565A"/>
                 </a:solidFill>
                 <a:latin typeface="Calibri"/>
               </a:rPr>
-              <a:t>Foundational electrophysiology in the mouse — before any clearance claim</a:t>
-            </a:r>
-          </a:p>
-        </p:txBody>
-      </p:sp>
-      <p:sp>
-        <p:nvSpPr>
-          <p:cNvPr id="6" name="TextBox 5"/>
-          <p:cNvSpPr txBox="1"/>
-          <p:nvPr/>
-        </p:nvSpPr>
-        <p:spPr>
-          <a:xfrm>
-            <a:off x="10545775" y="246888"/>
-            <a:ext cx="1280160" cy="365760"/>
-          </a:xfrm>
-          <a:prstGeom prst="rect">
-            <a:avLst/>
-          </a:prstGeom>
-          <a:noFill/>
-        </p:spPr>
-        <p:txBody>
-          <a:bodyPr wrap="square" anchor="t">
-            <a:spAutoFit/>
-          </a:bodyPr>
-          <a:lstStyle/>
-          <a:p>
-            <a:pPr algn="r"/>
-            <a:r>
-              <a:rPr sz="1100" b="0">
-                <a:solidFill>
-                  <a:srgbClr val="FFFFFF"/>
-                </a:solidFill>
-                <a:latin typeface="Calibri"/>
-              </a:rPr>
-              <a:t>12 / 31</a:t>
+              <a:t>12 / 33</a:t>
             </a:r>
           </a:p>
         </p:txBody>
@@ -6275,6 +6471,41 @@
         <p:spPr>
           <a:xfrm>
             <a:off x="548640" y="411480"/>
+            <a:ext cx="11094415" cy="365760"/>
+          </a:xfrm>
+          <a:prstGeom prst="rect">
+            <a:avLst/>
+          </a:prstGeom>
+          <a:noFill/>
+        </p:spPr>
+        <p:txBody>
+          <a:bodyPr wrap="square" anchor="t">
+            <a:spAutoFit/>
+          </a:bodyPr>
+          <a:lstStyle/>
+          <a:p>
+            <a:pPr algn="l"/>
+            <a:r>
+              <a:rPr sz="1400" b="1">
+                <a:solidFill>
+                  <a:srgbClr val="8C1515"/>
+                </a:solidFill>
+                <a:latin typeface="Calibri"/>
+              </a:rPr>
+              <a:t>→ WHAT TO TEST</a:t>
+            </a:r>
+          </a:p>
+        </p:txBody>
+      </p:sp>
+      <p:sp>
+        <p:nvSpPr>
+          <p:cNvPr id="4" name="TextBox 3"/>
+          <p:cNvSpPr txBox="1"/>
+          <p:nvPr/>
+        </p:nvSpPr>
+        <p:spPr>
+          <a:xfrm>
+            <a:off x="548640" y="822960"/>
             <a:ext cx="11094415" cy="1005840"/>
           </a:xfrm>
           <a:prstGeom prst="rect">
@@ -6296,35 +6527,11 @@
                 </a:solidFill>
                 <a:latin typeface="Calibri"/>
               </a:rPr>
-              <a:t>Design: parametric vibrotactile stimulation with simultaneous electrophysiology</a:t>
-            </a:r>
-          </a:p>
-        </p:txBody>
-      </p:sp>
-      <p:pic>
-        <p:nvPicPr>
-          <p:cNvPr id="4" name="Picture 3" descr="trial_window_diagram.png"/>
-          <p:cNvPicPr>
-            <a:picLocks noChangeAspect="1"/>
-          </p:cNvPicPr>
-          <p:nvPr/>
-        </p:nvPicPr>
-        <p:blipFill>
-          <a:blip r:embed="rId2"/>
-          <a:stretch>
-            <a:fillRect/>
-          </a:stretch>
-        </p:blipFill>
-        <p:spPr>
-          <a:xfrm>
-            <a:off x="1514917" y="1554480"/>
-            <a:ext cx="9161859" cy="4343400"/>
-          </a:xfrm>
-          <a:prstGeom prst="rect">
-            <a:avLst/>
-          </a:prstGeom>
-        </p:spPr>
-      </p:pic>
+              <a:t>So which vibrotactile parameters should we test?</a:t>
+            </a:r>
+          </a:p>
+        </p:txBody>
+      </p:sp>
       <p:sp>
         <p:nvSpPr>
           <p:cNvPr id="5" name="Rectangle 4"/>
@@ -6398,7 +6605,7 @@
                 </a:solidFill>
                 <a:latin typeface="Calibri"/>
               </a:rPr>
-              <a:t>3 s ON / 3 s OFF blocks across four carrier frequencies (5/10/26/50 Hz) and three amplitudes; ~200 repeats/condition; dual-region linear-probe recording (hippocampus + entorhinal cortex).</a:t>
+              <a:t>40 Hz (gamma) · ~50 Hz (our electrophysiology, Part 3) · slow ~1 Hz / sleep-band (clearance biology) · steady vs coordinated-reset patterning · controls: 20 Hz, sham, matched salience.</a:t>
             </a:r>
           </a:p>
         </p:txBody>
@@ -6433,7 +6640,7 @@
                 </a:solidFill>
                 <a:latin typeface="Calibri"/>
               </a:rPr>
-              <a:t>13 / 31</a:t>
+              <a:t>13 / 33</a:t>
             </a:r>
           </a:p>
         </p:txBody>
@@ -6465,7 +6672,7 @@
         <p:spPr>
           <a:xfrm>
             <a:off x="0" y="0"/>
-            <a:ext cx="12191695" cy="164592"/>
+            <a:ext cx="12191695" cy="6858000"/>
           </a:xfrm>
           <a:prstGeom prst="rect">
             <a:avLst/>
@@ -6499,79 +6706,9 @@
           </a:p>
         </p:txBody>
       </p:sp>
-      <p:sp>
-        <p:nvSpPr>
-          <p:cNvPr id="3" name="TextBox 2"/>
-          <p:cNvSpPr txBox="1"/>
-          <p:nvPr/>
-        </p:nvSpPr>
-        <p:spPr>
-          <a:xfrm>
-            <a:off x="548640" y="411480"/>
-            <a:ext cx="11094415" cy="365760"/>
-          </a:xfrm>
-          <a:prstGeom prst="rect">
-            <a:avLst/>
-          </a:prstGeom>
-          <a:noFill/>
-        </p:spPr>
-        <p:txBody>
-          <a:bodyPr wrap="square" anchor="t">
-            <a:spAutoFit/>
-          </a:bodyPr>
-          <a:lstStyle/>
-          <a:p>
-            <a:pPr algn="l"/>
-            <a:r>
-              <a:rPr sz="1400" b="1">
-                <a:solidFill>
-                  <a:srgbClr val="8C1515"/>
-                </a:solidFill>
-                <a:latin typeface="Calibri"/>
-              </a:rPr>
-              <a:t>KEY METHODOLOGICAL DISTINCTION</a:t>
-            </a:r>
-          </a:p>
-        </p:txBody>
-      </p:sp>
-      <p:sp>
-        <p:nvSpPr>
-          <p:cNvPr id="4" name="TextBox 3"/>
-          <p:cNvSpPr txBox="1"/>
-          <p:nvPr/>
-        </p:nvSpPr>
-        <p:spPr>
-          <a:xfrm>
-            <a:off x="548640" y="822960"/>
-            <a:ext cx="11094415" cy="1005840"/>
-          </a:xfrm>
-          <a:prstGeom prst="rect">
-            <a:avLst/>
-          </a:prstGeom>
-          <a:noFill/>
-        </p:spPr>
-        <p:txBody>
-          <a:bodyPr wrap="square" anchor="t">
-            <a:spAutoFit/>
-          </a:bodyPr>
-          <a:lstStyle/>
-          <a:p>
-            <a:pPr algn="l"/>
-            <a:r>
-              <a:rPr sz="2400" b="1">
-                <a:solidFill>
-                  <a:srgbClr val="2E2D29"/>
-                </a:solidFill>
-                <a:latin typeface="Calibri"/>
-              </a:rPr>
-              <a:t>One electrode yields two readouts: LFP and single-unit activity</a:t>
-            </a:r>
-          </a:p>
-        </p:txBody>
-      </p:sp>
       <p:pic>
         <p:nvPicPr>
-          <p:cNvPr id="5" name="Picture 4" descr="stadium.png"/>
+          <p:cNvPr id="3" name="Picture 2" descr="som_logo_white.png"/>
           <p:cNvPicPr>
             <a:picLocks noChangeAspect="1"/>
           </p:cNvPicPr>
@@ -6585,8 +6722,8 @@
         </p:blipFill>
         <p:spPr>
           <a:xfrm>
-            <a:off x="2014140" y="1965960"/>
-            <a:ext cx="8163414" cy="3931920"/>
+            <a:off x="502920" y="457200"/>
+            <a:ext cx="2651760" cy="338836"/>
           </a:xfrm>
           <a:prstGeom prst="rect">
             <a:avLst/>
@@ -6595,57 +6732,14 @@
       </p:pic>
       <p:sp>
         <p:nvSpPr>
-          <p:cNvPr id="6" name="Rectangle 5"/>
-          <p:cNvSpPr/>
-          <p:nvPr/>
-        </p:nvSpPr>
-        <p:spPr>
-          <a:xfrm>
-            <a:off x="0" y="6035040"/>
-            <a:ext cx="12191695" cy="822960"/>
-          </a:xfrm>
-          <a:prstGeom prst="rect">
-            <a:avLst/>
-          </a:prstGeom>
-          <a:solidFill>
-            <a:srgbClr val="F4F4F4"/>
-          </a:solidFill>
-          <a:ln>
-            <a:noFill/>
-          </a:ln>
-        </p:spPr>
-        <p:style>
-          <a:lnRef idx="1">
-            <a:schemeClr val="accent1"/>
-          </a:lnRef>
-          <a:fillRef idx="3">
-            <a:schemeClr val="accent1"/>
-          </a:fillRef>
-          <a:effectRef idx="2">
-            <a:schemeClr val="accent1"/>
-          </a:effectRef>
-          <a:fontRef idx="minor">
-            <a:schemeClr val="lt1"/>
-          </a:fontRef>
-        </p:style>
-        <p:txBody>
-          <a:bodyPr rtlCol="0" anchor="ctr"/>
-          <a:lstStyle/>
-          <a:p>
-            <a:pPr algn="ctr"/>
-          </a:p>
-        </p:txBody>
-      </p:sp>
-      <p:sp>
-        <p:nvSpPr>
-          <p:cNvPr id="7" name="TextBox 6"/>
+          <p:cNvPr id="4" name="TextBox 3"/>
           <p:cNvSpPr txBox="1"/>
           <p:nvPr/>
         </p:nvSpPr>
         <p:spPr>
           <a:xfrm>
-            <a:off x="548640" y="6062472"/>
-            <a:ext cx="11094415" cy="777240"/>
+            <a:off x="914400" y="2468880"/>
+            <a:ext cx="10362895" cy="1371600"/>
           </a:xfrm>
           <a:prstGeom prst="rect">
             <a:avLst/>
@@ -6660,27 +6754,27 @@
           <a:p>
             <a:pPr algn="l"/>
             <a:r>
-              <a:rPr sz="1500" b="1">
+              <a:rPr sz="3400" b="1">
                 <a:solidFill>
-                  <a:srgbClr val="8C1515"/>
+                  <a:srgbClr val="FFFFFF"/>
                 </a:solidFill>
                 <a:latin typeface="Calibri"/>
               </a:rPr>
-              <a:t>LFP = low-frequency aggregate field (many cells). A single unit = one individual neuron's firing (spikes), isolated by spike sorting. They differ in what can fake them — spikes are the conservative readout.</a:t>
-            </a:r>
-          </a:p>
-        </p:txBody>
-      </p:sp>
-      <p:sp>
-        <p:nvSpPr>
-          <p:cNvPr id="8" name="TextBox 7"/>
+              <a:t>Part 3 · Does vibrotactile stimulation reach the brain? A first study</a:t>
+            </a:r>
+          </a:p>
+        </p:txBody>
+      </p:sp>
+      <p:sp>
+        <p:nvSpPr>
+          <p:cNvPr id="5" name="TextBox 4"/>
           <p:cNvSpPr txBox="1"/>
           <p:nvPr/>
         </p:nvSpPr>
         <p:spPr>
           <a:xfrm>
-            <a:off x="10545775" y="246888"/>
-            <a:ext cx="1280160" cy="365760"/>
+            <a:off x="914400" y="3749039"/>
+            <a:ext cx="10362895" cy="914400"/>
           </a:xfrm>
           <a:prstGeom prst="rect">
             <a:avLst/>
@@ -6693,15 +6787,50 @@
           </a:bodyPr>
           <a:lstStyle/>
           <a:p>
-            <a:pPr algn="r"/>
-            <a:r>
-              <a:rPr sz="1100" b="0">
+            <a:pPr algn="l"/>
+            <a:r>
+              <a:rPr sz="1900" b="0">
                 <a:solidFill>
-                  <a:srgbClr val="53565A"/>
+                  <a:srgbClr val="EDDDDD"/>
                 </a:solidFill>
                 <a:latin typeface="Calibri"/>
               </a:rPr>
-              <a:t>14 / 31</a:t>
+              <a:t>Foundational electrophysiology in the mouse — before any clearance claim</a:t>
+            </a:r>
+          </a:p>
+        </p:txBody>
+      </p:sp>
+      <p:sp>
+        <p:nvSpPr>
+          <p:cNvPr id="6" name="TextBox 5"/>
+          <p:cNvSpPr txBox="1"/>
+          <p:nvPr/>
+        </p:nvSpPr>
+        <p:spPr>
+          <a:xfrm>
+            <a:off x="10545775" y="246888"/>
+            <a:ext cx="1280160" cy="365760"/>
+          </a:xfrm>
+          <a:prstGeom prst="rect">
+            <a:avLst/>
+          </a:prstGeom>
+          <a:noFill/>
+        </p:spPr>
+        <p:txBody>
+          <a:bodyPr wrap="square" anchor="t">
+            <a:spAutoFit/>
+          </a:bodyPr>
+          <a:lstStyle/>
+          <a:p>
+            <a:pPr algn="r"/>
+            <a:r>
+              <a:rPr sz="1100" b="0">
+                <a:solidFill>
+                  <a:srgbClr val="FFFFFF"/>
+                </a:solidFill>
+                <a:latin typeface="Calibri"/>
+              </a:rPr>
+              <a:t>14 / 33</a:t>
             </a:r>
           </a:p>
         </p:txBody>
@@ -6776,41 +6905,6 @@
         <p:spPr>
           <a:xfrm>
             <a:off x="548640" y="411480"/>
-            <a:ext cx="11094415" cy="365760"/>
-          </a:xfrm>
-          <a:prstGeom prst="rect">
-            <a:avLst/>
-          </a:prstGeom>
-          <a:noFill/>
-        </p:spPr>
-        <p:txBody>
-          <a:bodyPr wrap="square" anchor="t">
-            <a:spAutoFit/>
-          </a:bodyPr>
-          <a:lstStyle/>
-          <a:p>
-            <a:pPr algn="l"/>
-            <a:r>
-              <a:rPr sz="1400" b="1">
-                <a:solidFill>
-                  <a:srgbClr val="8C1515"/>
-                </a:solidFill>
-                <a:latin typeface="Calibri"/>
-              </a:rPr>
-              <a:t>FINDING 1</a:t>
-            </a:r>
-          </a:p>
-        </p:txBody>
-      </p:sp>
-      <p:sp>
-        <p:nvSpPr>
-          <p:cNvPr id="4" name="TextBox 3"/>
-          <p:cNvSpPr txBox="1"/>
-          <p:nvPr/>
-        </p:nvSpPr>
-        <p:spPr>
-          <a:xfrm>
-            <a:off x="548640" y="822960"/>
             <a:ext cx="11094415" cy="1005840"/>
           </a:xfrm>
           <a:prstGeom prst="rect">
@@ -6832,14 +6926,14 @@
                 </a:solidFill>
                 <a:latin typeface="Calibri"/>
               </a:rPr>
-              <a:t>A robust LFP response — transition-weighted, not a sustained oscillation</a:t>
+              <a:t>Design: parametric vibrotactile stimulation with simultaneous electrophysiology</a:t>
             </a:r>
           </a:p>
         </p:txBody>
       </p:sp>
       <p:pic>
         <p:nvPicPr>
-          <p:cNvPr id="5" name="Picture 4" descr="transition_index_condition.png"/>
+          <p:cNvPr id="4" name="Picture 3" descr="trial_window_diagram.png"/>
           <p:cNvPicPr>
             <a:picLocks noChangeAspect="1"/>
           </p:cNvPicPr>
@@ -6853,8 +6947,8 @@
         </p:blipFill>
         <p:spPr>
           <a:xfrm>
-            <a:off x="2000097" y="1965960"/>
-            <a:ext cx="8191500" cy="3931920"/>
+            <a:off x="1514917" y="1554480"/>
+            <a:ext cx="9161859" cy="4343400"/>
           </a:xfrm>
           <a:prstGeom prst="rect">
             <a:avLst/>
@@ -6863,7 +6957,7 @@
       </p:pic>
       <p:sp>
         <p:nvSpPr>
-          <p:cNvPr id="6" name="Rectangle 5"/>
+          <p:cNvPr id="5" name="Rectangle 4"/>
           <p:cNvSpPr/>
           <p:nvPr/>
         </p:nvSpPr>
@@ -6906,7 +7000,7 @@
       </p:sp>
       <p:sp>
         <p:nvSpPr>
-          <p:cNvPr id="7" name="TextBox 6"/>
+          <p:cNvPr id="6" name="TextBox 5"/>
           <p:cNvSpPr txBox="1"/>
           <p:nvPr/>
         </p:nvSpPr>
@@ -6934,14 +7028,14 @@
                 </a:solidFill>
                 <a:latin typeface="Calibri"/>
               </a:rPr>
-              <a:t>The broadband LFP responds at stimulus onset/offset (an evoked transient), not as a sustained rhythm at the carrier frequency.</a:t>
-            </a:r>
-          </a:p>
-        </p:txBody>
-      </p:sp>
-      <p:sp>
-        <p:nvSpPr>
-          <p:cNvPr id="8" name="TextBox 7"/>
+              <a:t>3 s ON / 3 s OFF blocks across four carrier frequencies (5/10/26/50 Hz) and three amplitudes; ~200 repeats/condition; dual-region linear-probe recording (hippocampus + entorhinal cortex).</a:t>
+            </a:r>
+          </a:p>
+        </p:txBody>
+      </p:sp>
+      <p:sp>
+        <p:nvSpPr>
+          <p:cNvPr id="7" name="TextBox 6"/>
           <p:cNvSpPr txBox="1"/>
           <p:nvPr/>
         </p:nvSpPr>
@@ -6969,7 +7063,7 @@
                 </a:solidFill>
                 <a:latin typeface="Calibri"/>
               </a:rPr>
-              <a:t>15 / 31</a:t>
+              <a:t>15 / 33</a:t>
             </a:r>
           </a:p>
         </p:txBody>
@@ -7065,7 +7159,7 @@
                 </a:solidFill>
                 <a:latin typeface="Calibri"/>
               </a:rPr>
-              <a:t>FINDING 2</a:t>
+              <a:t>KEY METHODOLOGICAL DISTINCTION</a:t>
             </a:r>
           </a:p>
         </p:txBody>
@@ -7100,14 +7194,14 @@
                 </a:solidFill>
                 <a:latin typeface="Calibri"/>
               </a:rPr>
-              <a:t>No frequency-following in hippocampus at any carrier</a:t>
+              <a:t>One electrode yields two readouts: LFP and single-unit activity</a:t>
             </a:r>
           </a:p>
         </p:txBody>
       </p:sp>
       <p:pic>
         <p:nvPicPr>
-          <p:cNvPr id="5" name="Picture 4" descr="spectral_slope_itpc_dec4.png"/>
+          <p:cNvPr id="5" name="Picture 4" descr="stadium.png"/>
           <p:cNvPicPr>
             <a:picLocks noChangeAspect="1"/>
           </p:cNvPicPr>
@@ -7121,8 +7215,8 @@
         </p:blipFill>
         <p:spPr>
           <a:xfrm>
-            <a:off x="2819247" y="1965960"/>
-            <a:ext cx="6553200" cy="3931920"/>
+            <a:off x="2014140" y="1965960"/>
+            <a:ext cx="8163414" cy="3931920"/>
           </a:xfrm>
           <a:prstGeom prst="rect">
             <a:avLst/>
@@ -7202,7 +7296,7 @@
                 </a:solidFill>
                 <a:latin typeface="Calibri"/>
               </a:rPr>
-              <a:t>No narrowband spectral peak above the 1/f background, and inter-trial phase consistency at chance — across 5/10/26/50 Hz, replicated across sessions.</a:t>
+              <a:t>LFP = low-frequency aggregate field (many cells). A single unit = one individual neuron's firing (spikes), isolated by spike sorting. They differ in what can fake them — spikes are the conservative readout.</a:t>
             </a:r>
           </a:p>
         </p:txBody>
@@ -7237,7 +7331,7 @@
                 </a:solidFill>
                 <a:latin typeface="Calibri"/>
               </a:rPr>
-              <a:t>16 / 31</a:t>
+              <a:t>16 / 33</a:t>
             </a:r>
           </a:p>
         </p:txBody>
@@ -7333,7 +7427,7 @@
                 </a:solidFill>
                 <a:latin typeface="Calibri"/>
               </a:rPr>
-              <a:t>FINDING 3</a:t>
+              <a:t>FINDING 1</a:t>
             </a:r>
           </a:p>
         </p:txBody>
@@ -7368,14 +7462,14 @@
                 </a:solidFill>
                 <a:latin typeface="Calibri"/>
               </a:rPr>
-              <a:t>Entorhinal cortex shows an amplitude-graded 50 Hz LFP increase</a:t>
+              <a:t>A robust LFP response — transition-weighted, not a sustained oscillation</a:t>
             </a:r>
           </a:p>
         </p:txBody>
       </p:sp>
       <p:pic>
         <p:nvPicPr>
-          <p:cNvPr id="5" name="Picture 4" descr="driven_power_change_by_analysis_group.png"/>
+          <p:cNvPr id="5" name="Picture 4" descr="transition_index_condition.png"/>
           <p:cNvPicPr>
             <a:picLocks noChangeAspect="1"/>
           </p:cNvPicPr>
@@ -7389,8 +7483,8 @@
         </p:blipFill>
         <p:spPr>
           <a:xfrm>
-            <a:off x="731519" y="1965960"/>
-            <a:ext cx="10728655" cy="2043553"/>
+            <a:off x="2000097" y="1965960"/>
+            <a:ext cx="8191500" cy="3931920"/>
           </a:xfrm>
           <a:prstGeom prst="rect">
             <a:avLst/>
@@ -7470,7 +7564,7 @@
                 </a:solidFill>
                 <a:latin typeface="Calibri"/>
               </a:rPr>
-              <a:t>A narrowband 50 Hz LFP power increase, scaling with amplitude — the candidate entrainment signal. But the LFP is exactly the readout most vulnerable to artifact.</a:t>
+              <a:t>The broadband LFP responds at stimulus onset/offset (an evoked transient), not as a sustained rhythm at the carrier frequency.</a:t>
             </a:r>
           </a:p>
         </p:txBody>
@@ -7505,7 +7599,7 @@
                 </a:solidFill>
                 <a:latin typeface="Calibri"/>
               </a:rPr>
-              <a:t>17 / 31</a:t>
+              <a:t>17 / 33</a:t>
             </a:r>
           </a:p>
         </p:txBody>
@@ -7601,7 +7695,7 @@
                 </a:solidFill>
                 <a:latin typeface="Calibri"/>
               </a:rPr>
-              <a:t>THE CONFOUND</a:t>
+              <a:t>FINDING 2</a:t>
             </a:r>
           </a:p>
         </p:txBody>
@@ -7636,14 +7730,14 @@
                 </a:solidFill>
                 <a:latin typeface="Calibri"/>
               </a:rPr>
-              <a:t>The confound: stimulator-coupled 50 Hz electrical artifact</a:t>
+              <a:t>No frequency-following in hippocampus at any carrier</a:t>
             </a:r>
           </a:p>
         </p:txBody>
       </p:sp>
       <p:pic>
         <p:nvPicPr>
-          <p:cNvPr id="5" name="Picture 4" descr="trap.png"/>
+          <p:cNvPr id="5" name="Picture 4" descr="spectral_slope_itpc_dec4.png"/>
           <p:cNvPicPr>
             <a:picLocks noChangeAspect="1"/>
           </p:cNvPicPr>
@@ -7657,8 +7751,8 @@
         </p:blipFill>
         <p:spPr>
           <a:xfrm>
-            <a:off x="1774039" y="1965960"/>
-            <a:ext cx="8643615" cy="3931920"/>
+            <a:off x="2819247" y="1965960"/>
+            <a:ext cx="6553200" cy="3931920"/>
           </a:xfrm>
           <a:prstGeom prst="rect">
             <a:avLst/>
@@ -7738,7 +7832,7 @@
                 </a:solidFill>
                 <a:latin typeface="Calibri"/>
               </a:rPr>
-              <a:t>An electromechanical actuator can inject a 50 Hz electrical artifact directly into the recording — indistinguishable from a neural 50 Hz in the LFP alone.</a:t>
+              <a:t>No narrowband spectral peak above the 1/f background, and inter-trial phase consistency at chance — across 5/10/26/50 Hz, replicated across sessions.</a:t>
             </a:r>
           </a:p>
         </p:txBody>
@@ -7773,7 +7867,7 @@
                 </a:solidFill>
                 <a:latin typeface="Calibri"/>
               </a:rPr>
-              <a:t>18 / 31</a:t>
+              <a:t>18 / 33</a:t>
             </a:r>
           </a:p>
         </p:txBody>
@@ -7869,7 +7963,7 @@
                 </a:solidFill>
                 <a:latin typeface="Calibri"/>
               </a:rPr>
-              <a:t>FINDING 3, CONTROLLED</a:t>
+              <a:t>FINDING 3</a:t>
             </a:r>
           </a:p>
         </p:txBody>
@@ -7904,14 +7998,14 @@
                 </a:solidFill>
                 <a:latin typeface="Calibri"/>
               </a:rPr>
-              <a:t>Disconnected channels carry the 50 Hz — so it is largely pickup</a:t>
+              <a:t>Entorhinal cortex shows an amplitude-graded 50 Hz LFP increase</a:t>
             </a:r>
           </a:p>
         </p:txBody>
       </p:sp>
       <p:pic>
         <p:nvPicPr>
-          <p:cNvPr id="5" name="Picture 4" descr="50hz_pickup_gradient_dhpc_vs_lec.png"/>
+          <p:cNvPr id="5" name="Picture 4" descr="driven_power_change_by_analysis_group.png"/>
           <p:cNvPicPr>
             <a:picLocks noChangeAspect="1"/>
           </p:cNvPicPr>
@@ -7926,7 +8020,7 @@
         <p:spPr>
           <a:xfrm>
             <a:off x="731519" y="1965960"/>
-            <a:ext cx="10728655" cy="3796293"/>
+            <a:ext cx="10728655" cy="2043553"/>
           </a:xfrm>
           <a:prstGeom prst="rect">
             <a:avLst/>
@@ -8006,7 +8100,7 @@
                 </a:solidFill>
                 <a:latin typeface="Calibri"/>
               </a:rPr>
-              <a:t>Disconnected electrodes (which cannot record neural signal) show ~6× more 50 Hz than in-tissue channels. The entorhinal 50 Hz LFP is substantially artifact.</a:t>
+              <a:t>A narrowband 50 Hz LFP power increase, scaling with amplitude — the candidate entrainment signal. But the LFP is exactly the readout most vulnerable to artifact.</a:t>
             </a:r>
           </a:p>
         </p:txBody>
@@ -8041,7 +8135,7 @@
                 </a:solidFill>
                 <a:latin typeface="Calibri"/>
               </a:rPr>
-              <a:t>19 / 31</a:t>
+              <a:t>19 / 33</a:t>
             </a:r>
           </a:p>
         </p:txBody>
@@ -8196,7 +8290,7 @@
                 </a:solidFill>
                 <a:latin typeface="Calibri"/>
               </a:rPr>
-              <a:t>2 / 31</a:t>
+              <a:t>2 / 33</a:t>
             </a:r>
           </a:p>
         </p:txBody>
@@ -8292,7 +8386,7 @@
                 </a:solidFill>
                 <a:latin typeface="Calibri"/>
               </a:rPr>
-              <a:t>FINDING 4 — THE ROBUST RESULT</a:t>
+              <a:t>THE CONFOUND</a:t>
             </a:r>
           </a:p>
         </p:txBody>
@@ -8327,14 +8421,14 @@
                 </a:solidFill>
                 <a:latin typeface="Calibri"/>
               </a:rPr>
-              <a:t>Frequency-specific single-unit rate modulation at 50 Hz</a:t>
+              <a:t>The confound: stimulator-coupled 50 Hz electrical artifact</a:t>
             </a:r>
           </a:p>
         </p:txBody>
       </p:sp>
       <p:pic>
         <p:nvPicPr>
-          <p:cNvPr id="5" name="Picture 4" descr="spike_onoff_cross_dataset.png"/>
+          <p:cNvPr id="5" name="Picture 4" descr="trap.png"/>
           <p:cNvPicPr>
             <a:picLocks noChangeAspect="1"/>
           </p:cNvPicPr>
@@ -8348,8 +8442,8 @@
         </p:blipFill>
         <p:spPr>
           <a:xfrm>
-            <a:off x="731519" y="1965960"/>
-            <a:ext cx="10728655" cy="3121063"/>
+            <a:off x="1774039" y="1965960"/>
+            <a:ext cx="8643615" cy="3931920"/>
           </a:xfrm>
           <a:prstGeom prst="rect">
             <a:avLst/>
@@ -8429,7 +8523,7 @@
                 </a:solidFill>
                 <a:latin typeface="Calibri"/>
               </a:rPr>
-              <a:t>Sorted single units change firing rate during 50 Hz / high-amplitude stimulation, in both regions — an effect electrical pickup cannot produce.</a:t>
+              <a:t>An electromechanical actuator can inject a 50 Hz electrical artifact directly into the recording — indistinguishable from a neural 50 Hz in the LFP alone.</a:t>
             </a:r>
           </a:p>
         </p:txBody>
@@ -8464,7 +8558,7 @@
                 </a:solidFill>
                 <a:latin typeface="Calibri"/>
               </a:rPr>
-              <a:t>20 / 31</a:t>
+              <a:t>20 / 33</a:t>
             </a:r>
           </a:p>
         </p:txBody>
@@ -8560,7 +8654,7 @@
                 </a:solidFill>
                 <a:latin typeface="Calibri"/>
               </a:rPr>
-              <a:t>CONTROLS</a:t>
+              <a:t>FINDING 3, CONTROLLED</a:t>
             </a:r>
           </a:p>
         </p:txBody>
@@ -8595,14 +8689,14 @@
                 </a:solidFill>
                 <a:latin typeface="Calibri"/>
               </a:rPr>
-              <a:t>Controls: high-pass separation + autocorrelogram / ISI screens</a:t>
+              <a:t>Disconnected channels carry the 50 Hz — so it is largely pickup</a:t>
             </a:r>
           </a:p>
         </p:txBody>
       </p:sp>
       <p:pic>
         <p:nvPicPr>
-          <p:cNvPr id="5" name="Picture 4" descr="unit87_acg_artifact_screen.png"/>
+          <p:cNvPr id="5" name="Picture 4" descr="50hz_pickup_gradient_dhpc_vs_lec.png"/>
           <p:cNvPicPr>
             <a:picLocks noChangeAspect="1"/>
           </p:cNvPicPr>
@@ -8617,7 +8711,7 @@
         <p:spPr>
           <a:xfrm>
             <a:off x="731519" y="1965960"/>
-            <a:ext cx="10728655" cy="2795952"/>
+            <a:ext cx="10728655" cy="3796293"/>
           </a:xfrm>
           <a:prstGeom prst="rect">
             <a:avLst/>
@@ -8697,7 +8791,7 @@
                 </a:solidFill>
                 <a:latin typeface="Calibri"/>
               </a:rPr>
-              <a:t>Spikes are detected &gt;~300 Hz (50 Hz pickup is removed pre-detection); units show no stimulus-locked 50 Hz periodicity and no ON-rise in refractory violations.</a:t>
+              <a:t>Disconnected electrodes (which cannot record neural signal) show ~6× more 50 Hz than in-tissue channels. The entorhinal 50 Hz LFP is substantially artifact.</a:t>
             </a:r>
           </a:p>
         </p:txBody>
@@ -8732,7 +8826,7 @@
                 </a:solidFill>
                 <a:latin typeface="Calibri"/>
               </a:rPr>
-              <a:t>21 / 31</a:t>
+              <a:t>21 / 33</a:t>
             </a:r>
           </a:p>
         </p:txBody>
@@ -8828,7 +8922,7 @@
                 </a:solidFill>
                 <a:latin typeface="Calibri"/>
               </a:rPr>
-              <a:t>FINDING 5</a:t>
+              <a:t>FINDING 4 — THE ROBUST RESULT</a:t>
             </a:r>
           </a:p>
         </p:txBody>
@@ -8863,14 +8957,14 @@
                 </a:solidFill>
                 <a:latin typeface="Calibri"/>
               </a:rPr>
-              <a:t>Region-specific, bidirectional modulation — not a passive relay</a:t>
+              <a:t>Frequency-specific single-unit rate modulation at 50 Hz</a:t>
             </a:r>
           </a:p>
         </p:txBody>
       </p:sp>
       <p:pic>
         <p:nvPicPr>
-          <p:cNvPr id="5" name="Picture 4" descr="spike_50hz_interpretation.png"/>
+          <p:cNvPr id="5" name="Picture 4" descr="spike_onoff_cross_dataset.png"/>
           <p:cNvPicPr>
             <a:picLocks noChangeAspect="1"/>
           </p:cNvPicPr>
@@ -8884,8 +8978,8 @@
         </p:blipFill>
         <p:spPr>
           <a:xfrm>
-            <a:off x="2269624" y="1965960"/>
-            <a:ext cx="7652446" cy="3931920"/>
+            <a:off x="731519" y="1965960"/>
+            <a:ext cx="10728655" cy="3121063"/>
           </a:xfrm>
           <a:prstGeom prst="rect">
             <a:avLst/>
@@ -8965,7 +9059,7 @@
                 </a:solidFill>
                 <a:latin typeface="Calibri"/>
               </a:rPr>
-              <a:t>Hippocampus: a driven-up subset. Entorhinal cortex: net-suppressed. Opposite transformations of identical input argue for active, circuit-specific processing.</a:t>
+              <a:t>Sorted single units change firing rate during 50 Hz / high-amplitude stimulation, in both regions — an effect electrical pickup cannot produce.</a:t>
             </a:r>
           </a:p>
         </p:txBody>
@@ -9000,7 +9094,7 @@
                 </a:solidFill>
                 <a:latin typeface="Calibri"/>
               </a:rPr>
-              <a:t>22 / 31</a:t>
+              <a:t>22 / 33</a:t>
             </a:r>
           </a:p>
         </p:txBody>
@@ -9096,7 +9190,7 @@
                 </a:solidFill>
                 <a:latin typeface="Calibri"/>
               </a:rPr>
-              <a:t>FINDING 6</a:t>
+              <a:t>CONTROLS</a:t>
             </a:r>
           </a:p>
         </p:txBody>
@@ -9131,14 +9225,14 @@
                 </a:solidFill>
                 <a:latin typeface="Calibri"/>
               </a:rPr>
-              <a:t>No clear cross-regional coordination at 50 Hz</a:t>
+              <a:t>Controls: high-pass separation + autocorrelogram / ISI screens</a:t>
             </a:r>
           </a:p>
         </p:txBody>
       </p:sp>
       <p:pic>
         <p:nvPicPr>
-          <p:cNvPr id="5" name="Picture 4" descr="coordination_50hz_pooled.png"/>
+          <p:cNvPr id="5" name="Picture 4" descr="unit87_acg_artifact_screen.png"/>
           <p:cNvPicPr>
             <a:picLocks noChangeAspect="1"/>
           </p:cNvPicPr>
@@ -9152,8 +9246,8 @@
         </p:blipFill>
         <p:spPr>
           <a:xfrm>
-            <a:off x="880035" y="1965960"/>
-            <a:ext cx="10431624" cy="3931920"/>
+            <a:off x="731519" y="1965960"/>
+            <a:ext cx="10728655" cy="2795952"/>
           </a:xfrm>
           <a:prstGeom prst="rect">
             <a:avLst/>
@@ -9233,7 +9327,7 @@
                 </a:solidFill>
                 <a:latin typeface="Calibri"/>
               </a:rPr>
-              <a:t>LFP–LFP coherence rises, but the artifact-resistant cross-region spike–field measure does not — parsimoniously a shared signal, not interaction.</a:t>
+              <a:t>Spikes are detected &gt;~300 Hz (50 Hz pickup is removed pre-detection); units show no stimulus-locked 50 Hz periodicity and no ON-rise in refractory violations.</a:t>
             </a:r>
           </a:p>
         </p:txBody>
@@ -9268,7 +9362,7 @@
                 </a:solidFill>
                 <a:latin typeface="Calibri"/>
               </a:rPr>
-              <a:t>23 / 31</a:t>
+              <a:t>23 / 33</a:t>
             </a:r>
           </a:p>
         </p:txBody>
@@ -9300,7 +9394,7 @@
         <p:spPr>
           <a:xfrm>
             <a:off x="0" y="0"/>
-            <a:ext cx="12191695" cy="6858000"/>
+            <a:ext cx="12191695" cy="164592"/>
           </a:xfrm>
           <a:prstGeom prst="rect">
             <a:avLst/>
@@ -9334,9 +9428,79 @@
           </a:p>
         </p:txBody>
       </p:sp>
+      <p:sp>
+        <p:nvSpPr>
+          <p:cNvPr id="3" name="TextBox 2"/>
+          <p:cNvSpPr txBox="1"/>
+          <p:nvPr/>
+        </p:nvSpPr>
+        <p:spPr>
+          <a:xfrm>
+            <a:off x="548640" y="411480"/>
+            <a:ext cx="11094415" cy="365760"/>
+          </a:xfrm>
+          <a:prstGeom prst="rect">
+            <a:avLst/>
+          </a:prstGeom>
+          <a:noFill/>
+        </p:spPr>
+        <p:txBody>
+          <a:bodyPr wrap="square" anchor="t">
+            <a:spAutoFit/>
+          </a:bodyPr>
+          <a:lstStyle/>
+          <a:p>
+            <a:pPr algn="l"/>
+            <a:r>
+              <a:rPr sz="1400" b="1">
+                <a:solidFill>
+                  <a:srgbClr val="8C1515"/>
+                </a:solidFill>
+                <a:latin typeface="Calibri"/>
+              </a:rPr>
+              <a:t>FINDING 5</a:t>
+            </a:r>
+          </a:p>
+        </p:txBody>
+      </p:sp>
+      <p:sp>
+        <p:nvSpPr>
+          <p:cNvPr id="4" name="TextBox 3"/>
+          <p:cNvSpPr txBox="1"/>
+          <p:nvPr/>
+        </p:nvSpPr>
+        <p:spPr>
+          <a:xfrm>
+            <a:off x="548640" y="822960"/>
+            <a:ext cx="11094415" cy="1005840"/>
+          </a:xfrm>
+          <a:prstGeom prst="rect">
+            <a:avLst/>
+          </a:prstGeom>
+          <a:noFill/>
+        </p:spPr>
+        <p:txBody>
+          <a:bodyPr wrap="square" anchor="t">
+            <a:spAutoFit/>
+          </a:bodyPr>
+          <a:lstStyle/>
+          <a:p>
+            <a:pPr algn="l"/>
+            <a:r>
+              <a:rPr sz="2400" b="1">
+                <a:solidFill>
+                  <a:srgbClr val="2E2D29"/>
+                </a:solidFill>
+                <a:latin typeface="Calibri"/>
+              </a:rPr>
+              <a:t>Region-specific, bidirectional modulation — not a passive relay</a:t>
+            </a:r>
+          </a:p>
+        </p:txBody>
+      </p:sp>
       <p:pic>
         <p:nvPicPr>
-          <p:cNvPr id="3" name="Picture 2" descr="som_logo_white.png"/>
+          <p:cNvPr id="5" name="Picture 4" descr="spike_50hz_interpretation.png"/>
           <p:cNvPicPr>
             <a:picLocks noChangeAspect="1"/>
           </p:cNvPicPr>
@@ -9350,8 +9514,8 @@
         </p:blipFill>
         <p:spPr>
           <a:xfrm>
-            <a:off x="502920" y="457200"/>
-            <a:ext cx="2651760" cy="338836"/>
+            <a:off x="2269624" y="1965960"/>
+            <a:ext cx="7652446" cy="3931920"/>
           </a:xfrm>
           <a:prstGeom prst="rect">
             <a:avLst/>
@@ -9360,14 +9524,57 @@
       </p:pic>
       <p:sp>
         <p:nvSpPr>
-          <p:cNvPr id="4" name="TextBox 3"/>
+          <p:cNvPr id="6" name="Rectangle 5"/>
+          <p:cNvSpPr/>
+          <p:nvPr/>
+        </p:nvSpPr>
+        <p:spPr>
+          <a:xfrm>
+            <a:off x="0" y="6035040"/>
+            <a:ext cx="12191695" cy="822960"/>
+          </a:xfrm>
+          <a:prstGeom prst="rect">
+            <a:avLst/>
+          </a:prstGeom>
+          <a:solidFill>
+            <a:srgbClr val="F4F4F4"/>
+          </a:solidFill>
+          <a:ln>
+            <a:noFill/>
+          </a:ln>
+        </p:spPr>
+        <p:style>
+          <a:lnRef idx="1">
+            <a:schemeClr val="accent1"/>
+          </a:lnRef>
+          <a:fillRef idx="3">
+            <a:schemeClr val="accent1"/>
+          </a:fillRef>
+          <a:effectRef idx="2">
+            <a:schemeClr val="accent1"/>
+          </a:effectRef>
+          <a:fontRef idx="minor">
+            <a:schemeClr val="lt1"/>
+          </a:fontRef>
+        </p:style>
+        <p:txBody>
+          <a:bodyPr rtlCol="0" anchor="ctr"/>
+          <a:lstStyle/>
+          <a:p>
+            <a:pPr algn="ctr"/>
+          </a:p>
+        </p:txBody>
+      </p:sp>
+      <p:sp>
+        <p:nvSpPr>
+          <p:cNvPr id="7" name="TextBox 6"/>
           <p:cNvSpPr txBox="1"/>
           <p:nvPr/>
         </p:nvSpPr>
         <p:spPr>
           <a:xfrm>
-            <a:off x="914400" y="2468880"/>
-            <a:ext cx="10362895" cy="1371600"/>
+            <a:off x="548640" y="6062472"/>
+            <a:ext cx="11094415" cy="777240"/>
           </a:xfrm>
           <a:prstGeom prst="rect">
             <a:avLst/>
@@ -9382,20 +9589,20 @@
           <a:p>
             <a:pPr algn="l"/>
             <a:r>
-              <a:rPr sz="3400" b="1">
+              <a:rPr sz="1500" b="1">
                 <a:solidFill>
-                  <a:srgbClr val="FFFFFF"/>
+                  <a:srgbClr val="8C1515"/>
                 </a:solidFill>
                 <a:latin typeface="Calibri"/>
               </a:rPr>
-              <a:t>Part 4 · Limits, and the next study</a:t>
-            </a:r>
-          </a:p>
-        </p:txBody>
-      </p:sp>
-      <p:sp>
-        <p:nvSpPr>
-          <p:cNvPr id="5" name="TextBox 4"/>
+              <a:t>Hippocampus: a driven-up subset. Entorhinal cortex: net-suppressed. Opposite transformations of identical input argue for active, circuit-specific processing.</a:t>
+            </a:r>
+          </a:p>
+        </p:txBody>
+      </p:sp>
+      <p:sp>
+        <p:nvSpPr>
+          <p:cNvPr id="8" name="TextBox 7"/>
           <p:cNvSpPr txBox="1"/>
           <p:nvPr/>
         </p:nvSpPr>
@@ -9419,11 +9626,11 @@
             <a:r>
               <a:rPr sz="1100" b="0">
                 <a:solidFill>
-                  <a:srgbClr val="FFFFFF"/>
+                  <a:srgbClr val="53565A"/>
                 </a:solidFill>
                 <a:latin typeface="Calibri"/>
               </a:rPr>
-              <a:t>24 / 31</a:t>
+              <a:t>24 / 33</a:t>
             </a:r>
           </a:p>
         </p:txBody>
@@ -9519,7 +9726,7 @@
                 </a:solidFill>
                 <a:latin typeface="Calibri"/>
               </a:rPr>
-              <a:t>THE LIMITATION</a:t>
+              <a:t>FINDING 6</a:t>
             </a:r>
           </a:p>
         </p:txBody>
@@ -9554,14 +9761,38 @@
                 </a:solidFill>
                 <a:latin typeface="Calibri"/>
               </a:rPr>
-              <a:t>Entrainment was untestable — a measurement gap, not a null</a:t>
-            </a:r>
-          </a:p>
-        </p:txBody>
-      </p:sp>
-      <p:sp>
-        <p:nvSpPr>
-          <p:cNvPr id="5" name="Rectangle 4"/>
+              <a:t>No clear cross-regional coordination at 50 Hz</a:t>
+            </a:r>
+          </a:p>
+        </p:txBody>
+      </p:sp>
+      <p:pic>
+        <p:nvPicPr>
+          <p:cNvPr id="5" name="Picture 4" descr="coordination_50hz_pooled.png"/>
+          <p:cNvPicPr>
+            <a:picLocks noChangeAspect="1"/>
+          </p:cNvPicPr>
+          <p:nvPr/>
+        </p:nvPicPr>
+        <p:blipFill>
+          <a:blip r:embed="rId2"/>
+          <a:stretch>
+            <a:fillRect/>
+          </a:stretch>
+        </p:blipFill>
+        <p:spPr>
+          <a:xfrm>
+            <a:off x="880035" y="1965960"/>
+            <a:ext cx="10431624" cy="3931920"/>
+          </a:xfrm>
+          <a:prstGeom prst="rect">
+            <a:avLst/>
+          </a:prstGeom>
+        </p:spPr>
+      </p:pic>
+      <p:sp>
+        <p:nvSpPr>
+          <p:cNvPr id="6" name="Rectangle 5"/>
           <p:cNvSpPr/>
           <p:nvPr/>
         </p:nvSpPr>
@@ -9604,7 +9835,7 @@
       </p:sp>
       <p:sp>
         <p:nvSpPr>
-          <p:cNvPr id="6" name="TextBox 5"/>
+          <p:cNvPr id="7" name="TextBox 6"/>
           <p:cNvSpPr txBox="1"/>
           <p:nvPr/>
         </p:nvSpPr>
@@ -9632,14 +9863,14 @@
                 </a:solidFill>
                 <a:latin typeface="Calibri"/>
               </a:rPr>
-              <a:t>Our acquisition was not equipped to test entrainment: no time-aligned stimulus-phase reference was recorded — so phase-following is untestable here, not negative.</a:t>
-            </a:r>
-          </a:p>
-        </p:txBody>
-      </p:sp>
-      <p:sp>
-        <p:nvSpPr>
-          <p:cNvPr id="7" name="TextBox 6"/>
+              <a:t>LFP–LFP coherence rises, but the artifact-resistant cross-region spike–field measure does not — parsimoniously a shared signal, not interaction.</a:t>
+            </a:r>
+          </a:p>
+        </p:txBody>
+      </p:sp>
+      <p:sp>
+        <p:nvSpPr>
+          <p:cNvPr id="8" name="TextBox 7"/>
           <p:cNvSpPr txBox="1"/>
           <p:nvPr/>
         </p:nvSpPr>
@@ -9667,7 +9898,7 @@
                 </a:solidFill>
                 <a:latin typeface="Calibri"/>
               </a:rPr>
-              <a:t>25 / 31</a:t>
+              <a:t>25 / 33</a:t>
             </a:r>
           </a:p>
         </p:txBody>
@@ -9699,7 +9930,7 @@
         <p:spPr>
           <a:xfrm>
             <a:off x="0" y="0"/>
-            <a:ext cx="12191695" cy="164592"/>
+            <a:ext cx="12191695" cy="6858000"/>
           </a:xfrm>
           <a:prstGeom prst="rect">
             <a:avLst/>
@@ -9733,79 +9964,9 @@
           </a:p>
         </p:txBody>
       </p:sp>
-      <p:sp>
-        <p:nvSpPr>
-          <p:cNvPr id="3" name="TextBox 2"/>
-          <p:cNvSpPr txBox="1"/>
-          <p:nvPr/>
-        </p:nvSpPr>
-        <p:spPr>
-          <a:xfrm>
-            <a:off x="548640" y="411480"/>
-            <a:ext cx="11094415" cy="365760"/>
-          </a:xfrm>
-          <a:prstGeom prst="rect">
-            <a:avLst/>
-          </a:prstGeom>
-          <a:noFill/>
-        </p:spPr>
-        <p:txBody>
-          <a:bodyPr wrap="square" anchor="t">
-            <a:spAutoFit/>
-          </a:bodyPr>
-          <a:lstStyle/>
-          <a:p>
-            <a:pPr algn="l"/>
-            <a:r>
-              <a:rPr sz="1400" b="1">
-                <a:solidFill>
-                  <a:srgbClr val="8C1515"/>
-                </a:solidFill>
-                <a:latin typeface="Calibri"/>
-              </a:rPr>
-              <a:t>DIAGNOSIS</a:t>
-            </a:r>
-          </a:p>
-        </p:txBody>
-      </p:sp>
-      <p:sp>
-        <p:nvSpPr>
-          <p:cNvPr id="4" name="TextBox 3"/>
-          <p:cNvSpPr txBox="1"/>
-          <p:nvPr/>
-        </p:nvSpPr>
-        <p:spPr>
-          <a:xfrm>
-            <a:off x="548640" y="822960"/>
-            <a:ext cx="11094415" cy="1005840"/>
-          </a:xfrm>
-          <a:prstGeom prst="rect">
-            <a:avLst/>
-          </a:prstGeom>
-          <a:noFill/>
-        </p:spPr>
-        <p:txBody>
-          <a:bodyPr wrap="square" anchor="t">
-            <a:spAutoFit/>
-          </a:bodyPr>
-          <a:lstStyle/>
-          <a:p>
-            <a:pPr algn="l"/>
-            <a:r>
-              <a:rPr sz="2400" b="1">
-                <a:solidFill>
-                  <a:srgbClr val="2E2D29"/>
-                </a:solidFill>
-                <a:latin typeface="Calibri"/>
-              </a:rPr>
-              <a:t>The digital sync channel never captured the carrier</a:t>
-            </a:r>
-          </a:p>
-        </p:txBody>
-      </p:sp>
       <p:pic>
         <p:nvPicPr>
-          <p:cNvPr id="5" name="Picture 4" descr="ttl_cannot_recover_tactor_phase.png"/>
+          <p:cNvPr id="3" name="Picture 2" descr="som_logo_white.png"/>
           <p:cNvPicPr>
             <a:picLocks noChangeAspect="1"/>
           </p:cNvPicPr>
@@ -9819,8 +9980,8 @@
         </p:blipFill>
         <p:spPr>
           <a:xfrm>
-            <a:off x="2546197" y="1965960"/>
-            <a:ext cx="7099300" cy="3931920"/>
+            <a:off x="502920" y="457200"/>
+            <a:ext cx="2651760" cy="338836"/>
           </a:xfrm>
           <a:prstGeom prst="rect">
             <a:avLst/>
@@ -9829,57 +9990,14 @@
       </p:pic>
       <p:sp>
         <p:nvSpPr>
-          <p:cNvPr id="6" name="Rectangle 5"/>
-          <p:cNvSpPr/>
-          <p:nvPr/>
-        </p:nvSpPr>
-        <p:spPr>
-          <a:xfrm>
-            <a:off x="0" y="6035040"/>
-            <a:ext cx="12191695" cy="822960"/>
-          </a:xfrm>
-          <a:prstGeom prst="rect">
-            <a:avLst/>
-          </a:prstGeom>
-          <a:solidFill>
-            <a:srgbClr val="F4F4F4"/>
-          </a:solidFill>
-          <a:ln>
-            <a:noFill/>
-          </a:ln>
-        </p:spPr>
-        <p:style>
-          <a:lnRef idx="1">
-            <a:schemeClr val="accent1"/>
-          </a:lnRef>
-          <a:fillRef idx="3">
-            <a:schemeClr val="accent1"/>
-          </a:fillRef>
-          <a:effectRef idx="2">
-            <a:schemeClr val="accent1"/>
-          </a:effectRef>
-          <a:fontRef idx="minor">
-            <a:schemeClr val="lt1"/>
-          </a:fontRef>
-        </p:style>
-        <p:txBody>
-          <a:bodyPr rtlCol="0" anchor="ctr"/>
-          <a:lstStyle/>
-          <a:p>
-            <a:pPr algn="ctr"/>
-          </a:p>
-        </p:txBody>
-      </p:sp>
-      <p:sp>
-        <p:nvSpPr>
-          <p:cNvPr id="7" name="TextBox 6"/>
+          <p:cNvPr id="4" name="TextBox 3"/>
           <p:cNvSpPr txBox="1"/>
           <p:nvPr/>
         </p:nvSpPr>
         <p:spPr>
           <a:xfrm>
-            <a:off x="548640" y="6062472"/>
-            <a:ext cx="11094415" cy="777240"/>
+            <a:off x="914400" y="2468880"/>
+            <a:ext cx="10362895" cy="1371600"/>
           </a:xfrm>
           <a:prstGeom prst="rect">
             <a:avLst/>
@@ -9894,20 +10012,20 @@
           <a:p>
             <a:pPr algn="l"/>
             <a:r>
-              <a:rPr sz="1500" b="1">
+              <a:rPr sz="3400" b="1">
                 <a:solidFill>
-                  <a:srgbClr val="8C1515"/>
+                  <a:srgbClr val="FFFFFF"/>
                 </a:solidFill>
                 <a:latin typeface="Calibri"/>
               </a:rPr>
-              <a:t>The recorded sync line updated at ~4 Hz, independent of carrier (identical pulse counts at 5 vs 26 Hz; ~78 expected at 26 Hz). No phase reference exists in the data.</a:t>
-            </a:r>
-          </a:p>
-        </p:txBody>
-      </p:sp>
-      <p:sp>
-        <p:nvSpPr>
-          <p:cNvPr id="8" name="TextBox 7"/>
+              <a:t>Part 4 · Limits, and the next study</a:t>
+            </a:r>
+          </a:p>
+        </p:txBody>
+      </p:sp>
+      <p:sp>
+        <p:nvSpPr>
+          <p:cNvPr id="5" name="TextBox 4"/>
           <p:cNvSpPr txBox="1"/>
           <p:nvPr/>
         </p:nvSpPr>
@@ -9931,11 +10049,11 @@
             <a:r>
               <a:rPr sz="1100" b="0">
                 <a:solidFill>
-                  <a:srgbClr val="53565A"/>
+                  <a:srgbClr val="FFFFFF"/>
                 </a:solidFill>
                 <a:latin typeface="Calibri"/>
               </a:rPr>
-              <a:t>26 / 31</a:t>
+              <a:t>26 / 33</a:t>
             </a:r>
           </a:p>
         </p:txBody>
@@ -10031,7 +10149,7 @@
                 </a:solidFill>
                 <a:latin typeface="Calibri"/>
               </a:rPr>
-              <a:t>THE FIX</a:t>
+              <a:t>THE LIMITATION</a:t>
             </a:r>
           </a:p>
         </p:txBody>
@@ -10066,38 +10184,14 @@
                 </a:solidFill>
                 <a:latin typeface="Calibri"/>
               </a:rPr>
-              <a:t>Fix: redundant, clock-shared stimulus references</a:t>
-            </a:r>
-          </a:p>
-        </p:txBody>
-      </p:sp>
-      <p:pic>
-        <p:nvPicPr>
-          <p:cNvPr id="5" name="Picture 4" descr="fix.png"/>
-          <p:cNvPicPr>
-            <a:picLocks noChangeAspect="1"/>
-          </p:cNvPicPr>
-          <p:nvPr/>
-        </p:nvPicPr>
-        <p:blipFill>
-          <a:blip r:embed="rId2"/>
-          <a:stretch>
-            <a:fillRect/>
-          </a:stretch>
-        </p:blipFill>
-        <p:spPr>
-          <a:xfrm>
-            <a:off x="2179739" y="1965960"/>
-            <a:ext cx="7832215" cy="3931920"/>
-          </a:xfrm>
-          <a:prstGeom prst="rect">
-            <a:avLst/>
-          </a:prstGeom>
-        </p:spPr>
-      </p:pic>
-      <p:sp>
-        <p:nvSpPr>
-          <p:cNvPr id="6" name="Rectangle 5"/>
+              <a:t>Entrainment was untestable — a measurement gap, not a null</a:t>
+            </a:r>
+          </a:p>
+        </p:txBody>
+      </p:sp>
+      <p:sp>
+        <p:nvSpPr>
+          <p:cNvPr id="5" name="Rectangle 4"/>
           <p:cNvSpPr/>
           <p:nvPr/>
         </p:nvSpPr>
@@ -10140,7 +10234,7 @@
       </p:sp>
       <p:sp>
         <p:nvSpPr>
-          <p:cNvPr id="7" name="TextBox 6"/>
+          <p:cNvPr id="6" name="TextBox 5"/>
           <p:cNvSpPr txBox="1"/>
           <p:nvPr/>
         </p:nvSpPr>
@@ -10168,14 +10262,14 @@
                 </a:solidFill>
                 <a:latin typeface="Calibri"/>
               </a:rPr>
-              <a:t>Firmware per-cycle sync + a transduced force/accelerometer signal + a drive-signal copy, all on the acquisition clock — cross-checked, with pre-session verification.</a:t>
-            </a:r>
-          </a:p>
-        </p:txBody>
-      </p:sp>
-      <p:sp>
-        <p:nvSpPr>
-          <p:cNvPr id="8" name="TextBox 7"/>
+              <a:t>Our acquisition was not equipped to test entrainment: no time-aligned stimulus-phase reference was recorded — so phase-following is untestable here, not negative.</a:t>
+            </a:r>
+          </a:p>
+        </p:txBody>
+      </p:sp>
+      <p:sp>
+        <p:nvSpPr>
+          <p:cNvPr id="7" name="TextBox 6"/>
           <p:cNvSpPr txBox="1"/>
           <p:nvPr/>
         </p:nvSpPr>
@@ -10203,7 +10297,7 @@
                 </a:solidFill>
                 <a:latin typeface="Calibri"/>
               </a:rPr>
-              <a:t>27 / 31</a:t>
+              <a:t>27 / 33</a:t>
             </a:r>
           </a:p>
         </p:txBody>
@@ -10235,7 +10329,7 @@
         <p:spPr>
           <a:xfrm>
             <a:off x="0" y="0"/>
-            <a:ext cx="12191695" cy="6858000"/>
+            <a:ext cx="12191695" cy="164592"/>
           </a:xfrm>
           <a:prstGeom prst="rect">
             <a:avLst/>
@@ -10269,9 +10363,79 @@
           </a:p>
         </p:txBody>
       </p:sp>
+      <p:sp>
+        <p:nvSpPr>
+          <p:cNvPr id="3" name="TextBox 2"/>
+          <p:cNvSpPr txBox="1"/>
+          <p:nvPr/>
+        </p:nvSpPr>
+        <p:spPr>
+          <a:xfrm>
+            <a:off x="548640" y="411480"/>
+            <a:ext cx="11094415" cy="365760"/>
+          </a:xfrm>
+          <a:prstGeom prst="rect">
+            <a:avLst/>
+          </a:prstGeom>
+          <a:noFill/>
+        </p:spPr>
+        <p:txBody>
+          <a:bodyPr wrap="square" anchor="t">
+            <a:spAutoFit/>
+          </a:bodyPr>
+          <a:lstStyle/>
+          <a:p>
+            <a:pPr algn="l"/>
+            <a:r>
+              <a:rPr sz="1400" b="1">
+                <a:solidFill>
+                  <a:srgbClr val="8C1515"/>
+                </a:solidFill>
+                <a:latin typeface="Calibri"/>
+              </a:rPr>
+              <a:t>DIAGNOSIS</a:t>
+            </a:r>
+          </a:p>
+        </p:txBody>
+      </p:sp>
+      <p:sp>
+        <p:nvSpPr>
+          <p:cNvPr id="4" name="TextBox 3"/>
+          <p:cNvSpPr txBox="1"/>
+          <p:nvPr/>
+        </p:nvSpPr>
+        <p:spPr>
+          <a:xfrm>
+            <a:off x="548640" y="822960"/>
+            <a:ext cx="11094415" cy="1005840"/>
+          </a:xfrm>
+          <a:prstGeom prst="rect">
+            <a:avLst/>
+          </a:prstGeom>
+          <a:noFill/>
+        </p:spPr>
+        <p:txBody>
+          <a:bodyPr wrap="square" anchor="t">
+            <a:spAutoFit/>
+          </a:bodyPr>
+          <a:lstStyle/>
+          <a:p>
+            <a:pPr algn="l"/>
+            <a:r>
+              <a:rPr sz="2400" b="1">
+                <a:solidFill>
+                  <a:srgbClr val="2E2D29"/>
+                </a:solidFill>
+                <a:latin typeface="Calibri"/>
+              </a:rPr>
+              <a:t>The digital sync channel never captured the carrier</a:t>
+            </a:r>
+          </a:p>
+        </p:txBody>
+      </p:sp>
       <p:pic>
         <p:nvPicPr>
-          <p:cNvPr id="3" name="Picture 2" descr="som_logo_white.png"/>
+          <p:cNvPr id="5" name="Picture 4" descr="ttl_cannot_recover_tactor_phase.png"/>
           <p:cNvPicPr>
             <a:picLocks noChangeAspect="1"/>
           </p:cNvPicPr>
@@ -10285,8 +10449,8 @@
         </p:blipFill>
         <p:spPr>
           <a:xfrm>
-            <a:off x="502920" y="457200"/>
-            <a:ext cx="2651760" cy="338836"/>
+            <a:off x="2546197" y="1965960"/>
+            <a:ext cx="7099300" cy="3931920"/>
           </a:xfrm>
           <a:prstGeom prst="rect">
             <a:avLst/>
@@ -10295,14 +10459,57 @@
       </p:pic>
       <p:sp>
         <p:nvSpPr>
-          <p:cNvPr id="4" name="TextBox 3"/>
+          <p:cNvPr id="6" name="Rectangle 5"/>
+          <p:cNvSpPr/>
+          <p:nvPr/>
+        </p:nvSpPr>
+        <p:spPr>
+          <a:xfrm>
+            <a:off x="0" y="6035040"/>
+            <a:ext cx="12191695" cy="822960"/>
+          </a:xfrm>
+          <a:prstGeom prst="rect">
+            <a:avLst/>
+          </a:prstGeom>
+          <a:solidFill>
+            <a:srgbClr val="F4F4F4"/>
+          </a:solidFill>
+          <a:ln>
+            <a:noFill/>
+          </a:ln>
+        </p:spPr>
+        <p:style>
+          <a:lnRef idx="1">
+            <a:schemeClr val="accent1"/>
+          </a:lnRef>
+          <a:fillRef idx="3">
+            <a:schemeClr val="accent1"/>
+          </a:fillRef>
+          <a:effectRef idx="2">
+            <a:schemeClr val="accent1"/>
+          </a:effectRef>
+          <a:fontRef idx="minor">
+            <a:schemeClr val="lt1"/>
+          </a:fontRef>
+        </p:style>
+        <p:txBody>
+          <a:bodyPr rtlCol="0" anchor="ctr"/>
+          <a:lstStyle/>
+          <a:p>
+            <a:pPr algn="ctr"/>
+          </a:p>
+        </p:txBody>
+      </p:sp>
+      <p:sp>
+        <p:nvSpPr>
+          <p:cNvPr id="7" name="TextBox 6"/>
           <p:cNvSpPr txBox="1"/>
           <p:nvPr/>
         </p:nvSpPr>
         <p:spPr>
           <a:xfrm>
-            <a:off x="914400" y="2468880"/>
-            <a:ext cx="10362895" cy="1371600"/>
+            <a:off x="548640" y="6062472"/>
+            <a:ext cx="11094415" cy="777240"/>
           </a:xfrm>
           <a:prstGeom prst="rect">
             <a:avLst/>
@@ -10317,20 +10524,20 @@
           <a:p>
             <a:pPr algn="l"/>
             <a:r>
-              <a:rPr sz="3400" b="1">
+              <a:rPr sz="1500" b="1">
                 <a:solidFill>
-                  <a:srgbClr val="FFFFFF"/>
+                  <a:srgbClr val="8C1515"/>
                 </a:solidFill>
                 <a:latin typeface="Calibri"/>
               </a:rPr>
-              <a:t>Part 5 · How it fits the program</a:t>
-            </a:r>
-          </a:p>
-        </p:txBody>
-      </p:sp>
-      <p:sp>
-        <p:nvSpPr>
-          <p:cNvPr id="5" name="TextBox 4"/>
+              <a:t>The recorded sync line updated at ~4 Hz, independent of carrier (identical pulse counts at 5 vs 26 Hz; ~78 expected at 26 Hz). No phase reference exists in the data.</a:t>
+            </a:r>
+          </a:p>
+        </p:txBody>
+      </p:sp>
+      <p:sp>
+        <p:nvSpPr>
+          <p:cNvPr id="8" name="TextBox 7"/>
           <p:cNvSpPr txBox="1"/>
           <p:nvPr/>
         </p:nvSpPr>
@@ -10354,11 +10561,11 @@
             <a:r>
               <a:rPr sz="1100" b="0">
                 <a:solidFill>
-                  <a:srgbClr val="FFFFFF"/>
+                  <a:srgbClr val="53565A"/>
                 </a:solidFill>
                 <a:latin typeface="Calibri"/>
               </a:rPr>
-              <a:t>28 / 31</a:t>
+              <a:t>28 / 33</a:t>
             </a:r>
           </a:p>
         </p:txBody>
@@ -10454,7 +10661,7 @@
                 </a:solidFill>
                 <a:latin typeface="Calibri"/>
               </a:rPr>
-              <a:t>THE ROLE OF THIS STUDY</a:t>
+              <a:t>THE FIX</a:t>
             </a:r>
           </a:p>
         </p:txBody>
@@ -10489,14 +10696,38 @@
                 </a:solidFill>
                 <a:latin typeface="Calibri"/>
               </a:rPr>
-              <a:t>This study de-risks the program's core premise</a:t>
-            </a:r>
-          </a:p>
-        </p:txBody>
-      </p:sp>
-      <p:sp>
-        <p:nvSpPr>
-          <p:cNvPr id="5" name="Rectangle 4"/>
+              <a:t>Fix: redundant, clock-shared stimulus references</a:t>
+            </a:r>
+          </a:p>
+        </p:txBody>
+      </p:sp>
+      <p:pic>
+        <p:nvPicPr>
+          <p:cNvPr id="5" name="Picture 4" descr="fix.png"/>
+          <p:cNvPicPr>
+            <a:picLocks noChangeAspect="1"/>
+          </p:cNvPicPr>
+          <p:nvPr/>
+        </p:nvPicPr>
+        <p:blipFill>
+          <a:blip r:embed="rId2"/>
+          <a:stretch>
+            <a:fillRect/>
+          </a:stretch>
+        </p:blipFill>
+        <p:spPr>
+          <a:xfrm>
+            <a:off x="2179739" y="1965960"/>
+            <a:ext cx="7832215" cy="3931920"/>
+          </a:xfrm>
+          <a:prstGeom prst="rect">
+            <a:avLst/>
+          </a:prstGeom>
+        </p:spPr>
+      </p:pic>
+      <p:sp>
+        <p:nvSpPr>
+          <p:cNvPr id="6" name="Rectangle 5"/>
           <p:cNvSpPr/>
           <p:nvPr/>
         </p:nvSpPr>
@@ -10539,7 +10770,7 @@
       </p:sp>
       <p:sp>
         <p:nvSpPr>
-          <p:cNvPr id="6" name="TextBox 5"/>
+          <p:cNvPr id="7" name="TextBox 6"/>
           <p:cNvSpPr txBox="1"/>
           <p:nvPr/>
         </p:nvSpPr>
@@ -10567,14 +10798,14 @@
                 </a:solidFill>
                 <a:latin typeface="Calibri"/>
               </a:rPr>
-              <a:t>It shows peripheral vibration reaches AD-relevant medial-temporal circuits and that those neurons are frequency-tuned (peak ~50 Hz) — directly answering the 'steady-state ≠ engagement' objection.</a:t>
-            </a:r>
-          </a:p>
-        </p:txBody>
-      </p:sp>
-      <p:sp>
-        <p:nvSpPr>
-          <p:cNvPr id="7" name="TextBox 6"/>
+              <a:t>Firmware per-cycle sync + a transduced force/accelerometer signal + a drive-signal copy, all on the acquisition clock — cross-checked, with pre-session verification.</a:t>
+            </a:r>
+          </a:p>
+        </p:txBody>
+      </p:sp>
+      <p:sp>
+        <p:nvSpPr>
+          <p:cNvPr id="8" name="TextBox 7"/>
           <p:cNvSpPr txBox="1"/>
           <p:nvPr/>
         </p:nvSpPr>
@@ -10602,7 +10833,7 @@
                 </a:solidFill>
                 <a:latin typeface="Calibri"/>
               </a:rPr>
-              <a:t>29 / 31</a:t>
+              <a:t>29 / 33</a:t>
             </a:r>
           </a:p>
         </p:txBody>
@@ -10835,7 +11066,7 @@
                 </a:solidFill>
                 <a:latin typeface="Calibri"/>
               </a:rPr>
-              <a:t>The strongest non-drug clinical evidence today is multidomain lifestyle (FINGER, US POINTER). Non-invasive stimulation is largely unproven — which is the opportunity.</a:t>
+              <a:t>The strongest non-drug clinical evidence today is multidomain lifestyle (FINGER, Ngandu 2015; US POINTER, Baker 2025). Non-invasive stimulation is largely unproven — which is the opportunity.</a:t>
             </a:r>
           </a:p>
         </p:txBody>
@@ -10870,7 +11101,7 @@
                 </a:solidFill>
                 <a:latin typeface="Calibri"/>
               </a:rPr>
-              <a:t>3 / 31</a:t>
+              <a:t>3 / 33</a:t>
             </a:r>
           </a:p>
         </p:txBody>
@@ -10902,7 +11133,7 @@
         <p:spPr>
           <a:xfrm>
             <a:off x="0" y="0"/>
-            <a:ext cx="12191695" cy="164592"/>
+            <a:ext cx="12191695" cy="6858000"/>
           </a:xfrm>
           <a:prstGeom prst="rect">
             <a:avLst/>
@@ -10936,16 +11167,75 @@
           </a:p>
         </p:txBody>
       </p:sp>
-      <p:sp>
-        <p:nvSpPr>
-          <p:cNvPr id="3" name="TextBox 2"/>
+      <p:pic>
+        <p:nvPicPr>
+          <p:cNvPr id="3" name="Picture 2" descr="som_logo_white.png"/>
+          <p:cNvPicPr>
+            <a:picLocks noChangeAspect="1"/>
+          </p:cNvPicPr>
+          <p:nvPr/>
+        </p:nvPicPr>
+        <p:blipFill>
+          <a:blip r:embed="rId2"/>
+          <a:stretch>
+            <a:fillRect/>
+          </a:stretch>
+        </p:blipFill>
+        <p:spPr>
+          <a:xfrm>
+            <a:off x="502920" y="457200"/>
+            <a:ext cx="2651760" cy="338836"/>
+          </a:xfrm>
+          <a:prstGeom prst="rect">
+            <a:avLst/>
+          </a:prstGeom>
+        </p:spPr>
+      </p:pic>
+      <p:sp>
+        <p:nvSpPr>
+          <p:cNvPr id="4" name="TextBox 3"/>
           <p:cNvSpPr txBox="1"/>
           <p:nvPr/>
         </p:nvSpPr>
         <p:spPr>
           <a:xfrm>
-            <a:off x="548640" y="411480"/>
-            <a:ext cx="11094415" cy="365760"/>
+            <a:off x="914400" y="2468880"/>
+            <a:ext cx="10362895" cy="1371600"/>
+          </a:xfrm>
+          <a:prstGeom prst="rect">
+            <a:avLst/>
+          </a:prstGeom>
+          <a:noFill/>
+        </p:spPr>
+        <p:txBody>
+          <a:bodyPr wrap="square" anchor="ctr">
+            <a:spAutoFit/>
+          </a:bodyPr>
+          <a:lstStyle/>
+          <a:p>
+            <a:pPr algn="l"/>
+            <a:r>
+              <a:rPr sz="3400" b="1">
+                <a:solidFill>
+                  <a:srgbClr val="FFFFFF"/>
+                </a:solidFill>
+                <a:latin typeface="Calibri"/>
+              </a:rPr>
+              <a:t>Part 5 · How it fits the program</a:t>
+            </a:r>
+          </a:p>
+        </p:txBody>
+      </p:sp>
+      <p:sp>
+        <p:nvSpPr>
+          <p:cNvPr id="5" name="TextBox 4"/>
+          <p:cNvSpPr txBox="1"/>
+          <p:nvPr/>
+        </p:nvSpPr>
+        <p:spPr>
+          <a:xfrm>
+            <a:off x="10545775" y="246888"/>
+            <a:ext cx="1280160" cy="365760"/>
           </a:xfrm>
           <a:prstGeom prst="rect">
             <a:avLst/>
@@ -10958,163 +11248,15 @@
           </a:bodyPr>
           <a:lstStyle/>
           <a:p>
-            <a:pPr algn="l"/>
-            <a:r>
-              <a:rPr sz="1400" b="1">
+            <a:pPr algn="r"/>
+            <a:r>
+              <a:rPr sz="1100" b="0">
                 <a:solidFill>
-                  <a:srgbClr val="8C1515"/>
+                  <a:srgbClr val="FFFFFF"/>
                 </a:solidFill>
                 <a:latin typeface="Calibri"/>
               </a:rPr>
-              <a:t>KEY REFERENCES</a:t>
-            </a:r>
-          </a:p>
-        </p:txBody>
-      </p:sp>
-      <p:sp>
-        <p:nvSpPr>
-          <p:cNvPr id="4" name="TextBox 3"/>
-          <p:cNvSpPr txBox="1"/>
-          <p:nvPr/>
-        </p:nvSpPr>
-        <p:spPr>
-          <a:xfrm>
-            <a:off x="548640" y="822960"/>
-            <a:ext cx="11094415" cy="1005840"/>
-          </a:xfrm>
-          <a:prstGeom prst="rect">
-            <a:avLst/>
-          </a:prstGeom>
-          <a:noFill/>
-        </p:spPr>
-        <p:txBody>
-          <a:bodyPr wrap="square" anchor="t">
-            <a:spAutoFit/>
-          </a:bodyPr>
-          <a:lstStyle/>
-          <a:p>
-            <a:pPr algn="l"/>
-            <a:r>
-              <a:rPr sz="2400" b="1">
-                <a:solidFill>
-                  <a:srgbClr val="2E2D29"/>
-                </a:solidFill>
-                <a:latin typeface="Calibri"/>
-              </a:rPr>
-              <a:t>Key references</a:t>
-            </a:r>
-          </a:p>
-        </p:txBody>
-      </p:sp>
-      <p:sp>
-        <p:nvSpPr>
-          <p:cNvPr id="5" name="Rectangle 4"/>
-          <p:cNvSpPr/>
-          <p:nvPr/>
-        </p:nvSpPr>
-        <p:spPr>
-          <a:xfrm>
-            <a:off x="0" y="6035040"/>
-            <a:ext cx="12191695" cy="822960"/>
-          </a:xfrm>
-          <a:prstGeom prst="rect">
-            <a:avLst/>
-          </a:prstGeom>
-          <a:solidFill>
-            <a:srgbClr val="F4F4F4"/>
-          </a:solidFill>
-          <a:ln>
-            <a:noFill/>
-          </a:ln>
-        </p:spPr>
-        <p:style>
-          <a:lnRef idx="1">
-            <a:schemeClr val="accent1"/>
-          </a:lnRef>
-          <a:fillRef idx="3">
-            <a:schemeClr val="accent1"/>
-          </a:fillRef>
-          <a:effectRef idx="2">
-            <a:schemeClr val="accent1"/>
-          </a:effectRef>
-          <a:fontRef idx="minor">
-            <a:schemeClr val="lt1"/>
-          </a:fontRef>
-        </p:style>
-        <p:txBody>
-          <a:bodyPr rtlCol="0" anchor="ctr"/>
-          <a:lstStyle/>
-          <a:p>
-            <a:pPr algn="ctr"/>
-          </a:p>
-        </p:txBody>
-      </p:sp>
-      <p:sp>
-        <p:nvSpPr>
-          <p:cNvPr id="6" name="TextBox 5"/>
-          <p:cNvSpPr txBox="1"/>
-          <p:nvPr/>
-        </p:nvSpPr>
-        <p:spPr>
-          <a:xfrm>
-            <a:off x="548640" y="6062472"/>
-            <a:ext cx="11094415" cy="777240"/>
-          </a:xfrm>
-          <a:prstGeom prst="rect">
-            <a:avLst/>
-          </a:prstGeom>
-          <a:noFill/>
-        </p:spPr>
-        <p:txBody>
-          <a:bodyPr wrap="square" anchor="ctr">
-            <a:spAutoFit/>
-          </a:bodyPr>
-          <a:lstStyle/>
-          <a:p>
-            <a:pPr algn="l"/>
-            <a:r>
-              <a:rPr sz="1500" b="1">
-                <a:solidFill>
-                  <a:srgbClr val="8C1515"/>
-                </a:solidFill>
-                <a:latin typeface="Calibri"/>
-              </a:rPr>
-              <a:t>GENUS / Tsai 2016 · Murdock 2024 (gamma → glymphatic) · Suk 2023 (40 Hz tactile) · Jiang-Xie–Kipnis 2024 (neural dynamics → CSF) · + Buzsáki / Soula (steady-state ≠ entrainment).</a:t>
-            </a:r>
-          </a:p>
-        </p:txBody>
-      </p:sp>
-      <p:sp>
-        <p:nvSpPr>
-          <p:cNvPr id="7" name="TextBox 6"/>
-          <p:cNvSpPr txBox="1"/>
-          <p:nvPr/>
-        </p:nvSpPr>
-        <p:spPr>
-          <a:xfrm>
-            <a:off x="10545775" y="246888"/>
-            <a:ext cx="1280160" cy="365760"/>
-          </a:xfrm>
-          <a:prstGeom prst="rect">
-            <a:avLst/>
-          </a:prstGeom>
-          <a:noFill/>
-        </p:spPr>
-        <p:txBody>
-          <a:bodyPr wrap="square" anchor="t">
-            <a:spAutoFit/>
-          </a:bodyPr>
-          <a:lstStyle/>
-          <a:p>
-            <a:pPr algn="r"/>
-            <a:r>
-              <a:rPr sz="1100" b="0">
-                <a:solidFill>
-                  <a:srgbClr val="53565A"/>
-                </a:solidFill>
-                <a:latin typeface="Calibri"/>
-              </a:rPr>
-              <a:t>30 / 31</a:t>
+              <a:t>30 / 33</a:t>
             </a:r>
           </a:p>
         </p:txBody>
@@ -11146,6 +11288,494 @@
         <p:spPr>
           <a:xfrm>
             <a:off x="0" y="0"/>
+            <a:ext cx="12191695" cy="164592"/>
+          </a:xfrm>
+          <a:prstGeom prst="rect">
+            <a:avLst/>
+          </a:prstGeom>
+          <a:solidFill>
+            <a:srgbClr val="8C1515"/>
+          </a:solidFill>
+          <a:ln>
+            <a:noFill/>
+          </a:ln>
+        </p:spPr>
+        <p:style>
+          <a:lnRef idx="1">
+            <a:schemeClr val="accent1"/>
+          </a:lnRef>
+          <a:fillRef idx="3">
+            <a:schemeClr val="accent1"/>
+          </a:fillRef>
+          <a:effectRef idx="2">
+            <a:schemeClr val="accent1"/>
+          </a:effectRef>
+          <a:fontRef idx="minor">
+            <a:schemeClr val="lt1"/>
+          </a:fontRef>
+        </p:style>
+        <p:txBody>
+          <a:bodyPr rtlCol="0" anchor="ctr"/>
+          <a:lstStyle/>
+          <a:p>
+            <a:pPr algn="ctr"/>
+          </a:p>
+        </p:txBody>
+      </p:sp>
+      <p:sp>
+        <p:nvSpPr>
+          <p:cNvPr id="3" name="TextBox 2"/>
+          <p:cNvSpPr txBox="1"/>
+          <p:nvPr/>
+        </p:nvSpPr>
+        <p:spPr>
+          <a:xfrm>
+            <a:off x="548640" y="411480"/>
+            <a:ext cx="11094415" cy="365760"/>
+          </a:xfrm>
+          <a:prstGeom prst="rect">
+            <a:avLst/>
+          </a:prstGeom>
+          <a:noFill/>
+        </p:spPr>
+        <p:txBody>
+          <a:bodyPr wrap="square" anchor="t">
+            <a:spAutoFit/>
+          </a:bodyPr>
+          <a:lstStyle/>
+          <a:p>
+            <a:pPr algn="l"/>
+            <a:r>
+              <a:rPr sz="1400" b="1">
+                <a:solidFill>
+                  <a:srgbClr val="8C1515"/>
+                </a:solidFill>
+                <a:latin typeface="Calibri"/>
+              </a:rPr>
+              <a:t>THE ROLE OF THIS STUDY</a:t>
+            </a:r>
+          </a:p>
+        </p:txBody>
+      </p:sp>
+      <p:sp>
+        <p:nvSpPr>
+          <p:cNvPr id="4" name="TextBox 3"/>
+          <p:cNvSpPr txBox="1"/>
+          <p:nvPr/>
+        </p:nvSpPr>
+        <p:spPr>
+          <a:xfrm>
+            <a:off x="548640" y="822960"/>
+            <a:ext cx="11094415" cy="1005840"/>
+          </a:xfrm>
+          <a:prstGeom prst="rect">
+            <a:avLst/>
+          </a:prstGeom>
+          <a:noFill/>
+        </p:spPr>
+        <p:txBody>
+          <a:bodyPr wrap="square" anchor="t">
+            <a:spAutoFit/>
+          </a:bodyPr>
+          <a:lstStyle/>
+          <a:p>
+            <a:pPr algn="l"/>
+            <a:r>
+              <a:rPr sz="2400" b="1">
+                <a:solidFill>
+                  <a:srgbClr val="2E2D29"/>
+                </a:solidFill>
+                <a:latin typeface="Calibri"/>
+              </a:rPr>
+              <a:t>This study de-risks the program's core premise</a:t>
+            </a:r>
+          </a:p>
+        </p:txBody>
+      </p:sp>
+      <p:sp>
+        <p:nvSpPr>
+          <p:cNvPr id="5" name="Rectangle 4"/>
+          <p:cNvSpPr/>
+          <p:nvPr/>
+        </p:nvSpPr>
+        <p:spPr>
+          <a:xfrm>
+            <a:off x="0" y="6035040"/>
+            <a:ext cx="12191695" cy="822960"/>
+          </a:xfrm>
+          <a:prstGeom prst="rect">
+            <a:avLst/>
+          </a:prstGeom>
+          <a:solidFill>
+            <a:srgbClr val="F4F4F4"/>
+          </a:solidFill>
+          <a:ln>
+            <a:noFill/>
+          </a:ln>
+        </p:spPr>
+        <p:style>
+          <a:lnRef idx="1">
+            <a:schemeClr val="accent1"/>
+          </a:lnRef>
+          <a:fillRef idx="3">
+            <a:schemeClr val="accent1"/>
+          </a:fillRef>
+          <a:effectRef idx="2">
+            <a:schemeClr val="accent1"/>
+          </a:effectRef>
+          <a:fontRef idx="minor">
+            <a:schemeClr val="lt1"/>
+          </a:fontRef>
+        </p:style>
+        <p:txBody>
+          <a:bodyPr rtlCol="0" anchor="ctr"/>
+          <a:lstStyle/>
+          <a:p>
+            <a:pPr algn="ctr"/>
+          </a:p>
+        </p:txBody>
+      </p:sp>
+      <p:sp>
+        <p:nvSpPr>
+          <p:cNvPr id="6" name="TextBox 5"/>
+          <p:cNvSpPr txBox="1"/>
+          <p:nvPr/>
+        </p:nvSpPr>
+        <p:spPr>
+          <a:xfrm>
+            <a:off x="548640" y="6062472"/>
+            <a:ext cx="11094415" cy="777240"/>
+          </a:xfrm>
+          <a:prstGeom prst="rect">
+            <a:avLst/>
+          </a:prstGeom>
+          <a:noFill/>
+        </p:spPr>
+        <p:txBody>
+          <a:bodyPr wrap="square" anchor="ctr">
+            <a:spAutoFit/>
+          </a:bodyPr>
+          <a:lstStyle/>
+          <a:p>
+            <a:pPr algn="l"/>
+            <a:r>
+              <a:rPr sz="1500" b="1">
+                <a:solidFill>
+                  <a:srgbClr val="8C1515"/>
+                </a:solidFill>
+                <a:latin typeface="Calibri"/>
+              </a:rPr>
+              <a:t>It shows peripheral vibration reaches AD-relevant medial-temporal circuits and that those neurons are frequency-tuned (peak ~50 Hz) — directly answering the 'steady-state ≠ engagement' objection.</a:t>
+            </a:r>
+          </a:p>
+        </p:txBody>
+      </p:sp>
+      <p:sp>
+        <p:nvSpPr>
+          <p:cNvPr id="7" name="TextBox 6"/>
+          <p:cNvSpPr txBox="1"/>
+          <p:nvPr/>
+        </p:nvSpPr>
+        <p:spPr>
+          <a:xfrm>
+            <a:off x="10545775" y="246888"/>
+            <a:ext cx="1280160" cy="365760"/>
+          </a:xfrm>
+          <a:prstGeom prst="rect">
+            <a:avLst/>
+          </a:prstGeom>
+          <a:noFill/>
+        </p:spPr>
+        <p:txBody>
+          <a:bodyPr wrap="square" anchor="t">
+            <a:spAutoFit/>
+          </a:bodyPr>
+          <a:lstStyle/>
+          <a:p>
+            <a:pPr algn="r"/>
+            <a:r>
+              <a:rPr sz="1100" b="0">
+                <a:solidFill>
+                  <a:srgbClr val="53565A"/>
+                </a:solidFill>
+                <a:latin typeface="Calibri"/>
+              </a:rPr>
+              <a:t>31 / 33</a:t>
+            </a:r>
+          </a:p>
+        </p:txBody>
+      </p:sp>
+    </p:spTree>
+  </p:cSld>
+  <p:clrMapOvr>
+    <a:masterClrMapping/>
+  </p:clrMapOvr>
+</p:sld>
+</file>
+
+<file path=ppt/slides/slide32.xml><?xml version="1.0" encoding="utf-8"?>
+<p:sld xmlns:a="http://schemas.openxmlformats.org/drawingml/2006/main" xmlns:p="http://schemas.openxmlformats.org/presentationml/2006/main" xmlns:r="http://schemas.openxmlformats.org/officeDocument/2006/relationships">
+  <p:cSld>
+    <p:spTree>
+      <p:nvGrpSpPr>
+        <p:cNvPr id="1" name=""/>
+        <p:cNvGrpSpPr/>
+        <p:nvPr/>
+      </p:nvGrpSpPr>
+      <p:grpSpPr/>
+      <p:sp>
+        <p:nvSpPr>
+          <p:cNvPr id="2" name="Rectangle 1"/>
+          <p:cNvSpPr/>
+          <p:nvPr/>
+        </p:nvSpPr>
+        <p:spPr>
+          <a:xfrm>
+            <a:off x="0" y="0"/>
+            <a:ext cx="12191695" cy="164592"/>
+          </a:xfrm>
+          <a:prstGeom prst="rect">
+            <a:avLst/>
+          </a:prstGeom>
+          <a:solidFill>
+            <a:srgbClr val="8C1515"/>
+          </a:solidFill>
+          <a:ln>
+            <a:noFill/>
+          </a:ln>
+        </p:spPr>
+        <p:style>
+          <a:lnRef idx="1">
+            <a:schemeClr val="accent1"/>
+          </a:lnRef>
+          <a:fillRef idx="3">
+            <a:schemeClr val="accent1"/>
+          </a:fillRef>
+          <a:effectRef idx="2">
+            <a:schemeClr val="accent1"/>
+          </a:effectRef>
+          <a:fontRef idx="minor">
+            <a:schemeClr val="lt1"/>
+          </a:fontRef>
+        </p:style>
+        <p:txBody>
+          <a:bodyPr rtlCol="0" anchor="ctr"/>
+          <a:lstStyle/>
+          <a:p>
+            <a:pPr algn="ctr"/>
+          </a:p>
+        </p:txBody>
+      </p:sp>
+      <p:sp>
+        <p:nvSpPr>
+          <p:cNvPr id="3" name="TextBox 2"/>
+          <p:cNvSpPr txBox="1"/>
+          <p:nvPr/>
+        </p:nvSpPr>
+        <p:spPr>
+          <a:xfrm>
+            <a:off x="548640" y="411480"/>
+            <a:ext cx="11094415" cy="365760"/>
+          </a:xfrm>
+          <a:prstGeom prst="rect">
+            <a:avLst/>
+          </a:prstGeom>
+          <a:noFill/>
+        </p:spPr>
+        <p:txBody>
+          <a:bodyPr wrap="square" anchor="t">
+            <a:spAutoFit/>
+          </a:bodyPr>
+          <a:lstStyle/>
+          <a:p>
+            <a:pPr algn="l"/>
+            <a:r>
+              <a:rPr sz="1400" b="1">
+                <a:solidFill>
+                  <a:srgbClr val="8C1515"/>
+                </a:solidFill>
+                <a:latin typeface="Calibri"/>
+              </a:rPr>
+              <a:t>KEY REFERENCES</a:t>
+            </a:r>
+          </a:p>
+        </p:txBody>
+      </p:sp>
+      <p:sp>
+        <p:nvSpPr>
+          <p:cNvPr id="4" name="TextBox 3"/>
+          <p:cNvSpPr txBox="1"/>
+          <p:nvPr/>
+        </p:nvSpPr>
+        <p:spPr>
+          <a:xfrm>
+            <a:off x="548640" y="822960"/>
+            <a:ext cx="11094415" cy="1005840"/>
+          </a:xfrm>
+          <a:prstGeom prst="rect">
+            <a:avLst/>
+          </a:prstGeom>
+          <a:noFill/>
+        </p:spPr>
+        <p:txBody>
+          <a:bodyPr wrap="square" anchor="t">
+            <a:spAutoFit/>
+          </a:bodyPr>
+          <a:lstStyle/>
+          <a:p>
+            <a:pPr algn="l"/>
+            <a:r>
+              <a:rPr sz="2400" b="1">
+                <a:solidFill>
+                  <a:srgbClr val="2E2D29"/>
+                </a:solidFill>
+                <a:latin typeface="Calibri"/>
+              </a:rPr>
+              <a:t>Key references</a:t>
+            </a:r>
+          </a:p>
+        </p:txBody>
+      </p:sp>
+      <p:sp>
+        <p:nvSpPr>
+          <p:cNvPr id="5" name="Rectangle 4"/>
+          <p:cNvSpPr/>
+          <p:nvPr/>
+        </p:nvSpPr>
+        <p:spPr>
+          <a:xfrm>
+            <a:off x="0" y="6035040"/>
+            <a:ext cx="12191695" cy="822960"/>
+          </a:xfrm>
+          <a:prstGeom prst="rect">
+            <a:avLst/>
+          </a:prstGeom>
+          <a:solidFill>
+            <a:srgbClr val="F4F4F4"/>
+          </a:solidFill>
+          <a:ln>
+            <a:noFill/>
+          </a:ln>
+        </p:spPr>
+        <p:style>
+          <a:lnRef idx="1">
+            <a:schemeClr val="accent1"/>
+          </a:lnRef>
+          <a:fillRef idx="3">
+            <a:schemeClr val="accent1"/>
+          </a:fillRef>
+          <a:effectRef idx="2">
+            <a:schemeClr val="accent1"/>
+          </a:effectRef>
+          <a:fontRef idx="minor">
+            <a:schemeClr val="lt1"/>
+          </a:fontRef>
+        </p:style>
+        <p:txBody>
+          <a:bodyPr rtlCol="0" anchor="ctr"/>
+          <a:lstStyle/>
+          <a:p>
+            <a:pPr algn="ctr"/>
+          </a:p>
+        </p:txBody>
+      </p:sp>
+      <p:sp>
+        <p:nvSpPr>
+          <p:cNvPr id="6" name="TextBox 5"/>
+          <p:cNvSpPr txBox="1"/>
+          <p:nvPr/>
+        </p:nvSpPr>
+        <p:spPr>
+          <a:xfrm>
+            <a:off x="548640" y="6062472"/>
+            <a:ext cx="11094415" cy="777240"/>
+          </a:xfrm>
+          <a:prstGeom prst="rect">
+            <a:avLst/>
+          </a:prstGeom>
+          <a:noFill/>
+        </p:spPr>
+        <p:txBody>
+          <a:bodyPr wrap="square" anchor="ctr">
+            <a:spAutoFit/>
+          </a:bodyPr>
+          <a:lstStyle/>
+          <a:p>
+            <a:pPr algn="l"/>
+            <a:r>
+              <a:rPr sz="1500" b="1">
+                <a:solidFill>
+                  <a:srgbClr val="8C1515"/>
+                </a:solidFill>
+                <a:latin typeface="Calibri"/>
+              </a:rPr>
+              <a:t>Lifestyle: Ngandu 2015 (FINGER) · Baker 2025 (US POINTER).  Clearance: Iliff 2012 · Xie 2013 · Mawuenyega 2010 · Murdock 2024 (40 Hz → glymphatic) · Aryal 2022 / Azadian 2025 (focused ultrasound).  Stimulation: Tsai 2016 (GENUS) · Suk 2023 (40 Hz tactile) · Jiang-Xie–Kipnis 2024 (neural dynamics → CSF).  Guardrail: Buzsáki / Soula (steady-state ≠ entrainment).</a:t>
+            </a:r>
+          </a:p>
+        </p:txBody>
+      </p:sp>
+      <p:sp>
+        <p:nvSpPr>
+          <p:cNvPr id="7" name="TextBox 6"/>
+          <p:cNvSpPr txBox="1"/>
+          <p:nvPr/>
+        </p:nvSpPr>
+        <p:spPr>
+          <a:xfrm>
+            <a:off x="10545775" y="246888"/>
+            <a:ext cx="1280160" cy="365760"/>
+          </a:xfrm>
+          <a:prstGeom prst="rect">
+            <a:avLst/>
+          </a:prstGeom>
+          <a:noFill/>
+        </p:spPr>
+        <p:txBody>
+          <a:bodyPr wrap="square" anchor="t">
+            <a:spAutoFit/>
+          </a:bodyPr>
+          <a:lstStyle/>
+          <a:p>
+            <a:pPr algn="r"/>
+            <a:r>
+              <a:rPr sz="1100" b="0">
+                <a:solidFill>
+                  <a:srgbClr val="53565A"/>
+                </a:solidFill>
+                <a:latin typeface="Calibri"/>
+              </a:rPr>
+              <a:t>32 / 33</a:t>
+            </a:r>
+          </a:p>
+        </p:txBody>
+      </p:sp>
+    </p:spTree>
+  </p:cSld>
+  <p:clrMapOvr>
+    <a:masterClrMapping/>
+  </p:clrMapOvr>
+</p:sld>
+</file>
+
+<file path=ppt/slides/slide33.xml><?xml version="1.0" encoding="utf-8"?>
+<p:sld xmlns:a="http://schemas.openxmlformats.org/drawingml/2006/main" xmlns:p="http://schemas.openxmlformats.org/presentationml/2006/main" xmlns:r="http://schemas.openxmlformats.org/officeDocument/2006/relationships">
+  <p:cSld>
+    <p:spTree>
+      <p:nvGrpSpPr>
+        <p:cNvPr id="1" name=""/>
+        <p:cNvGrpSpPr/>
+        <p:nvPr/>
+      </p:nvGrpSpPr>
+      <p:grpSpPr/>
+      <p:sp>
+        <p:nvSpPr>
+          <p:cNvPr id="2" name="Rectangle 1"/>
+          <p:cNvSpPr/>
+          <p:nvPr/>
+        </p:nvSpPr>
+        <p:spPr>
+          <a:xfrm>
+            <a:off x="0" y="0"/>
             <a:ext cx="12191695" cy="6858000"/>
           </a:xfrm>
           <a:prstGeom prst="rect">
@@ -11347,7 +11977,7 @@
                 </a:solidFill>
                 <a:latin typeface="Calibri"/>
               </a:rPr>
-              <a:t>31 / 31</a:t>
+              <a:t>33 / 33</a:t>
             </a:r>
           </a:p>
         </p:txBody>
@@ -11443,7 +12073,7 @@
                 </a:solidFill>
                 <a:latin typeface="Calibri"/>
               </a:rPr>
-              <a:t>THE THESIS</a:t>
+              <a:t>WHY CLEARANCE</a:t>
             </a:r>
           </a:p>
         </p:txBody>
@@ -11478,14 +12108,14 @@
                 </a:solidFill>
                 <a:latin typeface="Calibri"/>
               </a:rPr>
-              <a:t>The proposal: use vibrotactile stimulation to engage brain rhythms and drive clearance</a:t>
+              <a:t>A leading hypothesis: failing glymphatic clearance lets amyloid build up</a:t>
             </a:r>
           </a:p>
         </p:txBody>
       </p:sp>
       <p:pic>
         <p:nvPicPr>
-          <p:cNvPr id="5" name="Picture 4" descr="vision_chain.png"/>
+          <p:cNvPr id="5" name="Picture 4" descr="glymphatic.png"/>
           <p:cNvPicPr>
             <a:picLocks noChangeAspect="1"/>
           </p:cNvPicPr>
@@ -11499,8 +12129,8 @@
         </p:blipFill>
         <p:spPr>
           <a:xfrm>
-            <a:off x="731519" y="1965960"/>
-            <a:ext cx="10728655" cy="3177187"/>
+            <a:off x="1582399" y="1965960"/>
+            <a:ext cx="9026895" cy="3931920"/>
           </a:xfrm>
           <a:prstGeom prst="rect">
             <a:avLst/>
@@ -11580,7 +12210,7 @@
                 </a:solidFill>
                 <a:latin typeface="Calibri"/>
               </a:rPr>
-              <a:t>Wearable vibrotactile stimulation → entrain brain rhythms → engage glymphatic clearance of amyloid-β / tau. A mechanism hypothesis — explicitly not yet a treatment claim.</a:t>
+              <a:t>The brain clears amyloid-β / tau via CSF–interstitial exchange (the glymphatic system), boosted by sleep and vascular pulsation. Impaired clearance is a leading — but still-unsettled — explanation for AD (Iliff 2012; Xie 2013; DTI-ALPS, ADNI 2024).</a:t>
             </a:r>
           </a:p>
         </p:txBody>
@@ -11615,7 +12245,7 @@
                 </a:solidFill>
                 <a:latin typeface="Calibri"/>
               </a:rPr>
-              <a:t>4 / 31</a:t>
+              <a:t>4 / 33</a:t>
             </a:r>
           </a:p>
         </p:txBody>
@@ -11711,7 +12341,7 @@
                 </a:solidFill>
                 <a:latin typeface="Calibri"/>
               </a:rPr>
-              <a:t>WHY VIBROTACTILE</a:t>
+              <a:t>AND IT CAN BE DRIVEN</a:t>
             </a:r>
           </a:p>
         </p:txBody>
@@ -11746,14 +12376,14 @@
                 </a:solidFill>
                 <a:latin typeface="Calibri"/>
               </a:rPr>
-              <a:t>Why vibrotactile, and why wearable: the white space next to light and sound</a:t>
+              <a:t>And clearance can be driven non-invasively — 40 Hz in mice, focused ultrasound at Stanford</a:t>
             </a:r>
           </a:p>
         </p:txBody>
       </p:sp>
       <p:pic>
         <p:nvPicPr>
-          <p:cNvPr id="5" name="Picture 4" descr="whitespace.png"/>
+          <p:cNvPr id="5" name="Picture 4" descr="driving_clearance.png"/>
           <p:cNvPicPr>
             <a:picLocks noChangeAspect="1"/>
           </p:cNvPicPr>
@@ -11767,8 +12397,8 @@
         </p:blipFill>
         <p:spPr>
           <a:xfrm>
-            <a:off x="1102690" y="1965960"/>
-            <a:ext cx="9986313" cy="3931920"/>
+            <a:off x="731519" y="1965960"/>
+            <a:ext cx="10728655" cy="3769952"/>
           </a:xfrm>
           <a:prstGeom prst="rect">
             <a:avLst/>
@@ -11848,7 +12478,7 @@
                 </a:solidFill>
                 <a:latin typeface="Calibri"/>
               </a:rPr>
-              <a:t>40 Hz light/sound (GENUS) is the developed approach but hard to wear daily. Vibrotactile stimulation is the open frontier — wearable, sleep-compatible, and pairs naturally with sensing.</a:t>
+              <a:t>40 Hz sensory stimulation drove ~4× CSF influx and ~30% less cortical amyloid, abolished when AQP4 is blocked (Murdock 2024, Nature). Focused ultrasound enhances CSF influx and clearance (Aryal 2022; Azadian 2025). The open question: can a wearable modality do the same?</a:t>
             </a:r>
           </a:p>
         </p:txBody>
@@ -11883,7 +12513,7 @@
                 </a:solidFill>
                 <a:latin typeface="Calibri"/>
               </a:rPr>
-              <a:t>5 / 31</a:t>
+              <a:t>5 / 33</a:t>
             </a:r>
           </a:p>
         </p:txBody>
@@ -11915,7 +12545,7 @@
         <p:spPr>
           <a:xfrm>
             <a:off x="0" y="0"/>
-            <a:ext cx="12191695" cy="6858000"/>
+            <a:ext cx="12191695" cy="164592"/>
           </a:xfrm>
           <a:prstGeom prst="rect">
             <a:avLst/>
@@ -11949,9 +12579,79 @@
           </a:p>
         </p:txBody>
       </p:sp>
+      <p:sp>
+        <p:nvSpPr>
+          <p:cNvPr id="3" name="TextBox 2"/>
+          <p:cNvSpPr txBox="1"/>
+          <p:nvPr/>
+        </p:nvSpPr>
+        <p:spPr>
+          <a:xfrm>
+            <a:off x="548640" y="411480"/>
+            <a:ext cx="11094415" cy="365760"/>
+          </a:xfrm>
+          <a:prstGeom prst="rect">
+            <a:avLst/>
+          </a:prstGeom>
+          <a:noFill/>
+        </p:spPr>
+        <p:txBody>
+          <a:bodyPr wrap="square" anchor="t">
+            <a:spAutoFit/>
+          </a:bodyPr>
+          <a:lstStyle/>
+          <a:p>
+            <a:pPr algn="l"/>
+            <a:r>
+              <a:rPr sz="1400" b="1">
+                <a:solidFill>
+                  <a:srgbClr val="8C1515"/>
+                </a:solidFill>
+                <a:latin typeface="Calibri"/>
+              </a:rPr>
+              <a:t>THE THESIS</a:t>
+            </a:r>
+          </a:p>
+        </p:txBody>
+      </p:sp>
+      <p:sp>
+        <p:nvSpPr>
+          <p:cNvPr id="4" name="TextBox 3"/>
+          <p:cNvSpPr txBox="1"/>
+          <p:nvPr/>
+        </p:nvSpPr>
+        <p:spPr>
+          <a:xfrm>
+            <a:off x="548640" y="822960"/>
+            <a:ext cx="11094415" cy="1005840"/>
+          </a:xfrm>
+          <a:prstGeom prst="rect">
+            <a:avLst/>
+          </a:prstGeom>
+          <a:noFill/>
+        </p:spPr>
+        <p:txBody>
+          <a:bodyPr wrap="square" anchor="t">
+            <a:spAutoFit/>
+          </a:bodyPr>
+          <a:lstStyle/>
+          <a:p>
+            <a:pPr algn="l"/>
+            <a:r>
+              <a:rPr sz="2400" b="1">
+                <a:solidFill>
+                  <a:srgbClr val="2E2D29"/>
+                </a:solidFill>
+                <a:latin typeface="Calibri"/>
+              </a:rPr>
+              <a:t>The proposal: use vibrotactile stimulation to engage brain rhythms and drive clearance</a:t>
+            </a:r>
+          </a:p>
+        </p:txBody>
+      </p:sp>
       <p:pic>
         <p:nvPicPr>
-          <p:cNvPr id="3" name="Picture 2" descr="som_logo_white.png"/>
+          <p:cNvPr id="5" name="Picture 4" descr="vision_chain.png"/>
           <p:cNvPicPr>
             <a:picLocks noChangeAspect="1"/>
           </p:cNvPicPr>
@@ -11965,8 +12665,8 @@
         </p:blipFill>
         <p:spPr>
           <a:xfrm>
-            <a:off x="502920" y="457200"/>
-            <a:ext cx="2651760" cy="338836"/>
+            <a:off x="731519" y="1965960"/>
+            <a:ext cx="10728655" cy="3177187"/>
           </a:xfrm>
           <a:prstGeom prst="rect">
             <a:avLst/>
@@ -11975,14 +12675,57 @@
       </p:pic>
       <p:sp>
         <p:nvSpPr>
-          <p:cNvPr id="4" name="TextBox 3"/>
+          <p:cNvPr id="6" name="Rectangle 5"/>
+          <p:cNvSpPr/>
+          <p:nvPr/>
+        </p:nvSpPr>
+        <p:spPr>
+          <a:xfrm>
+            <a:off x="0" y="6035040"/>
+            <a:ext cx="12191695" cy="822960"/>
+          </a:xfrm>
+          <a:prstGeom prst="rect">
+            <a:avLst/>
+          </a:prstGeom>
+          <a:solidFill>
+            <a:srgbClr val="F4F4F4"/>
+          </a:solidFill>
+          <a:ln>
+            <a:noFill/>
+          </a:ln>
+        </p:spPr>
+        <p:style>
+          <a:lnRef idx="1">
+            <a:schemeClr val="accent1"/>
+          </a:lnRef>
+          <a:fillRef idx="3">
+            <a:schemeClr val="accent1"/>
+          </a:fillRef>
+          <a:effectRef idx="2">
+            <a:schemeClr val="accent1"/>
+          </a:effectRef>
+          <a:fontRef idx="minor">
+            <a:schemeClr val="lt1"/>
+          </a:fontRef>
+        </p:style>
+        <p:txBody>
+          <a:bodyPr rtlCol="0" anchor="ctr"/>
+          <a:lstStyle/>
+          <a:p>
+            <a:pPr algn="ctr"/>
+          </a:p>
+        </p:txBody>
+      </p:sp>
+      <p:sp>
+        <p:nvSpPr>
+          <p:cNvPr id="7" name="TextBox 6"/>
           <p:cNvSpPr txBox="1"/>
           <p:nvPr/>
         </p:nvSpPr>
         <p:spPr>
           <a:xfrm>
-            <a:off x="914400" y="2468880"/>
-            <a:ext cx="10362895" cy="1371600"/>
+            <a:off x="548640" y="6062472"/>
+            <a:ext cx="11094415" cy="777240"/>
           </a:xfrm>
           <a:prstGeom prst="rect">
             <a:avLst/>
@@ -11997,20 +12740,20 @@
           <a:p>
             <a:pPr algn="l"/>
             <a:r>
-              <a:rPr sz="3400" b="1">
+              <a:rPr sz="1500" b="1">
                 <a:solidFill>
-                  <a:srgbClr val="FFFFFF"/>
+                  <a:srgbClr val="8C1515"/>
                 </a:solidFill>
                 <a:latin typeface="Calibri"/>
               </a:rPr>
-              <a:t>Part 2 · What the literature says — and what to test</a:t>
-            </a:r>
-          </a:p>
-        </p:txBody>
-      </p:sp>
-      <p:sp>
-        <p:nvSpPr>
-          <p:cNvPr id="5" name="TextBox 4"/>
+              <a:t>Wearable vibrotactile stimulation → entrain brain rhythms → engage glymphatic clearance of amyloid-β / tau. A mechanism hypothesis — explicitly not yet a treatment claim.</a:t>
+            </a:r>
+          </a:p>
+        </p:txBody>
+      </p:sp>
+      <p:sp>
+        <p:nvSpPr>
+          <p:cNvPr id="8" name="TextBox 7"/>
           <p:cNvSpPr txBox="1"/>
           <p:nvPr/>
         </p:nvSpPr>
@@ -12034,11 +12777,11 @@
             <a:r>
               <a:rPr sz="1100" b="0">
                 <a:solidFill>
-                  <a:srgbClr val="FFFFFF"/>
+                  <a:srgbClr val="53565A"/>
                 </a:solidFill>
                 <a:latin typeface="Calibri"/>
               </a:rPr>
-              <a:t>6 / 31</a:t>
+              <a:t>6 / 33</a:t>
             </a:r>
           </a:p>
         </p:txBody>
@@ -12134,7 +12877,7 @@
                 </a:solidFill>
                 <a:latin typeface="Calibri"/>
               </a:rPr>
-              <a:t>EVIDENCE · 40 HZ GAMMA</a:t>
+              <a:t>WHY VIBROTACTILE</a:t>
             </a:r>
           </a:p>
         </p:txBody>
@@ -12169,14 +12912,38 @@
                 </a:solidFill>
                 <a:latin typeface="Calibri"/>
               </a:rPr>
-              <a:t>40 Hz sensory stimulation lowers amyloid and drives clearance — animals, and early humans</a:t>
-            </a:r>
-          </a:p>
-        </p:txBody>
-      </p:sp>
-      <p:sp>
-        <p:nvSpPr>
-          <p:cNvPr id="5" name="Rectangle 4"/>
+              <a:t>Why vibrotactile, and why wearable: the white space next to light and sound</a:t>
+            </a:r>
+          </a:p>
+        </p:txBody>
+      </p:sp>
+      <p:pic>
+        <p:nvPicPr>
+          <p:cNvPr id="5" name="Picture 4" descr="whitespace.png"/>
+          <p:cNvPicPr>
+            <a:picLocks noChangeAspect="1"/>
+          </p:cNvPicPr>
+          <p:nvPr/>
+        </p:nvPicPr>
+        <p:blipFill>
+          <a:blip r:embed="rId2"/>
+          <a:stretch>
+            <a:fillRect/>
+          </a:stretch>
+        </p:blipFill>
+        <p:spPr>
+          <a:xfrm>
+            <a:off x="1102690" y="1965960"/>
+            <a:ext cx="9986313" cy="3931920"/>
+          </a:xfrm>
+          <a:prstGeom prst="rect">
+            <a:avLst/>
+          </a:prstGeom>
+        </p:spPr>
+      </p:pic>
+      <p:sp>
+        <p:nvSpPr>
+          <p:cNvPr id="6" name="Rectangle 5"/>
           <p:cNvSpPr/>
           <p:nvPr/>
         </p:nvSpPr>
@@ -12219,7 +12986,7 @@
       </p:sp>
       <p:sp>
         <p:nvSpPr>
-          <p:cNvPr id="6" name="TextBox 5"/>
+          <p:cNvPr id="7" name="TextBox 6"/>
           <p:cNvSpPr txBox="1"/>
           <p:nvPr/>
         </p:nvSpPr>
@@ -12247,14 +13014,14 @@
                 </a:solidFill>
                 <a:latin typeface="Calibri"/>
               </a:rPr>
-              <a:t>GENUS / Tsai 2016: 40 Hz light/sound lowers amyloid. Murdock 2024 (Nature): 40 Hz gamma drives glymphatic Aβ clearance. Human gamma-sensory is safe with target engagement (Chan 2022).</a:t>
-            </a:r>
-          </a:p>
-        </p:txBody>
-      </p:sp>
-      <p:sp>
-        <p:nvSpPr>
-          <p:cNvPr id="7" name="TextBox 6"/>
+              <a:t>40 Hz light/sound (GENUS) is the developed approach but hard to wear daily. Vibrotactile stimulation is the open frontier — wearable, sleep-compatible, and pairs naturally with sensing.</a:t>
+            </a:r>
+          </a:p>
+        </p:txBody>
+      </p:sp>
+      <p:sp>
+        <p:nvSpPr>
+          <p:cNvPr id="8" name="TextBox 7"/>
           <p:cNvSpPr txBox="1"/>
           <p:nvPr/>
         </p:nvSpPr>
@@ -12282,7 +13049,7 @@
                 </a:solidFill>
                 <a:latin typeface="Calibri"/>
               </a:rPr>
-              <a:t>7 / 31</a:t>
+              <a:t>7 / 33</a:t>
             </a:r>
           </a:p>
         </p:txBody>
@@ -12314,7 +13081,7 @@
         <p:spPr>
           <a:xfrm>
             <a:off x="0" y="0"/>
-            <a:ext cx="12191695" cy="164592"/>
+            <a:ext cx="12191695" cy="6858000"/>
           </a:xfrm>
           <a:prstGeom prst="rect">
             <a:avLst/>
@@ -12348,16 +13115,75 @@
           </a:p>
         </p:txBody>
       </p:sp>
-      <p:sp>
-        <p:nvSpPr>
-          <p:cNvPr id="3" name="TextBox 2"/>
+      <p:pic>
+        <p:nvPicPr>
+          <p:cNvPr id="3" name="Picture 2" descr="som_logo_white.png"/>
+          <p:cNvPicPr>
+            <a:picLocks noChangeAspect="1"/>
+          </p:cNvPicPr>
+          <p:nvPr/>
+        </p:nvPicPr>
+        <p:blipFill>
+          <a:blip r:embed="rId2"/>
+          <a:stretch>
+            <a:fillRect/>
+          </a:stretch>
+        </p:blipFill>
+        <p:spPr>
+          <a:xfrm>
+            <a:off x="502920" y="457200"/>
+            <a:ext cx="2651760" cy="338836"/>
+          </a:xfrm>
+          <a:prstGeom prst="rect">
+            <a:avLst/>
+          </a:prstGeom>
+        </p:spPr>
+      </p:pic>
+      <p:sp>
+        <p:nvSpPr>
+          <p:cNvPr id="4" name="TextBox 3"/>
           <p:cNvSpPr txBox="1"/>
           <p:nvPr/>
         </p:nvSpPr>
         <p:spPr>
           <a:xfrm>
-            <a:off x="548640" y="411480"/>
-            <a:ext cx="11094415" cy="365760"/>
+            <a:off x="914400" y="2468880"/>
+            <a:ext cx="10362895" cy="1371600"/>
+          </a:xfrm>
+          <a:prstGeom prst="rect">
+            <a:avLst/>
+          </a:prstGeom>
+          <a:noFill/>
+        </p:spPr>
+        <p:txBody>
+          <a:bodyPr wrap="square" anchor="ctr">
+            <a:spAutoFit/>
+          </a:bodyPr>
+          <a:lstStyle/>
+          <a:p>
+            <a:pPr algn="l"/>
+            <a:r>
+              <a:rPr sz="3400" b="1">
+                <a:solidFill>
+                  <a:srgbClr val="FFFFFF"/>
+                </a:solidFill>
+                <a:latin typeface="Calibri"/>
+              </a:rPr>
+              <a:t>Part 2 · What the literature says — and what to test</a:t>
+            </a:r>
+          </a:p>
+        </p:txBody>
+      </p:sp>
+      <p:sp>
+        <p:nvSpPr>
+          <p:cNvPr id="5" name="TextBox 4"/>
+          <p:cNvSpPr txBox="1"/>
+          <p:nvPr/>
+        </p:nvSpPr>
+        <p:spPr>
+          <a:xfrm>
+            <a:off x="10545775" y="246888"/>
+            <a:ext cx="1280160" cy="365760"/>
           </a:xfrm>
           <a:prstGeom prst="rect">
             <a:avLst/>
@@ -12370,163 +13196,15 @@
           </a:bodyPr>
           <a:lstStyle/>
           <a:p>
-            <a:pPr algn="l"/>
-            <a:r>
-              <a:rPr sz="1400" b="1">
+            <a:pPr algn="r"/>
+            <a:r>
+              <a:rPr sz="1100" b="0">
                 <a:solidFill>
-                  <a:srgbClr val="8C1515"/>
+                  <a:srgbClr val="FFFFFF"/>
                 </a:solidFill>
                 <a:latin typeface="Calibri"/>
               </a:rPr>
-              <a:t>THE KEY CAVEAT</a:t>
-            </a:r>
-          </a:p>
-        </p:txBody>
-      </p:sp>
-      <p:sp>
-        <p:nvSpPr>
-          <p:cNvPr id="4" name="TextBox 3"/>
-          <p:cNvSpPr txBox="1"/>
-          <p:nvPr/>
-        </p:nvSpPr>
-        <p:spPr>
-          <a:xfrm>
-            <a:off x="548640" y="822960"/>
-            <a:ext cx="11094415" cy="1005840"/>
-          </a:xfrm>
-          <a:prstGeom prst="rect">
-            <a:avLst/>
-          </a:prstGeom>
-          <a:noFill/>
-        </p:spPr>
-        <p:txBody>
-          <a:bodyPr wrap="square" anchor="t">
-            <a:spAutoFit/>
-          </a:bodyPr>
-          <a:lstStyle/>
-          <a:p>
-            <a:pPr algn="l"/>
-            <a:r>
-              <a:rPr sz="2400" b="1">
-                <a:solidFill>
-                  <a:srgbClr val="2E2D29"/>
-                </a:solidFill>
-                <a:latin typeface="Calibri"/>
-              </a:rPr>
-              <a:t>But a steady-state response is not the same as entraining the brain's own rhythm</a:t>
-            </a:r>
-          </a:p>
-        </p:txBody>
-      </p:sp>
-      <p:sp>
-        <p:nvSpPr>
-          <p:cNvPr id="5" name="Rectangle 4"/>
-          <p:cNvSpPr/>
-          <p:nvPr/>
-        </p:nvSpPr>
-        <p:spPr>
-          <a:xfrm>
-            <a:off x="0" y="6035040"/>
-            <a:ext cx="12191695" cy="822960"/>
-          </a:xfrm>
-          <a:prstGeom prst="rect">
-            <a:avLst/>
-          </a:prstGeom>
-          <a:solidFill>
-            <a:srgbClr val="F4F4F4"/>
-          </a:solidFill>
-          <a:ln>
-            <a:noFill/>
-          </a:ln>
-        </p:spPr>
-        <p:style>
-          <a:lnRef idx="1">
-            <a:schemeClr val="accent1"/>
-          </a:lnRef>
-          <a:fillRef idx="3">
-            <a:schemeClr val="accent1"/>
-          </a:fillRef>
-          <a:effectRef idx="2">
-            <a:schemeClr val="accent1"/>
-          </a:effectRef>
-          <a:fontRef idx="minor">
-            <a:schemeClr val="lt1"/>
-          </a:fontRef>
-        </p:style>
-        <p:txBody>
-          <a:bodyPr rtlCol="0" anchor="ctr"/>
-          <a:lstStyle/>
-          <a:p>
-            <a:pPr algn="ctr"/>
-          </a:p>
-        </p:txBody>
-      </p:sp>
-      <p:sp>
-        <p:nvSpPr>
-          <p:cNvPr id="6" name="TextBox 5"/>
-          <p:cNvSpPr txBox="1"/>
-          <p:nvPr/>
-        </p:nvSpPr>
-        <p:spPr>
-          <a:xfrm>
-            <a:off x="548640" y="6062472"/>
-            <a:ext cx="11094415" cy="777240"/>
-          </a:xfrm>
-          <a:prstGeom prst="rect">
-            <a:avLst/>
-          </a:prstGeom>
-          <a:noFill/>
-        </p:spPr>
-        <p:txBody>
-          <a:bodyPr wrap="square" anchor="ctr">
-            <a:spAutoFit/>
-          </a:bodyPr>
-          <a:lstStyle/>
-          <a:p>
-            <a:pPr algn="l"/>
-            <a:r>
-              <a:rPr sz="1500" b="1">
-                <a:solidFill>
-                  <a:srgbClr val="8C1515"/>
-                </a:solidFill>
-                <a:latin typeface="Calibri"/>
-              </a:rPr>
-              <a:t>A driven 40 Hz response ≠ engaging native gamma (Buzsáki/Soula; some studies find 40 Hz light fails to entrain native gamma in AD-model mice). We separate target engagement from disease modification.</a:t>
-            </a:r>
-          </a:p>
-        </p:txBody>
-      </p:sp>
-      <p:sp>
-        <p:nvSpPr>
-          <p:cNvPr id="7" name="TextBox 6"/>
-          <p:cNvSpPr txBox="1"/>
-          <p:nvPr/>
-        </p:nvSpPr>
-        <p:spPr>
-          <a:xfrm>
-            <a:off x="10545775" y="246888"/>
-            <a:ext cx="1280160" cy="365760"/>
-          </a:xfrm>
-          <a:prstGeom prst="rect">
-            <a:avLst/>
-          </a:prstGeom>
-          <a:noFill/>
-        </p:spPr>
-        <p:txBody>
-          <a:bodyPr wrap="square" anchor="t">
-            <a:spAutoFit/>
-          </a:bodyPr>
-          <a:lstStyle/>
-          <a:p>
-            <a:pPr algn="r"/>
-            <a:r>
-              <a:rPr sz="1100" b="0">
-                <a:solidFill>
-                  <a:srgbClr val="53565A"/>
-                </a:solidFill>
-                <a:latin typeface="Calibri"/>
-              </a:rPr>
-              <a:t>8 / 31</a:t>
+              <a:t>8 / 33</a:t>
             </a:r>
           </a:p>
         </p:txBody>
@@ -12622,7 +13300,7 @@
                 </a:solidFill>
                 <a:latin typeface="Calibri"/>
               </a:rPr>
-              <a:t>EVIDENCE · CLEARANCE</a:t>
+              <a:t>EVIDENCE · 40 HZ GAMMA</a:t>
             </a:r>
           </a:p>
         </p:txBody>
@@ -12657,7 +13335,7 @@
                 </a:solidFill>
                 <a:latin typeface="Calibri"/>
               </a:rPr>
-              <a:t>Clearance is actively driven by neural, vascular &amp; sleep dynamics — so 'brain-state' stimulation is plausible</a:t>
+              <a:t>40 Hz sensory stimulation lowers amyloid and drives clearance — animals, and early humans</a:t>
             </a:r>
           </a:p>
         </p:txBody>
@@ -12735,7 +13413,7 @@
                 </a:solidFill>
                 <a:latin typeface="Calibri"/>
               </a:rPr>
-              <a:t>CSF flow tracks NREM slow waves (Fultz 2019) and EEG delta (Hablitz 2019); neuronal dynamics actively direct CSF perfusion (Jiang-Xie–Kipnis 2024, Nature); human sleep clearance moves plasma Aβ/tau (Dagum 2026).</a:t>
+              <a:t>GENUS / Tsai 2016: 40 Hz light/sound lowers amyloid. Murdock 2024 (Nature): 40 Hz gamma drives glymphatic Aβ clearance. Human gamma-sensory is safe with target engagement (Chan 2022).</a:t>
             </a:r>
           </a:p>
         </p:txBody>
@@ -12770,7 +13448,7 @@
                 </a:solidFill>
                 <a:latin typeface="Calibri"/>
               </a:rPr>
-              <a:t>9 / 31</a:t>
+              <a:t>9 / 33</a:t>
             </a:r>
           </a:p>
         </p:txBody>

</xml_diff>

<commit_message>
Presentation: add Lancet Commission 2024 + MIND-diet single-domain nuance
- "the problem" slide now cites the Lancet Commission (Livingston 2024,
  ~45% modifiable risk) and notes that single-domain interventions (MIND
  diet alone, Barnes NEJM 2023) underperform — the case for *multidomain*.
- Key references slide: added Livingston 2024 and Barnes 2023 to the
  lifestyle group.
- Deck rebuilt (pptx + pdf), 33 slides.

(Lit-review repo separately updated: inventory rows for Mawuenyega 2010 and
Aryal 2022 added; Aryal PDF downloaded; Mawuenyega queued for manual access.)

Co-Authored-By: Claude Opus 4.8 <noreply@anthropic.com>
</commit_message>
<xml_diff>
--- a/presentation/haptic_brain_talk.pptx
+++ b/presentation/haptic_brain_talk.pptx
@@ -1304,7 +1304,7 @@
           <a:lstStyle/>
           <a:p>
             <a:r>
-              <a:t>Framing the gap. Pharmacology for Alzheimer's has struggled — anti-amyloid drugs give small effects and carry safety costs. The most credible non-drug clinical evidence is multidomain lifestyle intervention: FINGER (Ngandu, Lancet 2015) — a 2-year diet + exercise + cognitive-training + vascular-care RCT that slowed cognitive decline — and its U.S. replication, U.S. POINTER (Baker, JAMA 2025). The takeaway: the best non-drug evidence today is a lifestyle package, not a device. Non-invasive neuromodulation — light, sound, vibrotactile — is an emerging but mostly unproven frontier. The question is what a wearable, vibrotactile approach could add, held to the bar those lifestyle trials set.</a:t>
+              <a:t>Framing the gap. Pharmacology for Alzheimer's has struggled — anti-amyloid drugs give small effects and carry safety costs. The most credible non-drug clinical evidence is multidomain lifestyle intervention: FINGER (Ngandu, Lancet 2015) — a 2-year diet + exercise + cognitive-training + vascular-care RCT that slowed cognitive decline — and its U.S. replication, U.S. POINTER (Baker, JAMA 2025). The Lancet Commission (Livingston 2024) estimates ~45% of dementia is tied to modifiable risk factors. The operative word is *multidomain*: when a single domain is isolated — e.g. the MIND diet alone (Barnes, NEJM 2023) — the benefit largely disappears. The takeaway: the best non-drug evidence today is a multidomain lifestyle package, not a device or any single change. Non-invasive neuromodulation — light, sound, vibrotactile — is an emerging but mostly unproven frontier; the question is what a wearable, vibrotactile approach could add, held to the bar those lifestyle trials set.</a:t>
             </a:r>
           </a:p>
         </p:txBody>
@@ -1864,7 +1864,7 @@
           <a:lstStyle/>
           <a:p>
             <a:r>
-              <a:t>Grouped anchors. Lifestyle bar — FINGER (Ngandu, Lancet 2015) and U.S. POINTER (Baker, JAMA 2025). Clearance hypothesis &amp; drivers — glymphatic discovery (Iliff, Sci Transl Med 2012), sleep clearance (Xie, Science 2013), slowed Aβ clearance in AD (Mawuenyega, Science 2010), 40 Hz → glymphatic clearance, AQP4-dependent (Murdock, Nature 2024), and Stanford focused ultrasound (Aryal, J Control Release 2022; Azadian, Nat Biotech 2025). Stimulation — origin of sensory-gamma (Tsai 2016), the vibrotactile anchor (Suk 2023), and the mechanism legitimizing brain-state stimulation of clearance (Jiang-Xie–Kipnis 2024). Guardrail — Buzsáki/Soula: a steady-state response is not entrainment. Full lit-review repository available on request.</a:t>
+              <a:t>Grouped anchors. Lifestyle bar — FINGER (Ngandu, Lancet 2015), U.S. POINTER (Baker, JAMA 2025), the Lancet Commission synthesis (Livingston 2024, ~45% modifiable risk), and the single-domain counterpoint (MIND diet alone null; Barnes, NEJM 2023). Clearance hypothesis &amp; drivers — glymphatic discovery (Iliff, Sci Transl Med 2012), sleep clearance (Xie, Science 2013), slowed Aβ clearance in AD (Mawuenyega, Science 2010), 40 Hz → glymphatic clearance, AQP4-dependent (Murdock, Nature 2024), and Stanford focused ultrasound (Aryal, J Control Release 2022; Azadian, Nat Biotech 2025). Stimulation — origin of sensory-gamma (Tsai 2016), the vibrotactile anchor (Suk 2023), and the mechanism legitimizing brain-state stimulation of clearance (Jiang-Xie–Kipnis 2024). Guardrail — Buzsáki/Soula: a steady-state response is not entrainment. Full lit-review repository available on request.</a:t>
             </a:r>
           </a:p>
         </p:txBody>
@@ -11066,7 +11066,7 @@
                 </a:solidFill>
                 <a:latin typeface="Calibri"/>
               </a:rPr>
-              <a:t>The strongest non-drug clinical evidence today is multidomain lifestyle (FINGER, Ngandu 2015; US POINTER, Baker 2025). Non-invasive stimulation is largely unproven — which is the opportunity.</a:t>
+              <a:t>The strongest non-drug clinical evidence today is multidomain lifestyle (FINGER, Ngandu 2015; US POINTER, Baker 2025; synthesis: Lancet Commission 2024). Single domains alone underperform. Non-invasive stimulation is largely unproven — which is the opportunity.</a:t>
             </a:r>
           </a:p>
         </p:txBody>
@@ -11709,7 +11709,7 @@
                 </a:solidFill>
                 <a:latin typeface="Calibri"/>
               </a:rPr>
-              <a:t>Lifestyle: Ngandu 2015 (FINGER) · Baker 2025 (US POINTER).  Clearance: Iliff 2012 · Xie 2013 · Mawuenyega 2010 · Murdock 2024 (40 Hz → glymphatic) · Aryal 2022 / Azadian 2025 (focused ultrasound).  Stimulation: Tsai 2016 (GENUS) · Suk 2023 (40 Hz tactile) · Jiang-Xie–Kipnis 2024 (neural dynamics → CSF).  Guardrail: Buzsáki / Soula (steady-state ≠ entrainment).</a:t>
+              <a:t>Lifestyle: Ngandu 2015 (FINGER) · Baker 2025 (US POINTER) · Livingston 2024 (Lancet Commission) · Barnes 2023 (MIND diet — single-domain null).  Clearance: Iliff 2012 · Xie 2013 · Mawuenyega 2010 · Murdock 2024 (40 Hz → glymphatic) · Aryal 2022 / Azadian 2025 (focused ultrasound).  Stimulation: Tsai 2016 (GENUS) · Suk 2023 (40 Hz tactile) · Jiang-Xie–Kipnis 2024 (neural dynamics → CSF).  Guardrail: Buzsáki / Soula (steady-state ≠ entrainment).</a:t>
             </a:r>
           </a:p>
         </p:txBody>

</xml_diff>